<commit_message>
Upload .pdf presentation & add .gitignore file
</commit_message>
<xml_diff>
--- a/presentations/Intro_R_Session1.pptx
+++ b/presentations/Intro_R_Session1.pptx
@@ -5,7 +5,7 @@
     <p:sldMasterId id="2147483648" r:id="rId1"/>
   </p:sldMasterIdLst>
   <p:notesMasterIdLst>
-    <p:notesMasterId r:id="rId7"/>
+    <p:notesMasterId r:id="rId10"/>
   </p:notesMasterIdLst>
   <p:sldIdLst>
     <p:sldId id="289" r:id="rId2"/>
@@ -13,6 +13,9 @@
     <p:sldId id="879" r:id="rId4"/>
     <p:sldId id="880" r:id="rId5"/>
     <p:sldId id="881" r:id="rId6"/>
+    <p:sldId id="882" r:id="rId7"/>
+    <p:sldId id="883" r:id="rId8"/>
+    <p:sldId id="884" r:id="rId9"/>
   </p:sldIdLst>
   <p:sldSz cx="12192000" cy="6858000"/>
   <p:notesSz cx="6858000" cy="9144000"/>
@@ -122,7 +125,7 @@
 <file path=ppt/revisionInfo.xml><?xml version="1.0" encoding="utf-8"?>
 <p1510:revInfo xmlns:a="http://schemas.openxmlformats.org/drawingml/2006/main" xmlns:r="http://schemas.openxmlformats.org/officeDocument/2006/relationships" xmlns:p1510="http://schemas.microsoft.com/office/powerpoint/2015/10/main">
   <p1510:revLst>
-    <p1510:client id="{80CB159F-E254-4E56-A497-3660E959EAF4}" v="7" dt="2026-01-12T09:34:11.722"/>
+    <p1510:client id="{80CB159F-E254-4E56-A497-3660E959EAF4}" v="14" dt="2026-01-12T09:54:29.274"/>
   </p1510:revLst>
 </p1510:revInfo>
 </file>
@@ -131,8 +134,8 @@
 <pc:chgInfo xmlns:a="http://schemas.openxmlformats.org/drawingml/2006/main" xmlns:r="http://schemas.openxmlformats.org/officeDocument/2006/relationships" xmlns:ac="http://schemas.microsoft.com/office/drawing/2013/main/command" xmlns:pc="http://schemas.microsoft.com/office/powerpoint/2013/main/command">
   <pc:docChgLst>
     <pc:chgData name="André Boler Cláudio da Silva Barros" userId="6a6e06a7-71d6-4753-8f49-a25f8eb0dc15" providerId="ADAL" clId="{6BE99AA9-1EEE-46D3-8261-83B0B634593B}"/>
-    <pc:docChg chg="custSel addSld delSld modSld">
-      <pc:chgData name="André Boler Cláudio da Silva Barros" userId="6a6e06a7-71d6-4753-8f49-a25f8eb0dc15" providerId="ADAL" clId="{6BE99AA9-1EEE-46D3-8261-83B0B634593B}" dt="2026-01-12T09:34:37.059" v="1047" actId="20577"/>
+    <pc:docChg chg="undo custSel addSld delSld modSld">
+      <pc:chgData name="André Boler Cláudio da Silva Barros" userId="6a6e06a7-71d6-4753-8f49-a25f8eb0dc15" providerId="ADAL" clId="{6BE99AA9-1EEE-46D3-8261-83B0B634593B}" dt="2026-01-12T09:54:40.856" v="1293" actId="1036"/>
       <pc:docMkLst>
         <pc:docMk/>
       </pc:docMkLst>
@@ -251,12 +254,20 @@
           </ac:spMkLst>
         </pc:spChg>
       </pc:sldChg>
-      <pc:sldChg chg="modSp add mod">
-        <pc:chgData name="André Boler Cláudio da Silva Barros" userId="6a6e06a7-71d6-4753-8f49-a25f8eb0dc15" providerId="ADAL" clId="{6BE99AA9-1EEE-46D3-8261-83B0B634593B}" dt="2026-01-12T09:34:37.059" v="1047" actId="20577"/>
+      <pc:sldChg chg="addSp delSp modSp add mod">
+        <pc:chgData name="André Boler Cláudio da Silva Barros" userId="6a6e06a7-71d6-4753-8f49-a25f8eb0dc15" providerId="ADAL" clId="{6BE99AA9-1EEE-46D3-8261-83B0B634593B}" dt="2026-01-12T09:47:52.759" v="1165" actId="14100"/>
         <pc:sldMkLst>
           <pc:docMk/>
           <pc:sldMk cId="2310122796" sldId="881"/>
         </pc:sldMkLst>
+        <pc:spChg chg="add mod">
+          <ac:chgData name="André Boler Cláudio da Silva Barros" userId="6a6e06a7-71d6-4753-8f49-a25f8eb0dc15" providerId="ADAL" clId="{6BE99AA9-1EEE-46D3-8261-83B0B634593B}" dt="2026-01-12T09:47:05.511" v="1159" actId="1036"/>
+          <ac:spMkLst>
+            <pc:docMk/>
+            <pc:sldMk cId="2310122796" sldId="881"/>
+            <ac:spMk id="4" creationId="{72EE2559-4C3B-C03B-E93B-0B09C7C1877A}"/>
+          </ac:spMkLst>
+        </pc:spChg>
         <pc:spChg chg="mod">
           <ac:chgData name="André Boler Cláudio da Silva Barros" userId="6a6e06a7-71d6-4753-8f49-a25f8eb0dc15" providerId="ADAL" clId="{6BE99AA9-1EEE-46D3-8261-83B0B634593B}" dt="2026-01-12T09:33:45.003" v="1040" actId="20577"/>
           <ac:spMkLst>
@@ -266,13 +277,29 @@
           </ac:spMkLst>
         </pc:spChg>
         <pc:spChg chg="mod">
-          <ac:chgData name="André Boler Cláudio da Silva Barros" userId="6a6e06a7-71d6-4753-8f49-a25f8eb0dc15" providerId="ADAL" clId="{6BE99AA9-1EEE-46D3-8261-83B0B634593B}" dt="2026-01-12T09:34:37.059" v="1047" actId="20577"/>
+          <ac:chgData name="André Boler Cláudio da Silva Barros" userId="6a6e06a7-71d6-4753-8f49-a25f8eb0dc15" providerId="ADAL" clId="{6BE99AA9-1EEE-46D3-8261-83B0B634593B}" dt="2026-01-12T09:45:16.238" v="1050" actId="404"/>
           <ac:spMkLst>
             <pc:docMk/>
             <pc:sldMk cId="2310122796" sldId="881"/>
             <ac:spMk id="13" creationId="{B6AC6DE2-2E99-4842-94A4-942D9ADDA612}"/>
           </ac:spMkLst>
         </pc:spChg>
+        <pc:picChg chg="add del mod">
+          <ac:chgData name="André Boler Cláudio da Silva Barros" userId="6a6e06a7-71d6-4753-8f49-a25f8eb0dc15" providerId="ADAL" clId="{6BE99AA9-1EEE-46D3-8261-83B0B634593B}" dt="2026-01-12T09:46:59.859" v="1142" actId="478"/>
+          <ac:picMkLst>
+            <pc:docMk/>
+            <pc:sldMk cId="2310122796" sldId="881"/>
+            <ac:picMk id="3" creationId="{B5AB33DA-8F40-B31C-AB33-04467F9324A7}"/>
+          </ac:picMkLst>
+        </pc:picChg>
+        <pc:picChg chg="add mod modCrop">
+          <ac:chgData name="André Boler Cláudio da Silva Barros" userId="6a6e06a7-71d6-4753-8f49-a25f8eb0dc15" providerId="ADAL" clId="{6BE99AA9-1EEE-46D3-8261-83B0B634593B}" dt="2026-01-12T09:47:52.759" v="1165" actId="14100"/>
+          <ac:picMkLst>
+            <pc:docMk/>
+            <pc:sldMk cId="2310122796" sldId="881"/>
+            <ac:picMk id="6" creationId="{CC3CF65D-AC81-F858-12BC-C3E3CEC52B85}"/>
+          </ac:picMkLst>
+        </pc:picChg>
       </pc:sldChg>
       <pc:sldChg chg="del">
         <pc:chgData name="André Boler Cláudio da Silva Barros" userId="6a6e06a7-71d6-4753-8f49-a25f8eb0dc15" providerId="ADAL" clId="{6BE99AA9-1EEE-46D3-8261-83B0B634593B}" dt="2026-01-12T09:21:56.604" v="548" actId="47"/>
@@ -281,12 +308,169 @@
           <pc:sldMk cId="1311924374" sldId="882"/>
         </pc:sldMkLst>
       </pc:sldChg>
+      <pc:sldChg chg="addSp delSp modSp add mod">
+        <pc:chgData name="André Boler Cláudio da Silva Barros" userId="6a6e06a7-71d6-4753-8f49-a25f8eb0dc15" providerId="ADAL" clId="{6BE99AA9-1EEE-46D3-8261-83B0B634593B}" dt="2026-01-12T09:52:17.450" v="1225" actId="1076"/>
+        <pc:sldMkLst>
+          <pc:docMk/>
+          <pc:sldMk cId="2037528930" sldId="882"/>
+        </pc:sldMkLst>
+        <pc:spChg chg="add mod">
+          <ac:chgData name="André Boler Cláudio da Silva Barros" userId="6a6e06a7-71d6-4753-8f49-a25f8eb0dc15" providerId="ADAL" clId="{6BE99AA9-1EEE-46D3-8261-83B0B634593B}" dt="2026-01-12T09:48:22.609" v="1169" actId="208"/>
+          <ac:spMkLst>
+            <pc:docMk/>
+            <pc:sldMk cId="2037528930" sldId="882"/>
+            <ac:spMk id="2" creationId="{981156AD-61CB-63FB-C097-B8EECF5FB2DD}"/>
+          </ac:spMkLst>
+        </pc:spChg>
+        <pc:picChg chg="add mod">
+          <ac:chgData name="André Boler Cláudio da Silva Barros" userId="6a6e06a7-71d6-4753-8f49-a25f8eb0dc15" providerId="ADAL" clId="{6BE99AA9-1EEE-46D3-8261-83B0B634593B}" dt="2026-01-12T09:50:51.101" v="1173" actId="14100"/>
+          <ac:picMkLst>
+            <pc:docMk/>
+            <pc:sldMk cId="2037528930" sldId="882"/>
+            <ac:picMk id="5" creationId="{08761869-FFC3-45EB-4A12-AA62DC426D51}"/>
+          </ac:picMkLst>
+        </pc:picChg>
+        <pc:picChg chg="mod">
+          <ac:chgData name="André Boler Cláudio da Silva Barros" userId="6a6e06a7-71d6-4753-8f49-a25f8eb0dc15" providerId="ADAL" clId="{6BE99AA9-1EEE-46D3-8261-83B0B634593B}" dt="2026-01-12T09:52:17.450" v="1225" actId="1076"/>
+          <ac:picMkLst>
+            <pc:docMk/>
+            <pc:sldMk cId="2037528930" sldId="882"/>
+            <ac:picMk id="6" creationId="{1C645F75-16CA-01EA-6399-BE29CB47CB0C}"/>
+          </ac:picMkLst>
+        </pc:picChg>
+        <pc:picChg chg="add del">
+          <ac:chgData name="André Boler Cláudio da Silva Barros" userId="6a6e06a7-71d6-4753-8f49-a25f8eb0dc15" providerId="ADAL" clId="{6BE99AA9-1EEE-46D3-8261-83B0B634593B}" dt="2026-01-12T09:51:06.330" v="1175" actId="478"/>
+          <ac:picMkLst>
+            <pc:docMk/>
+            <pc:sldMk cId="2037528930" sldId="882"/>
+            <ac:picMk id="15" creationId="{57AF7549-8E33-3347-96B5-D2661F1B0AAE}"/>
+          </ac:picMkLst>
+        </pc:picChg>
+      </pc:sldChg>
       <pc:sldChg chg="del">
         <pc:chgData name="André Boler Cláudio da Silva Barros" userId="6a6e06a7-71d6-4753-8f49-a25f8eb0dc15" providerId="ADAL" clId="{6BE99AA9-1EEE-46D3-8261-83B0B634593B}" dt="2026-01-12T09:21:56.604" v="548" actId="47"/>
         <pc:sldMkLst>
           <pc:docMk/>
           <pc:sldMk cId="2957797501" sldId="883"/>
         </pc:sldMkLst>
+      </pc:sldChg>
+      <pc:sldChg chg="addSp delSp modSp add mod">
+        <pc:chgData name="André Boler Cláudio da Silva Barros" userId="6a6e06a7-71d6-4753-8f49-a25f8eb0dc15" providerId="ADAL" clId="{6BE99AA9-1EEE-46D3-8261-83B0B634593B}" dt="2026-01-12T09:53:13.511" v="1235" actId="1076"/>
+        <pc:sldMkLst>
+          <pc:docMk/>
+          <pc:sldMk cId="3898382547" sldId="883"/>
+        </pc:sldMkLst>
+        <pc:spChg chg="del">
+          <ac:chgData name="André Boler Cláudio da Silva Barros" userId="6a6e06a7-71d6-4753-8f49-a25f8eb0dc15" providerId="ADAL" clId="{6BE99AA9-1EEE-46D3-8261-83B0B634593B}" dt="2026-01-12T09:51:48.449" v="1218" actId="478"/>
+          <ac:spMkLst>
+            <pc:docMk/>
+            <pc:sldMk cId="3898382547" sldId="883"/>
+            <ac:spMk id="2" creationId="{EF930B1D-CC3B-8C12-95FE-2C6B92B469B8}"/>
+          </ac:spMkLst>
+        </pc:spChg>
+        <pc:spChg chg="mod">
+          <ac:chgData name="André Boler Cláudio da Silva Barros" userId="6a6e06a7-71d6-4753-8f49-a25f8eb0dc15" providerId="ADAL" clId="{6BE99AA9-1EEE-46D3-8261-83B0B634593B}" dt="2026-01-12T09:51:46.247" v="1217" actId="20577"/>
+          <ac:spMkLst>
+            <pc:docMk/>
+            <pc:sldMk cId="3898382547" sldId="883"/>
+            <ac:spMk id="4" creationId="{8BB9A50C-743C-271F-70D7-E34DC3AF900E}"/>
+          </ac:spMkLst>
+        </pc:spChg>
+        <pc:spChg chg="add mod">
+          <ac:chgData name="André Boler Cláudio da Silva Barros" userId="6a6e06a7-71d6-4753-8f49-a25f8eb0dc15" providerId="ADAL" clId="{6BE99AA9-1EEE-46D3-8261-83B0B634593B}" dt="2026-01-12T09:52:33.331" v="1232" actId="14100"/>
+          <ac:spMkLst>
+            <pc:docMk/>
+            <pc:sldMk cId="3898382547" sldId="883"/>
+            <ac:spMk id="15" creationId="{65A782FF-BA00-27A1-F4B9-EE6D98ABE094}"/>
+          </ac:spMkLst>
+        </pc:spChg>
+        <pc:picChg chg="del">
+          <ac:chgData name="André Boler Cláudio da Silva Barros" userId="6a6e06a7-71d6-4753-8f49-a25f8eb0dc15" providerId="ADAL" clId="{6BE99AA9-1EEE-46D3-8261-83B0B634593B}" dt="2026-01-12T09:51:12.030" v="1178" actId="478"/>
+          <ac:picMkLst>
+            <pc:docMk/>
+            <pc:sldMk cId="3898382547" sldId="883"/>
+            <ac:picMk id="5" creationId="{605473B1-641E-781B-9F82-92871F8269B1}"/>
+          </ac:picMkLst>
+        </pc:picChg>
+        <pc:picChg chg="del">
+          <ac:chgData name="André Boler Cláudio da Silva Barros" userId="6a6e06a7-71d6-4753-8f49-a25f8eb0dc15" providerId="ADAL" clId="{6BE99AA9-1EEE-46D3-8261-83B0B634593B}" dt="2026-01-12T09:51:11.009" v="1177" actId="478"/>
+          <ac:picMkLst>
+            <pc:docMk/>
+            <pc:sldMk cId="3898382547" sldId="883"/>
+            <ac:picMk id="6" creationId="{29E23511-E3F5-2FA7-C87E-D9CB908A256B}"/>
+          </ac:picMkLst>
+        </pc:picChg>
+        <pc:picChg chg="add mod modCrop">
+          <ac:chgData name="André Boler Cláudio da Silva Barros" userId="6a6e06a7-71d6-4753-8f49-a25f8eb0dc15" providerId="ADAL" clId="{6BE99AA9-1EEE-46D3-8261-83B0B634593B}" dt="2026-01-12T09:52:27.030" v="1229" actId="1076"/>
+          <ac:picMkLst>
+            <pc:docMk/>
+            <pc:sldMk cId="3898382547" sldId="883"/>
+            <ac:picMk id="8" creationId="{34DA4F9B-1EEA-3393-8A13-1F56013FC050}"/>
+          </ac:picMkLst>
+        </pc:picChg>
+        <pc:picChg chg="add mod">
+          <ac:chgData name="André Boler Cláudio da Silva Barros" userId="6a6e06a7-71d6-4753-8f49-a25f8eb0dc15" providerId="ADAL" clId="{6BE99AA9-1EEE-46D3-8261-83B0B634593B}" dt="2026-01-12T09:53:13.511" v="1235" actId="1076"/>
+          <ac:picMkLst>
+            <pc:docMk/>
+            <pc:sldMk cId="3898382547" sldId="883"/>
+            <ac:picMk id="17" creationId="{5A189844-8582-DCE9-6B9F-3C4EBB496620}"/>
+          </ac:picMkLst>
+        </pc:picChg>
+      </pc:sldChg>
+      <pc:sldChg chg="addSp delSp modSp add mod">
+        <pc:chgData name="André Boler Cláudio da Silva Barros" userId="6a6e06a7-71d6-4753-8f49-a25f8eb0dc15" providerId="ADAL" clId="{6BE99AA9-1EEE-46D3-8261-83B0B634593B}" dt="2026-01-12T09:54:40.856" v="1293" actId="1036"/>
+        <pc:sldMkLst>
+          <pc:docMk/>
+          <pc:sldMk cId="3811760795" sldId="884"/>
+        </pc:sldMkLst>
+        <pc:spChg chg="mod">
+          <ac:chgData name="André Boler Cláudio da Silva Barros" userId="6a6e06a7-71d6-4753-8f49-a25f8eb0dc15" providerId="ADAL" clId="{6BE99AA9-1EEE-46D3-8261-83B0B634593B}" dt="2026-01-12T09:53:32.592" v="1272" actId="20577"/>
+          <ac:spMkLst>
+            <pc:docMk/>
+            <pc:sldMk cId="3811760795" sldId="884"/>
+            <ac:spMk id="4" creationId="{B1EEA1FE-0E17-6AD1-2AFA-014911C1B9A6}"/>
+          </ac:spMkLst>
+        </pc:spChg>
+        <pc:spChg chg="add mod">
+          <ac:chgData name="André Boler Cláudio da Silva Barros" userId="6a6e06a7-71d6-4753-8f49-a25f8eb0dc15" providerId="ADAL" clId="{6BE99AA9-1EEE-46D3-8261-83B0B634593B}" dt="2026-01-12T09:54:40.856" v="1293" actId="1036"/>
+          <ac:spMkLst>
+            <pc:docMk/>
+            <pc:sldMk cId="3811760795" sldId="884"/>
+            <ac:spMk id="5" creationId="{3AF94B33-A8EB-1EDE-6D11-70FD40963897}"/>
+          </ac:spMkLst>
+        </pc:spChg>
+        <pc:spChg chg="mod">
+          <ac:chgData name="André Boler Cláudio da Silva Barros" userId="6a6e06a7-71d6-4753-8f49-a25f8eb0dc15" providerId="ADAL" clId="{6BE99AA9-1EEE-46D3-8261-83B0B634593B}" dt="2026-01-12T09:53:56.543" v="1280" actId="1076"/>
+          <ac:spMkLst>
+            <pc:docMk/>
+            <pc:sldMk cId="3811760795" sldId="884"/>
+            <ac:spMk id="15" creationId="{6478EFC7-F045-7079-8000-5B1307E810E4}"/>
+          </ac:spMkLst>
+        </pc:spChg>
+        <pc:picChg chg="add mod modCrop">
+          <ac:chgData name="André Boler Cláudio da Silva Barros" userId="6a6e06a7-71d6-4753-8f49-a25f8eb0dc15" providerId="ADAL" clId="{6BE99AA9-1EEE-46D3-8261-83B0B634593B}" dt="2026-01-12T09:54:26.680" v="1285" actId="14100"/>
+          <ac:picMkLst>
+            <pc:docMk/>
+            <pc:sldMk cId="3811760795" sldId="884"/>
+            <ac:picMk id="3" creationId="{EAC31A07-C2E3-BA9B-D4A0-5DFF260C4AC0}"/>
+          </ac:picMkLst>
+        </pc:picChg>
+        <pc:picChg chg="del">
+          <ac:chgData name="André Boler Cláudio da Silva Barros" userId="6a6e06a7-71d6-4753-8f49-a25f8eb0dc15" providerId="ADAL" clId="{6BE99AA9-1EEE-46D3-8261-83B0B634593B}" dt="2026-01-12T09:53:35.336" v="1273" actId="478"/>
+          <ac:picMkLst>
+            <pc:docMk/>
+            <pc:sldMk cId="3811760795" sldId="884"/>
+            <ac:picMk id="8" creationId="{AF223430-0886-3A3D-1AEE-367C23E1346C}"/>
+          </ac:picMkLst>
+        </pc:picChg>
+        <pc:picChg chg="mod ord modCrop">
+          <ac:chgData name="André Boler Cláudio da Silva Barros" userId="6a6e06a7-71d6-4753-8f49-a25f8eb0dc15" providerId="ADAL" clId="{6BE99AA9-1EEE-46D3-8261-83B0B634593B}" dt="2026-01-12T09:53:51.576" v="1279" actId="1076"/>
+          <ac:picMkLst>
+            <pc:docMk/>
+            <pc:sldMk cId="3811760795" sldId="884"/>
+            <ac:picMk id="17" creationId="{FED5154D-8E9B-10D4-6458-6DA83132A5EB}"/>
+          </ac:picMkLst>
+        </pc:picChg>
       </pc:sldChg>
       <pc:sldChg chg="del">
         <pc:chgData name="André Boler Cláudio da Silva Barros" userId="6a6e06a7-71d6-4753-8f49-a25f8eb0dc15" providerId="ADAL" clId="{6BE99AA9-1EEE-46D3-8261-83B0B634593B}" dt="2026-01-12T09:21:56.604" v="548" actId="47"/>
@@ -1502,6 +1686,351 @@
 </p:notes>
 </file>
 
+<file path=ppt/notesSlides/notesSlide6.xml><?xml version="1.0" encoding="utf-8"?>
+<p:notes xmlns:a="http://schemas.openxmlformats.org/drawingml/2006/main" xmlns:r="http://schemas.openxmlformats.org/officeDocument/2006/relationships" xmlns:p="http://schemas.openxmlformats.org/presentationml/2006/main">
+  <p:cSld>
+    <p:spTree>
+      <p:nvGrpSpPr>
+        <p:cNvPr id="1" name="">
+          <a:extLst>
+            <a:ext uri="{FF2B5EF4-FFF2-40B4-BE49-F238E27FC236}">
+              <a16:creationId xmlns:a16="http://schemas.microsoft.com/office/drawing/2014/main" id="{1666E4FB-C198-8341-1230-A51657580704}"/>
+            </a:ext>
+          </a:extLst>
+        </p:cNvPr>
+        <p:cNvGrpSpPr/>
+        <p:nvPr/>
+      </p:nvGrpSpPr>
+      <p:grpSpPr>
+        <a:xfrm>
+          <a:off x="0" y="0"/>
+          <a:ext cx="0" cy="0"/>
+          <a:chOff x="0" y="0"/>
+          <a:chExt cx="0" cy="0"/>
+        </a:xfrm>
+      </p:grpSpPr>
+      <p:sp>
+        <p:nvSpPr>
+          <p:cNvPr id="2" name="Slide Image Placeholder 1">
+            <a:extLst>
+              <a:ext uri="{FF2B5EF4-FFF2-40B4-BE49-F238E27FC236}">
+                <a16:creationId xmlns:a16="http://schemas.microsoft.com/office/drawing/2014/main" id="{118F8715-2340-3A0C-B069-A61FA8E32851}"/>
+              </a:ext>
+            </a:extLst>
+          </p:cNvPr>
+          <p:cNvSpPr>
+            <a:spLocks noGrp="1" noRot="1" noChangeAspect="1"/>
+          </p:cNvSpPr>
+          <p:nvPr>
+            <p:ph type="sldImg"/>
+          </p:nvPr>
+        </p:nvSpPr>
+        <p:spPr/>
+        <p:txBody>
+          <a:bodyPr/>
+          <a:lstStyle/>
+          <a:p>
+            <a:endParaRPr lang="pt-PT"/>
+          </a:p>
+        </p:txBody>
+      </p:sp>
+      <p:sp>
+        <p:nvSpPr>
+          <p:cNvPr id="3" name="Notes Placeholder 2">
+            <a:extLst>
+              <a:ext uri="{FF2B5EF4-FFF2-40B4-BE49-F238E27FC236}">
+                <a16:creationId xmlns:a16="http://schemas.microsoft.com/office/drawing/2014/main" id="{C7973336-7AFC-804D-8987-CBBF1040CA40}"/>
+              </a:ext>
+            </a:extLst>
+          </p:cNvPr>
+          <p:cNvSpPr>
+            <a:spLocks noGrp="1"/>
+          </p:cNvSpPr>
+          <p:nvPr>
+            <p:ph type="body" idx="1"/>
+          </p:nvPr>
+        </p:nvSpPr>
+        <p:spPr/>
+        <p:txBody>
+          <a:bodyPr/>
+          <a:lstStyle/>
+          <a:p>
+            <a:endParaRPr lang="pt-PT" dirty="0"/>
+          </a:p>
+        </p:txBody>
+      </p:sp>
+      <p:sp>
+        <p:nvSpPr>
+          <p:cNvPr id="4" name="Slide Number Placeholder 3">
+            <a:extLst>
+              <a:ext uri="{FF2B5EF4-FFF2-40B4-BE49-F238E27FC236}">
+                <a16:creationId xmlns:a16="http://schemas.microsoft.com/office/drawing/2014/main" id="{E252F391-20D4-17B3-BDBB-CC6F44E09914}"/>
+              </a:ext>
+            </a:extLst>
+          </p:cNvPr>
+          <p:cNvSpPr>
+            <a:spLocks noGrp="1"/>
+          </p:cNvSpPr>
+          <p:nvPr>
+            <p:ph type="sldNum" sz="quarter" idx="5"/>
+          </p:nvPr>
+        </p:nvSpPr>
+        <p:spPr/>
+        <p:txBody>
+          <a:bodyPr/>
+          <a:lstStyle/>
+          <a:p>
+            <a:fld id="{304CD7C7-91BF-4B50-A187-D8898A81460C}" type="slidenum">
+              <a:rPr lang="en-GB" smtClean="0"/>
+              <a:t>6</a:t>
+            </a:fld>
+            <a:endParaRPr lang="en-GB"/>
+          </a:p>
+        </p:txBody>
+      </p:sp>
+    </p:spTree>
+    <p:extLst>
+      <p:ext uri="{BB962C8B-B14F-4D97-AF65-F5344CB8AC3E}">
+        <p14:creationId xmlns:p14="http://schemas.microsoft.com/office/powerpoint/2010/main" val="629655458"/>
+      </p:ext>
+    </p:extLst>
+  </p:cSld>
+  <p:clrMapOvr>
+    <a:masterClrMapping/>
+  </p:clrMapOvr>
+</p:notes>
+</file>
+
+<file path=ppt/notesSlides/notesSlide7.xml><?xml version="1.0" encoding="utf-8"?>
+<p:notes xmlns:a="http://schemas.openxmlformats.org/drawingml/2006/main" xmlns:r="http://schemas.openxmlformats.org/officeDocument/2006/relationships" xmlns:p="http://schemas.openxmlformats.org/presentationml/2006/main">
+  <p:cSld>
+    <p:spTree>
+      <p:nvGrpSpPr>
+        <p:cNvPr id="1" name="">
+          <a:extLst>
+            <a:ext uri="{FF2B5EF4-FFF2-40B4-BE49-F238E27FC236}">
+              <a16:creationId xmlns:a16="http://schemas.microsoft.com/office/drawing/2014/main" id="{F329BB4E-E696-CC78-8B7D-B63109436791}"/>
+            </a:ext>
+          </a:extLst>
+        </p:cNvPr>
+        <p:cNvGrpSpPr/>
+        <p:nvPr/>
+      </p:nvGrpSpPr>
+      <p:grpSpPr>
+        <a:xfrm>
+          <a:off x="0" y="0"/>
+          <a:ext cx="0" cy="0"/>
+          <a:chOff x="0" y="0"/>
+          <a:chExt cx="0" cy="0"/>
+        </a:xfrm>
+      </p:grpSpPr>
+      <p:sp>
+        <p:nvSpPr>
+          <p:cNvPr id="2" name="Slide Image Placeholder 1">
+            <a:extLst>
+              <a:ext uri="{FF2B5EF4-FFF2-40B4-BE49-F238E27FC236}">
+                <a16:creationId xmlns:a16="http://schemas.microsoft.com/office/drawing/2014/main" id="{6D819366-7802-9080-6FE6-96977E3F33E1}"/>
+              </a:ext>
+            </a:extLst>
+          </p:cNvPr>
+          <p:cNvSpPr>
+            <a:spLocks noGrp="1" noRot="1" noChangeAspect="1"/>
+          </p:cNvSpPr>
+          <p:nvPr>
+            <p:ph type="sldImg"/>
+          </p:nvPr>
+        </p:nvSpPr>
+        <p:spPr/>
+        <p:txBody>
+          <a:bodyPr/>
+          <a:lstStyle/>
+          <a:p>
+            <a:endParaRPr lang="pt-PT"/>
+          </a:p>
+        </p:txBody>
+      </p:sp>
+      <p:sp>
+        <p:nvSpPr>
+          <p:cNvPr id="3" name="Notes Placeholder 2">
+            <a:extLst>
+              <a:ext uri="{FF2B5EF4-FFF2-40B4-BE49-F238E27FC236}">
+                <a16:creationId xmlns:a16="http://schemas.microsoft.com/office/drawing/2014/main" id="{01158DAC-2A07-5955-7DDC-6D5538F3F505}"/>
+              </a:ext>
+            </a:extLst>
+          </p:cNvPr>
+          <p:cNvSpPr>
+            <a:spLocks noGrp="1"/>
+          </p:cNvSpPr>
+          <p:nvPr>
+            <p:ph type="body" idx="1"/>
+          </p:nvPr>
+        </p:nvSpPr>
+        <p:spPr/>
+        <p:txBody>
+          <a:bodyPr/>
+          <a:lstStyle/>
+          <a:p>
+            <a:endParaRPr lang="pt-PT" dirty="0"/>
+          </a:p>
+        </p:txBody>
+      </p:sp>
+      <p:sp>
+        <p:nvSpPr>
+          <p:cNvPr id="4" name="Slide Number Placeholder 3">
+            <a:extLst>
+              <a:ext uri="{FF2B5EF4-FFF2-40B4-BE49-F238E27FC236}">
+                <a16:creationId xmlns:a16="http://schemas.microsoft.com/office/drawing/2014/main" id="{7E8E98A8-9216-E7A7-372B-133D439FBE66}"/>
+              </a:ext>
+            </a:extLst>
+          </p:cNvPr>
+          <p:cNvSpPr>
+            <a:spLocks noGrp="1"/>
+          </p:cNvSpPr>
+          <p:nvPr>
+            <p:ph type="sldNum" sz="quarter" idx="5"/>
+          </p:nvPr>
+        </p:nvSpPr>
+        <p:spPr/>
+        <p:txBody>
+          <a:bodyPr/>
+          <a:lstStyle/>
+          <a:p>
+            <a:fld id="{304CD7C7-91BF-4B50-A187-D8898A81460C}" type="slidenum">
+              <a:rPr lang="en-GB" smtClean="0"/>
+              <a:t>7</a:t>
+            </a:fld>
+            <a:endParaRPr lang="en-GB"/>
+          </a:p>
+        </p:txBody>
+      </p:sp>
+    </p:spTree>
+    <p:extLst>
+      <p:ext uri="{BB962C8B-B14F-4D97-AF65-F5344CB8AC3E}">
+        <p14:creationId xmlns:p14="http://schemas.microsoft.com/office/powerpoint/2010/main" val="3896732663"/>
+      </p:ext>
+    </p:extLst>
+  </p:cSld>
+  <p:clrMapOvr>
+    <a:masterClrMapping/>
+  </p:clrMapOvr>
+</p:notes>
+</file>
+
+<file path=ppt/notesSlides/notesSlide8.xml><?xml version="1.0" encoding="utf-8"?>
+<p:notes xmlns:a="http://schemas.openxmlformats.org/drawingml/2006/main" xmlns:r="http://schemas.openxmlformats.org/officeDocument/2006/relationships" xmlns:p="http://schemas.openxmlformats.org/presentationml/2006/main">
+  <p:cSld>
+    <p:spTree>
+      <p:nvGrpSpPr>
+        <p:cNvPr id="1" name="">
+          <a:extLst>
+            <a:ext uri="{FF2B5EF4-FFF2-40B4-BE49-F238E27FC236}">
+              <a16:creationId xmlns:a16="http://schemas.microsoft.com/office/drawing/2014/main" id="{03D6918A-7F94-DE9B-058E-EDEC77446835}"/>
+            </a:ext>
+          </a:extLst>
+        </p:cNvPr>
+        <p:cNvGrpSpPr/>
+        <p:nvPr/>
+      </p:nvGrpSpPr>
+      <p:grpSpPr>
+        <a:xfrm>
+          <a:off x="0" y="0"/>
+          <a:ext cx="0" cy="0"/>
+          <a:chOff x="0" y="0"/>
+          <a:chExt cx="0" cy="0"/>
+        </a:xfrm>
+      </p:grpSpPr>
+      <p:sp>
+        <p:nvSpPr>
+          <p:cNvPr id="2" name="Slide Image Placeholder 1">
+            <a:extLst>
+              <a:ext uri="{FF2B5EF4-FFF2-40B4-BE49-F238E27FC236}">
+                <a16:creationId xmlns:a16="http://schemas.microsoft.com/office/drawing/2014/main" id="{165B448D-442E-8019-334A-E57F86BDF4A4}"/>
+              </a:ext>
+            </a:extLst>
+          </p:cNvPr>
+          <p:cNvSpPr>
+            <a:spLocks noGrp="1" noRot="1" noChangeAspect="1"/>
+          </p:cNvSpPr>
+          <p:nvPr>
+            <p:ph type="sldImg"/>
+          </p:nvPr>
+        </p:nvSpPr>
+        <p:spPr/>
+        <p:txBody>
+          <a:bodyPr/>
+          <a:lstStyle/>
+          <a:p>
+            <a:endParaRPr lang="pt-PT"/>
+          </a:p>
+        </p:txBody>
+      </p:sp>
+      <p:sp>
+        <p:nvSpPr>
+          <p:cNvPr id="3" name="Notes Placeholder 2">
+            <a:extLst>
+              <a:ext uri="{FF2B5EF4-FFF2-40B4-BE49-F238E27FC236}">
+                <a16:creationId xmlns:a16="http://schemas.microsoft.com/office/drawing/2014/main" id="{98889B37-069F-C478-C68E-AFEF73F4BCAC}"/>
+              </a:ext>
+            </a:extLst>
+          </p:cNvPr>
+          <p:cNvSpPr>
+            <a:spLocks noGrp="1"/>
+          </p:cNvSpPr>
+          <p:nvPr>
+            <p:ph type="body" idx="1"/>
+          </p:nvPr>
+        </p:nvSpPr>
+        <p:spPr/>
+        <p:txBody>
+          <a:bodyPr/>
+          <a:lstStyle/>
+          <a:p>
+            <a:endParaRPr lang="pt-PT" dirty="0"/>
+          </a:p>
+        </p:txBody>
+      </p:sp>
+      <p:sp>
+        <p:nvSpPr>
+          <p:cNvPr id="4" name="Slide Number Placeholder 3">
+            <a:extLst>
+              <a:ext uri="{FF2B5EF4-FFF2-40B4-BE49-F238E27FC236}">
+                <a16:creationId xmlns:a16="http://schemas.microsoft.com/office/drawing/2014/main" id="{74E616D3-FE16-4766-4520-96A1D5757621}"/>
+              </a:ext>
+            </a:extLst>
+          </p:cNvPr>
+          <p:cNvSpPr>
+            <a:spLocks noGrp="1"/>
+          </p:cNvSpPr>
+          <p:nvPr>
+            <p:ph type="sldNum" sz="quarter" idx="5"/>
+          </p:nvPr>
+        </p:nvSpPr>
+        <p:spPr/>
+        <p:txBody>
+          <a:bodyPr/>
+          <a:lstStyle/>
+          <a:p>
+            <a:fld id="{304CD7C7-91BF-4B50-A187-D8898A81460C}" type="slidenum">
+              <a:rPr lang="en-GB" smtClean="0"/>
+              <a:t>8</a:t>
+            </a:fld>
+            <a:endParaRPr lang="en-GB"/>
+          </a:p>
+        </p:txBody>
+      </p:sp>
+    </p:spTree>
+    <p:extLst>
+      <p:ext uri="{BB962C8B-B14F-4D97-AF65-F5344CB8AC3E}">
+        <p14:creationId xmlns:p14="http://schemas.microsoft.com/office/powerpoint/2010/main" val="690028706"/>
+      </p:ext>
+    </p:extLst>
+  </p:cSld>
+  <p:clrMapOvr>
+    <a:masterClrMapping/>
+  </p:clrMapOvr>
+</p:notes>
+</file>
+
 <file path=ppt/slideLayouts/slideLayout1.xml><?xml version="1.0" encoding="utf-8"?>
 <p:sldLayout xmlns:a="http://schemas.openxmlformats.org/drawingml/2006/main" xmlns:r="http://schemas.openxmlformats.org/officeDocument/2006/relationships" xmlns:p="http://schemas.openxmlformats.org/presentationml/2006/main" type="title" preserve="1">
   <p:cSld name="Title Slide">
@@ -6824,7 +7353,7 @@
         <p:spPr>
           <a:xfrm>
             <a:off x="222111" y="800107"/>
-            <a:ext cx="11747779" cy="1131785"/>
+            <a:ext cx="11747779" cy="1039452"/>
           </a:xfrm>
           <a:prstGeom prst="rect">
             <a:avLst/>
@@ -6843,14 +7372,14 @@
               </a:lnSpc>
             </a:pPr>
             <a:r>
-              <a:rPr lang="en-GB" sz="2400" b="1" dirty="0">
+              <a:rPr lang="en-GB" sz="2000" b="1" dirty="0">
                 <a:latin typeface="Cambria" panose="02040503050406030204" pitchFamily="18" charset="0"/>
                 <a:ea typeface="Cambria" panose="02040503050406030204" pitchFamily="18" charset="0"/>
                 <a:hlinkClick r:id="rId3"/>
               </a:rPr>
               <a:t>https://github.com/andrebolerbarros/Intro_R</a:t>
             </a:r>
-            <a:endParaRPr lang="en-GB" sz="2400" b="1" dirty="0">
+            <a:endParaRPr lang="en-GB" sz="2000" b="1" dirty="0">
               <a:latin typeface="Cambria" panose="02040503050406030204" pitchFamily="18" charset="0"/>
               <a:ea typeface="Cambria" panose="02040503050406030204" pitchFamily="18" charset="0"/>
             </a:endParaRPr>
@@ -7178,10 +7707,2013 @@
           </a:prstGeom>
         </p:spPr>
       </p:pic>
+      <p:sp>
+        <p:nvSpPr>
+          <p:cNvPr id="4" name="TextBox 3">
+            <a:extLst>
+              <a:ext uri="{FF2B5EF4-FFF2-40B4-BE49-F238E27FC236}">
+                <a16:creationId xmlns:a16="http://schemas.microsoft.com/office/drawing/2014/main" id="{72EE2559-4C3B-C03B-E93B-0B09C7C1877A}"/>
+              </a:ext>
+            </a:extLst>
+          </p:cNvPr>
+          <p:cNvSpPr txBox="1"/>
+          <p:nvPr/>
+        </p:nvSpPr>
+        <p:spPr>
+          <a:xfrm>
+            <a:off x="222110" y="1529798"/>
+            <a:ext cx="11747779" cy="456472"/>
+          </a:xfrm>
+          <a:prstGeom prst="rect">
+            <a:avLst/>
+          </a:prstGeom>
+          <a:noFill/>
+        </p:spPr>
+        <p:txBody>
+          <a:bodyPr wrap="square" rtlCol="0">
+            <a:spAutoFit/>
+          </a:bodyPr>
+          <a:lstStyle/>
+          <a:p>
+            <a:pPr marL="342900" indent="-342900" algn="just">
+              <a:lnSpc>
+                <a:spcPct val="150000"/>
+              </a:lnSpc>
+              <a:buFont typeface="+mj-lt"/>
+              <a:buAutoNum type="arabicPeriod"/>
+              <a:tabLst>
+                <a:tab pos="447675" algn="l"/>
+              </a:tabLst>
+            </a:pPr>
+            <a:r>
+              <a:rPr lang="en-GB" dirty="0">
+                <a:latin typeface="Cambria" panose="02040503050406030204" pitchFamily="18" charset="0"/>
+                <a:ea typeface="Cambria" panose="02040503050406030204" pitchFamily="18" charset="0"/>
+              </a:rPr>
+              <a:t>Google </a:t>
+            </a:r>
+            <a:r>
+              <a:rPr lang="en-GB" dirty="0" err="1">
+                <a:latin typeface="Cambria" panose="02040503050406030204" pitchFamily="18" charset="0"/>
+                <a:ea typeface="Cambria" panose="02040503050406030204" pitchFamily="18" charset="0"/>
+              </a:rPr>
+              <a:t>Colab</a:t>
+            </a:r>
+            <a:r>
+              <a:rPr lang="en-GB" dirty="0">
+                <a:latin typeface="Cambria" panose="02040503050406030204" pitchFamily="18" charset="0"/>
+                <a:ea typeface="Cambria" panose="02040503050406030204" pitchFamily="18" charset="0"/>
+              </a:rPr>
+              <a:t> – colab.research.google.com</a:t>
+            </a:r>
+            <a:endParaRPr lang="en-GB" sz="2400" b="1" dirty="0">
+              <a:latin typeface="Cambria" panose="02040503050406030204" pitchFamily="18" charset="0"/>
+              <a:ea typeface="Cambria" panose="02040503050406030204" pitchFamily="18" charset="0"/>
+            </a:endParaRPr>
+          </a:p>
+        </p:txBody>
+      </p:sp>
+      <p:pic>
+        <p:nvPicPr>
+          <p:cNvPr id="6" name="Picture 5">
+            <a:extLst>
+              <a:ext uri="{FF2B5EF4-FFF2-40B4-BE49-F238E27FC236}">
+                <a16:creationId xmlns:a16="http://schemas.microsoft.com/office/drawing/2014/main" id="{CC3CF65D-AC81-F858-12BC-C3E3CEC52B85}"/>
+              </a:ext>
+            </a:extLst>
+          </p:cNvPr>
+          <p:cNvPicPr>
+            <a:picLocks noChangeAspect="1"/>
+          </p:cNvPicPr>
+          <p:nvPr/>
+        </p:nvPicPr>
+        <p:blipFill>
+          <a:blip r:embed="rId6"/>
+          <a:srcRect b="13118"/>
+          <a:stretch>
+            <a:fillRect/>
+          </a:stretch>
+        </p:blipFill>
+        <p:spPr>
+          <a:xfrm>
+            <a:off x="318096" y="2043574"/>
+            <a:ext cx="5777904" cy="4139021"/>
+          </a:xfrm>
+          <a:prstGeom prst="rect">
+            <a:avLst/>
+          </a:prstGeom>
+        </p:spPr>
+      </p:pic>
     </p:spTree>
     <p:extLst>
       <p:ext uri="{BB962C8B-B14F-4D97-AF65-F5344CB8AC3E}">
         <p14:creationId xmlns:p14="http://schemas.microsoft.com/office/powerpoint/2010/main" val="2310122796"/>
+      </p:ext>
+    </p:extLst>
+  </p:cSld>
+  <p:clrMapOvr>
+    <a:masterClrMapping/>
+  </p:clrMapOvr>
+</p:sld>
+</file>
+
+<file path=ppt/slides/slide6.xml><?xml version="1.0" encoding="utf-8"?>
+<p:sld xmlns:a="http://schemas.openxmlformats.org/drawingml/2006/main" xmlns:r="http://schemas.openxmlformats.org/officeDocument/2006/relationships" xmlns:p="http://schemas.openxmlformats.org/presentationml/2006/main">
+  <p:cSld>
+    <p:spTree>
+      <p:nvGrpSpPr>
+        <p:cNvPr id="1" name="">
+          <a:extLst>
+            <a:ext uri="{FF2B5EF4-FFF2-40B4-BE49-F238E27FC236}">
+              <a16:creationId xmlns:a16="http://schemas.microsoft.com/office/drawing/2014/main" id="{5E6E3A7E-46F1-B6CE-16CE-B0B73505E2CF}"/>
+            </a:ext>
+          </a:extLst>
+        </p:cNvPr>
+        <p:cNvGrpSpPr/>
+        <p:nvPr/>
+      </p:nvGrpSpPr>
+      <p:grpSpPr>
+        <a:xfrm>
+          <a:off x="0" y="0"/>
+          <a:ext cx="0" cy="0"/>
+          <a:chOff x="0" y="0"/>
+          <a:chExt cx="0" cy="0"/>
+        </a:xfrm>
+      </p:grpSpPr>
+      <p:sp>
+        <p:nvSpPr>
+          <p:cNvPr id="7" name="TextBox 6">
+            <a:extLst>
+              <a:ext uri="{FF2B5EF4-FFF2-40B4-BE49-F238E27FC236}">
+                <a16:creationId xmlns:a16="http://schemas.microsoft.com/office/drawing/2014/main" id="{3B663FD9-06FF-B617-A03C-BC0FDF55BB25}"/>
+              </a:ext>
+            </a:extLst>
+          </p:cNvPr>
+          <p:cNvSpPr txBox="1"/>
+          <p:nvPr/>
+        </p:nvSpPr>
+        <p:spPr>
+          <a:xfrm>
+            <a:off x="318096" y="0"/>
+            <a:ext cx="11555807" cy="584775"/>
+          </a:xfrm>
+          <a:prstGeom prst="rect">
+            <a:avLst/>
+          </a:prstGeom>
+          <a:noFill/>
+        </p:spPr>
+        <p:txBody>
+          <a:bodyPr wrap="square" rtlCol="0">
+            <a:spAutoFit/>
+          </a:bodyPr>
+          <a:lstStyle/>
+          <a:p>
+            <a:r>
+              <a:rPr lang="en-GB" sz="3200" b="1" noProof="0" dirty="0">
+                <a:solidFill>
+                  <a:schemeClr val="bg1"/>
+                </a:solidFill>
+                <a:latin typeface="Cambria" panose="02040503050406030204" pitchFamily="18" charset="0"/>
+                <a:ea typeface="Cambria" panose="02040503050406030204" pitchFamily="18" charset="0"/>
+                <a:cs typeface="Times New Roman" panose="02020603050405020304" pitchFamily="18" charset="0"/>
+              </a:rPr>
+              <a:t>Course Material</a:t>
+            </a:r>
+          </a:p>
+        </p:txBody>
+      </p:sp>
+      <p:sp>
+        <p:nvSpPr>
+          <p:cNvPr id="13" name="TextBox 12">
+            <a:extLst>
+              <a:ext uri="{FF2B5EF4-FFF2-40B4-BE49-F238E27FC236}">
+                <a16:creationId xmlns:a16="http://schemas.microsoft.com/office/drawing/2014/main" id="{0DA69895-95AC-C112-E18B-681787F74DB8}"/>
+              </a:ext>
+            </a:extLst>
+          </p:cNvPr>
+          <p:cNvSpPr txBox="1"/>
+          <p:nvPr/>
+        </p:nvSpPr>
+        <p:spPr>
+          <a:xfrm>
+            <a:off x="222111" y="800107"/>
+            <a:ext cx="11747779" cy="1039452"/>
+          </a:xfrm>
+          <a:prstGeom prst="rect">
+            <a:avLst/>
+          </a:prstGeom>
+          <a:noFill/>
+        </p:spPr>
+        <p:txBody>
+          <a:bodyPr wrap="square" rtlCol="0">
+            <a:spAutoFit/>
+          </a:bodyPr>
+          <a:lstStyle/>
+          <a:p>
+            <a:pPr algn="ctr">
+              <a:lnSpc>
+                <a:spcPct val="150000"/>
+              </a:lnSpc>
+            </a:pPr>
+            <a:r>
+              <a:rPr lang="en-GB" sz="2000" b="1" dirty="0">
+                <a:latin typeface="Cambria" panose="02040503050406030204" pitchFamily="18" charset="0"/>
+                <a:ea typeface="Cambria" panose="02040503050406030204" pitchFamily="18" charset="0"/>
+                <a:hlinkClick r:id="rId3"/>
+              </a:rPr>
+              <a:t>https://github.com/andrebolerbarros/Intro_R</a:t>
+            </a:r>
+            <a:endParaRPr lang="en-GB" sz="2000" b="1" dirty="0">
+              <a:latin typeface="Cambria" panose="02040503050406030204" pitchFamily="18" charset="0"/>
+              <a:ea typeface="Cambria" panose="02040503050406030204" pitchFamily="18" charset="0"/>
+            </a:endParaRPr>
+          </a:p>
+          <a:p>
+            <a:pPr marL="285750" indent="-285750" algn="just">
+              <a:lnSpc>
+                <a:spcPct val="150000"/>
+              </a:lnSpc>
+              <a:buFont typeface="Arial" panose="020B0604020202020204" pitchFamily="34" charset="0"/>
+              <a:buChar char="•"/>
+            </a:pPr>
+            <a:endParaRPr lang="en-GB" sz="2400" b="1" dirty="0">
+              <a:latin typeface="Cambria" panose="02040503050406030204" pitchFamily="18" charset="0"/>
+              <a:ea typeface="Cambria" panose="02040503050406030204" pitchFamily="18" charset="0"/>
+            </a:endParaRPr>
+          </a:p>
+        </p:txBody>
+      </p:sp>
+      <p:pic>
+        <p:nvPicPr>
+          <p:cNvPr id="9" name="Picture 8" descr="A white circle with black background&#10;&#10;Description automatically generated">
+            <a:extLst>
+              <a:ext uri="{FF2B5EF4-FFF2-40B4-BE49-F238E27FC236}">
+                <a16:creationId xmlns:a16="http://schemas.microsoft.com/office/drawing/2014/main" id="{7F99BFC3-A890-D0DC-0B23-3C6801830A7C}"/>
+              </a:ext>
+            </a:extLst>
+          </p:cNvPr>
+          <p:cNvPicPr>
+            <a:picLocks noChangeAspect="1"/>
+          </p:cNvPicPr>
+          <p:nvPr/>
+        </p:nvPicPr>
+        <p:blipFill>
+          <a:blip r:embed="rId4"/>
+          <a:srcRect t="19605" r="16255" b="22685"/>
+          <a:stretch>
+            <a:fillRect/>
+          </a:stretch>
+        </p:blipFill>
+        <p:spPr>
+          <a:xfrm>
+            <a:off x="-269926" y="6222582"/>
+            <a:ext cx="939853" cy="628211"/>
+          </a:xfrm>
+          <a:prstGeom prst="rect">
+            <a:avLst/>
+          </a:prstGeom>
+        </p:spPr>
+      </p:pic>
+      <p:cxnSp>
+        <p:nvCxnSpPr>
+          <p:cNvPr id="10" name="Straight Connector 9">
+            <a:extLst>
+              <a:ext uri="{FF2B5EF4-FFF2-40B4-BE49-F238E27FC236}">
+                <a16:creationId xmlns:a16="http://schemas.microsoft.com/office/drawing/2014/main" id="{4EC05F94-3E18-1CB2-C6A1-D4DA504413A6}"/>
+              </a:ext>
+            </a:extLst>
+          </p:cNvPr>
+          <p:cNvCxnSpPr>
+            <a:cxnSpLocks/>
+          </p:cNvCxnSpPr>
+          <p:nvPr/>
+        </p:nvCxnSpPr>
+        <p:spPr>
+          <a:xfrm flipV="1">
+            <a:off x="669927" y="6523348"/>
+            <a:ext cx="10580947" cy="1"/>
+          </a:xfrm>
+          <a:prstGeom prst="line">
+            <a:avLst/>
+          </a:prstGeom>
+          <a:ln>
+            <a:solidFill>
+              <a:schemeClr val="bg1"/>
+            </a:solidFill>
+          </a:ln>
+        </p:spPr>
+        <p:style>
+          <a:lnRef idx="1">
+            <a:schemeClr val="dk1"/>
+          </a:lnRef>
+          <a:fillRef idx="0">
+            <a:schemeClr val="dk1"/>
+          </a:fillRef>
+          <a:effectRef idx="0">
+            <a:schemeClr val="dk1"/>
+          </a:effectRef>
+          <a:fontRef idx="minor">
+            <a:schemeClr val="tx1"/>
+          </a:fontRef>
+        </p:style>
+      </p:cxnSp>
+      <p:sp>
+        <p:nvSpPr>
+          <p:cNvPr id="11" name="Slide Number Placeholder 2">
+            <a:extLst>
+              <a:ext uri="{FF2B5EF4-FFF2-40B4-BE49-F238E27FC236}">
+                <a16:creationId xmlns:a16="http://schemas.microsoft.com/office/drawing/2014/main" id="{0C987A9D-CCCD-BAE3-AB04-771563D0DA59}"/>
+              </a:ext>
+            </a:extLst>
+          </p:cNvPr>
+          <p:cNvSpPr txBox="1">
+            <a:spLocks/>
+          </p:cNvSpPr>
+          <p:nvPr/>
+        </p:nvSpPr>
+        <p:spPr>
+          <a:xfrm>
+            <a:off x="8804750" y="6337394"/>
+            <a:ext cx="2825475" cy="365125"/>
+          </a:xfrm>
+          <a:prstGeom prst="rect">
+            <a:avLst/>
+          </a:prstGeom>
+        </p:spPr>
+        <p:txBody>
+          <a:bodyPr vert="horz" lIns="91440" tIns="45720" rIns="91440" bIns="45720" rtlCol="0" anchor="ctr"/>
+          <a:lstStyle>
+            <a:defPPr>
+              <a:defRPr lang="en-US"/>
+            </a:defPPr>
+            <a:lvl1pPr marL="0" algn="r" defTabSz="914400" rtl="0" eaLnBrk="1" latinLnBrk="0" hangingPunct="1">
+              <a:defRPr sz="1200" kern="1200">
+                <a:solidFill>
+                  <a:schemeClr val="tx1">
+                    <a:tint val="75000"/>
+                  </a:schemeClr>
+                </a:solidFill>
+                <a:latin typeface="+mn-lt"/>
+                <a:ea typeface="+mn-ea"/>
+                <a:cs typeface="+mn-cs"/>
+              </a:defRPr>
+            </a:lvl1pPr>
+            <a:lvl2pPr marL="457200" algn="l" defTabSz="914400" rtl="0" eaLnBrk="1" latinLnBrk="0" hangingPunct="1">
+              <a:defRPr sz="1800" kern="1200">
+                <a:solidFill>
+                  <a:schemeClr val="tx1"/>
+                </a:solidFill>
+                <a:latin typeface="+mn-lt"/>
+                <a:ea typeface="+mn-ea"/>
+                <a:cs typeface="+mn-cs"/>
+              </a:defRPr>
+            </a:lvl2pPr>
+            <a:lvl3pPr marL="914400" algn="l" defTabSz="914400" rtl="0" eaLnBrk="1" latinLnBrk="0" hangingPunct="1">
+              <a:defRPr sz="1800" kern="1200">
+                <a:solidFill>
+                  <a:schemeClr val="tx1"/>
+                </a:solidFill>
+                <a:latin typeface="+mn-lt"/>
+                <a:ea typeface="+mn-ea"/>
+                <a:cs typeface="+mn-cs"/>
+              </a:defRPr>
+            </a:lvl3pPr>
+            <a:lvl4pPr marL="1371600" algn="l" defTabSz="914400" rtl="0" eaLnBrk="1" latinLnBrk="0" hangingPunct="1">
+              <a:defRPr sz="1800" kern="1200">
+                <a:solidFill>
+                  <a:schemeClr val="tx1"/>
+                </a:solidFill>
+                <a:latin typeface="+mn-lt"/>
+                <a:ea typeface="+mn-ea"/>
+                <a:cs typeface="+mn-cs"/>
+              </a:defRPr>
+            </a:lvl4pPr>
+            <a:lvl5pPr marL="1828800" algn="l" defTabSz="914400" rtl="0" eaLnBrk="1" latinLnBrk="0" hangingPunct="1">
+              <a:defRPr sz="1800" kern="1200">
+                <a:solidFill>
+                  <a:schemeClr val="tx1"/>
+                </a:solidFill>
+                <a:latin typeface="+mn-lt"/>
+                <a:ea typeface="+mn-ea"/>
+                <a:cs typeface="+mn-cs"/>
+              </a:defRPr>
+            </a:lvl5pPr>
+            <a:lvl6pPr marL="2286000" algn="l" defTabSz="914400" rtl="0" eaLnBrk="1" latinLnBrk="0" hangingPunct="1">
+              <a:defRPr sz="1800" kern="1200">
+                <a:solidFill>
+                  <a:schemeClr val="tx1"/>
+                </a:solidFill>
+                <a:latin typeface="+mn-lt"/>
+                <a:ea typeface="+mn-ea"/>
+                <a:cs typeface="+mn-cs"/>
+              </a:defRPr>
+            </a:lvl6pPr>
+            <a:lvl7pPr marL="2743200" algn="l" defTabSz="914400" rtl="0" eaLnBrk="1" latinLnBrk="0" hangingPunct="1">
+              <a:defRPr sz="1800" kern="1200">
+                <a:solidFill>
+                  <a:schemeClr val="tx1"/>
+                </a:solidFill>
+                <a:latin typeface="+mn-lt"/>
+                <a:ea typeface="+mn-ea"/>
+                <a:cs typeface="+mn-cs"/>
+              </a:defRPr>
+            </a:lvl7pPr>
+            <a:lvl8pPr marL="3200400" algn="l" defTabSz="914400" rtl="0" eaLnBrk="1" latinLnBrk="0" hangingPunct="1">
+              <a:defRPr sz="1800" kern="1200">
+                <a:solidFill>
+                  <a:schemeClr val="tx1"/>
+                </a:solidFill>
+                <a:latin typeface="+mn-lt"/>
+                <a:ea typeface="+mn-ea"/>
+                <a:cs typeface="+mn-cs"/>
+              </a:defRPr>
+            </a:lvl8pPr>
+            <a:lvl9pPr marL="3657600" algn="l" defTabSz="914400" rtl="0" eaLnBrk="1" latinLnBrk="0" hangingPunct="1">
+              <a:defRPr sz="1800" kern="1200">
+                <a:solidFill>
+                  <a:schemeClr val="tx1"/>
+                </a:solidFill>
+                <a:latin typeface="+mn-lt"/>
+                <a:ea typeface="+mn-ea"/>
+                <a:cs typeface="+mn-cs"/>
+              </a:defRPr>
+            </a:lvl9pPr>
+          </a:lstStyle>
+          <a:p>
+            <a:fld id="{54B21BD1-F593-4F4E-86E9-52991719DFB8}" type="slidenum">
+              <a:rPr lang="en-GB" sz="1400" noProof="0" smtClean="0">
+                <a:solidFill>
+                  <a:schemeClr val="bg1"/>
+                </a:solidFill>
+                <a:latin typeface="Cambria" panose="02040503050406030204" pitchFamily="18" charset="0"/>
+                <a:ea typeface="Cambria" panose="02040503050406030204" pitchFamily="18" charset="0"/>
+              </a:rPr>
+              <a:pPr/>
+              <a:t>6</a:t>
+            </a:fld>
+            <a:endParaRPr lang="en-GB" sz="1400" noProof="0" dirty="0">
+              <a:solidFill>
+                <a:schemeClr val="bg1"/>
+              </a:solidFill>
+              <a:latin typeface="Cambria" panose="02040503050406030204" pitchFamily="18" charset="0"/>
+              <a:ea typeface="Cambria" panose="02040503050406030204" pitchFamily="18" charset="0"/>
+            </a:endParaRPr>
+          </a:p>
+        </p:txBody>
+      </p:sp>
+      <p:sp>
+        <p:nvSpPr>
+          <p:cNvPr id="12" name="TextBox 11">
+            <a:extLst>
+              <a:ext uri="{FF2B5EF4-FFF2-40B4-BE49-F238E27FC236}">
+                <a16:creationId xmlns:a16="http://schemas.microsoft.com/office/drawing/2014/main" id="{24D2C0BB-C682-50A0-7220-4332061B24F4}"/>
+              </a:ext>
+            </a:extLst>
+          </p:cNvPr>
+          <p:cNvSpPr txBox="1"/>
+          <p:nvPr/>
+        </p:nvSpPr>
+        <p:spPr>
+          <a:xfrm>
+            <a:off x="3870960" y="6451133"/>
+            <a:ext cx="4450080" cy="335092"/>
+          </a:xfrm>
+          <a:prstGeom prst="rect">
+            <a:avLst/>
+          </a:prstGeom>
+          <a:noFill/>
+        </p:spPr>
+        <p:txBody>
+          <a:bodyPr wrap="square" rtlCol="0">
+            <a:spAutoFit/>
+          </a:bodyPr>
+          <a:lstStyle/>
+          <a:p>
+            <a:pPr defTabSz="825500">
+              <a:lnSpc>
+                <a:spcPct val="150000"/>
+              </a:lnSpc>
+              <a:tabLst>
+                <a:tab pos="3768725" algn="l"/>
+                <a:tab pos="4572000" algn="l"/>
+              </a:tabLst>
+            </a:pPr>
+            <a:r>
+              <a:rPr lang="en-GB" sz="1200" noProof="0" dirty="0">
+                <a:solidFill>
+                  <a:schemeClr val="bg1"/>
+                </a:solidFill>
+                <a:latin typeface="Cambria" panose="02040503050406030204" pitchFamily="18" charset="0"/>
+                <a:ea typeface="Cambria" panose="02040503050406030204" pitchFamily="18" charset="0"/>
+                <a:cs typeface="Times New Roman" panose="02020603050405020304" pitchFamily="18" charset="0"/>
+              </a:rPr>
+              <a:t>André Barros | Advanced Data Analysis | 12th January 2026</a:t>
+            </a:r>
+            <a:endParaRPr lang="en-GB" sz="1200" i="1" noProof="0" dirty="0">
+              <a:solidFill>
+                <a:schemeClr val="bg1"/>
+              </a:solidFill>
+              <a:latin typeface="Cambria" panose="02040503050406030204" pitchFamily="18" charset="0"/>
+              <a:ea typeface="Cambria" panose="02040503050406030204" pitchFamily="18" charset="0"/>
+              <a:cs typeface="Times New Roman" panose="02020603050405020304" pitchFamily="18" charset="0"/>
+            </a:endParaRPr>
+          </a:p>
+        </p:txBody>
+      </p:sp>
+      <p:pic>
+        <p:nvPicPr>
+          <p:cNvPr id="14" name="Picture 13">
+            <a:extLst>
+              <a:ext uri="{FF2B5EF4-FFF2-40B4-BE49-F238E27FC236}">
+                <a16:creationId xmlns:a16="http://schemas.microsoft.com/office/drawing/2014/main" id="{E7E029B3-CF6B-3A3B-B618-A035D8254055}"/>
+              </a:ext>
+            </a:extLst>
+          </p:cNvPr>
+          <p:cNvPicPr>
+            <a:picLocks noChangeAspect="1"/>
+          </p:cNvPicPr>
+          <p:nvPr/>
+        </p:nvPicPr>
+        <p:blipFill>
+          <a:blip r:embed="rId5"/>
+          <a:srcRect l="22765" t="18648" r="25605" b="15789"/>
+          <a:stretch>
+            <a:fillRect/>
+          </a:stretch>
+        </p:blipFill>
+        <p:spPr>
+          <a:xfrm>
+            <a:off x="11581065" y="6281675"/>
+            <a:ext cx="425229" cy="540000"/>
+          </a:xfrm>
+          <a:prstGeom prst="rect">
+            <a:avLst/>
+          </a:prstGeom>
+        </p:spPr>
+      </p:pic>
+      <p:sp>
+        <p:nvSpPr>
+          <p:cNvPr id="4" name="TextBox 3">
+            <a:extLst>
+              <a:ext uri="{FF2B5EF4-FFF2-40B4-BE49-F238E27FC236}">
+                <a16:creationId xmlns:a16="http://schemas.microsoft.com/office/drawing/2014/main" id="{968328BF-D3A6-1FD8-8400-9D50D4ED034F}"/>
+              </a:ext>
+            </a:extLst>
+          </p:cNvPr>
+          <p:cNvSpPr txBox="1"/>
+          <p:nvPr/>
+        </p:nvSpPr>
+        <p:spPr>
+          <a:xfrm>
+            <a:off x="222110" y="1529798"/>
+            <a:ext cx="11747779" cy="456472"/>
+          </a:xfrm>
+          <a:prstGeom prst="rect">
+            <a:avLst/>
+          </a:prstGeom>
+          <a:noFill/>
+        </p:spPr>
+        <p:txBody>
+          <a:bodyPr wrap="square" rtlCol="0">
+            <a:spAutoFit/>
+          </a:bodyPr>
+          <a:lstStyle/>
+          <a:p>
+            <a:pPr marL="342900" indent="-342900" algn="just">
+              <a:lnSpc>
+                <a:spcPct val="150000"/>
+              </a:lnSpc>
+              <a:buFont typeface="+mj-lt"/>
+              <a:buAutoNum type="arabicPeriod"/>
+              <a:tabLst>
+                <a:tab pos="447675" algn="l"/>
+              </a:tabLst>
+            </a:pPr>
+            <a:r>
+              <a:rPr lang="en-GB" dirty="0">
+                <a:latin typeface="Cambria" panose="02040503050406030204" pitchFamily="18" charset="0"/>
+                <a:ea typeface="Cambria" panose="02040503050406030204" pitchFamily="18" charset="0"/>
+              </a:rPr>
+              <a:t>Google </a:t>
+            </a:r>
+            <a:r>
+              <a:rPr lang="en-GB" dirty="0" err="1">
+                <a:latin typeface="Cambria" panose="02040503050406030204" pitchFamily="18" charset="0"/>
+                <a:ea typeface="Cambria" panose="02040503050406030204" pitchFamily="18" charset="0"/>
+              </a:rPr>
+              <a:t>Colab</a:t>
+            </a:r>
+            <a:r>
+              <a:rPr lang="en-GB" dirty="0">
+                <a:latin typeface="Cambria" panose="02040503050406030204" pitchFamily="18" charset="0"/>
+                <a:ea typeface="Cambria" panose="02040503050406030204" pitchFamily="18" charset="0"/>
+              </a:rPr>
+              <a:t> – colab.research.google.com</a:t>
+            </a:r>
+            <a:endParaRPr lang="en-GB" sz="2400" b="1" dirty="0">
+              <a:latin typeface="Cambria" panose="02040503050406030204" pitchFamily="18" charset="0"/>
+              <a:ea typeface="Cambria" panose="02040503050406030204" pitchFamily="18" charset="0"/>
+            </a:endParaRPr>
+          </a:p>
+        </p:txBody>
+      </p:sp>
+      <p:pic>
+        <p:nvPicPr>
+          <p:cNvPr id="6" name="Picture 5">
+            <a:extLst>
+              <a:ext uri="{FF2B5EF4-FFF2-40B4-BE49-F238E27FC236}">
+                <a16:creationId xmlns:a16="http://schemas.microsoft.com/office/drawing/2014/main" id="{1C645F75-16CA-01EA-6399-BE29CB47CB0C}"/>
+              </a:ext>
+            </a:extLst>
+          </p:cNvPr>
+          <p:cNvPicPr>
+            <a:picLocks noChangeAspect="1"/>
+          </p:cNvPicPr>
+          <p:nvPr/>
+        </p:nvPicPr>
+        <p:blipFill>
+          <a:blip r:embed="rId6"/>
+          <a:srcRect b="13118"/>
+          <a:stretch>
+            <a:fillRect/>
+          </a:stretch>
+        </p:blipFill>
+        <p:spPr>
+          <a:xfrm>
+            <a:off x="318096" y="2043574"/>
+            <a:ext cx="5777904" cy="4139021"/>
+          </a:xfrm>
+          <a:prstGeom prst="rect">
+            <a:avLst/>
+          </a:prstGeom>
+        </p:spPr>
+      </p:pic>
+      <p:sp>
+        <p:nvSpPr>
+          <p:cNvPr id="2" name="Rectangle: Rounded Corners 1">
+            <a:extLst>
+              <a:ext uri="{FF2B5EF4-FFF2-40B4-BE49-F238E27FC236}">
+                <a16:creationId xmlns:a16="http://schemas.microsoft.com/office/drawing/2014/main" id="{981156AD-61CB-63FB-C097-B8EECF5FB2DD}"/>
+              </a:ext>
+            </a:extLst>
+          </p:cNvPr>
+          <p:cNvSpPr/>
+          <p:nvPr/>
+        </p:nvSpPr>
+        <p:spPr>
+          <a:xfrm>
+            <a:off x="368490" y="4790364"/>
+            <a:ext cx="1153235" cy="331489"/>
+          </a:xfrm>
+          <a:prstGeom prst="roundRect">
+            <a:avLst/>
+          </a:prstGeom>
+          <a:noFill/>
+          <a:ln>
+            <a:solidFill>
+              <a:srgbClr val="C00000"/>
+            </a:solidFill>
+          </a:ln>
+        </p:spPr>
+        <p:style>
+          <a:lnRef idx="2">
+            <a:schemeClr val="accent1">
+              <a:shade val="15000"/>
+            </a:schemeClr>
+          </a:lnRef>
+          <a:fillRef idx="1">
+            <a:schemeClr val="accent1"/>
+          </a:fillRef>
+          <a:effectRef idx="0">
+            <a:schemeClr val="accent1"/>
+          </a:effectRef>
+          <a:fontRef idx="minor">
+            <a:schemeClr val="lt1"/>
+          </a:fontRef>
+        </p:style>
+        <p:txBody>
+          <a:bodyPr rtlCol="0" anchor="ctr"/>
+          <a:lstStyle/>
+          <a:p>
+            <a:pPr algn="ctr"/>
+            <a:endParaRPr lang="pt-PT"/>
+          </a:p>
+        </p:txBody>
+      </p:sp>
+      <p:pic>
+        <p:nvPicPr>
+          <p:cNvPr id="5" name="Picture 4">
+            <a:extLst>
+              <a:ext uri="{FF2B5EF4-FFF2-40B4-BE49-F238E27FC236}">
+                <a16:creationId xmlns:a16="http://schemas.microsoft.com/office/drawing/2014/main" id="{08761869-FFC3-45EB-4A12-AA62DC426D51}"/>
+              </a:ext>
+            </a:extLst>
+          </p:cNvPr>
+          <p:cNvPicPr>
+            <a:picLocks noChangeAspect="1"/>
+          </p:cNvPicPr>
+          <p:nvPr/>
+        </p:nvPicPr>
+        <p:blipFill>
+          <a:blip r:embed="rId7"/>
+          <a:stretch>
+            <a:fillRect/>
+          </a:stretch>
+        </p:blipFill>
+        <p:spPr>
+          <a:xfrm>
+            <a:off x="6820186" y="1986270"/>
+            <a:ext cx="5053717" cy="2738180"/>
+          </a:xfrm>
+          <a:prstGeom prst="rect">
+            <a:avLst/>
+          </a:prstGeom>
+        </p:spPr>
+      </p:pic>
+    </p:spTree>
+    <p:extLst>
+      <p:ext uri="{BB962C8B-B14F-4D97-AF65-F5344CB8AC3E}">
+        <p14:creationId xmlns:p14="http://schemas.microsoft.com/office/powerpoint/2010/main" val="2037528930"/>
+      </p:ext>
+    </p:extLst>
+  </p:cSld>
+  <p:clrMapOvr>
+    <a:masterClrMapping/>
+  </p:clrMapOvr>
+</p:sld>
+</file>
+
+<file path=ppt/slides/slide7.xml><?xml version="1.0" encoding="utf-8"?>
+<p:sld xmlns:a="http://schemas.openxmlformats.org/drawingml/2006/main" xmlns:r="http://schemas.openxmlformats.org/officeDocument/2006/relationships" xmlns:p="http://schemas.openxmlformats.org/presentationml/2006/main">
+  <p:cSld>
+    <p:spTree>
+      <p:nvGrpSpPr>
+        <p:cNvPr id="1" name="">
+          <a:extLst>
+            <a:ext uri="{FF2B5EF4-FFF2-40B4-BE49-F238E27FC236}">
+              <a16:creationId xmlns:a16="http://schemas.microsoft.com/office/drawing/2014/main" id="{4105F3A0-BADC-79FE-F084-FC12A977EDEE}"/>
+            </a:ext>
+          </a:extLst>
+        </p:cNvPr>
+        <p:cNvGrpSpPr/>
+        <p:nvPr/>
+      </p:nvGrpSpPr>
+      <p:grpSpPr>
+        <a:xfrm>
+          <a:off x="0" y="0"/>
+          <a:ext cx="0" cy="0"/>
+          <a:chOff x="0" y="0"/>
+          <a:chExt cx="0" cy="0"/>
+        </a:xfrm>
+      </p:grpSpPr>
+      <p:sp>
+        <p:nvSpPr>
+          <p:cNvPr id="7" name="TextBox 6">
+            <a:extLst>
+              <a:ext uri="{FF2B5EF4-FFF2-40B4-BE49-F238E27FC236}">
+                <a16:creationId xmlns:a16="http://schemas.microsoft.com/office/drawing/2014/main" id="{128BF5E7-C7C5-34B1-A06A-1BF0429D9F9B}"/>
+              </a:ext>
+            </a:extLst>
+          </p:cNvPr>
+          <p:cNvSpPr txBox="1"/>
+          <p:nvPr/>
+        </p:nvSpPr>
+        <p:spPr>
+          <a:xfrm>
+            <a:off x="318096" y="0"/>
+            <a:ext cx="11555807" cy="584775"/>
+          </a:xfrm>
+          <a:prstGeom prst="rect">
+            <a:avLst/>
+          </a:prstGeom>
+          <a:noFill/>
+        </p:spPr>
+        <p:txBody>
+          <a:bodyPr wrap="square" rtlCol="0">
+            <a:spAutoFit/>
+          </a:bodyPr>
+          <a:lstStyle/>
+          <a:p>
+            <a:r>
+              <a:rPr lang="en-GB" sz="3200" b="1" noProof="0" dirty="0">
+                <a:solidFill>
+                  <a:schemeClr val="bg1"/>
+                </a:solidFill>
+                <a:latin typeface="Cambria" panose="02040503050406030204" pitchFamily="18" charset="0"/>
+                <a:ea typeface="Cambria" panose="02040503050406030204" pitchFamily="18" charset="0"/>
+                <a:cs typeface="Times New Roman" panose="02020603050405020304" pitchFamily="18" charset="0"/>
+              </a:rPr>
+              <a:t>Course Material</a:t>
+            </a:r>
+          </a:p>
+        </p:txBody>
+      </p:sp>
+      <p:sp>
+        <p:nvSpPr>
+          <p:cNvPr id="13" name="TextBox 12">
+            <a:extLst>
+              <a:ext uri="{FF2B5EF4-FFF2-40B4-BE49-F238E27FC236}">
+                <a16:creationId xmlns:a16="http://schemas.microsoft.com/office/drawing/2014/main" id="{D3E9A08A-B163-C480-000D-9C5B2F1C650B}"/>
+              </a:ext>
+            </a:extLst>
+          </p:cNvPr>
+          <p:cNvSpPr txBox="1"/>
+          <p:nvPr/>
+        </p:nvSpPr>
+        <p:spPr>
+          <a:xfrm>
+            <a:off x="222111" y="800107"/>
+            <a:ext cx="11747779" cy="1039452"/>
+          </a:xfrm>
+          <a:prstGeom prst="rect">
+            <a:avLst/>
+          </a:prstGeom>
+          <a:noFill/>
+        </p:spPr>
+        <p:txBody>
+          <a:bodyPr wrap="square" rtlCol="0">
+            <a:spAutoFit/>
+          </a:bodyPr>
+          <a:lstStyle/>
+          <a:p>
+            <a:pPr algn="ctr">
+              <a:lnSpc>
+                <a:spcPct val="150000"/>
+              </a:lnSpc>
+            </a:pPr>
+            <a:r>
+              <a:rPr lang="en-GB" sz="2000" b="1" dirty="0">
+                <a:latin typeface="Cambria" panose="02040503050406030204" pitchFamily="18" charset="0"/>
+                <a:ea typeface="Cambria" panose="02040503050406030204" pitchFamily="18" charset="0"/>
+                <a:hlinkClick r:id="rId3"/>
+              </a:rPr>
+              <a:t>https://github.com/andrebolerbarros/Intro_R</a:t>
+            </a:r>
+            <a:endParaRPr lang="en-GB" sz="2000" b="1" dirty="0">
+              <a:latin typeface="Cambria" panose="02040503050406030204" pitchFamily="18" charset="0"/>
+              <a:ea typeface="Cambria" panose="02040503050406030204" pitchFamily="18" charset="0"/>
+            </a:endParaRPr>
+          </a:p>
+          <a:p>
+            <a:pPr marL="285750" indent="-285750" algn="just">
+              <a:lnSpc>
+                <a:spcPct val="150000"/>
+              </a:lnSpc>
+              <a:buFont typeface="Arial" panose="020B0604020202020204" pitchFamily="34" charset="0"/>
+              <a:buChar char="•"/>
+            </a:pPr>
+            <a:endParaRPr lang="en-GB" sz="2400" b="1" dirty="0">
+              <a:latin typeface="Cambria" panose="02040503050406030204" pitchFamily="18" charset="0"/>
+              <a:ea typeface="Cambria" panose="02040503050406030204" pitchFamily="18" charset="0"/>
+            </a:endParaRPr>
+          </a:p>
+        </p:txBody>
+      </p:sp>
+      <p:pic>
+        <p:nvPicPr>
+          <p:cNvPr id="9" name="Picture 8" descr="A white circle with black background&#10;&#10;Description automatically generated">
+            <a:extLst>
+              <a:ext uri="{FF2B5EF4-FFF2-40B4-BE49-F238E27FC236}">
+                <a16:creationId xmlns:a16="http://schemas.microsoft.com/office/drawing/2014/main" id="{C08904FE-13A9-855B-AD54-6B9CED445FED}"/>
+              </a:ext>
+            </a:extLst>
+          </p:cNvPr>
+          <p:cNvPicPr>
+            <a:picLocks noChangeAspect="1"/>
+          </p:cNvPicPr>
+          <p:nvPr/>
+        </p:nvPicPr>
+        <p:blipFill>
+          <a:blip r:embed="rId4"/>
+          <a:srcRect t="19605" r="16255" b="22685"/>
+          <a:stretch>
+            <a:fillRect/>
+          </a:stretch>
+        </p:blipFill>
+        <p:spPr>
+          <a:xfrm>
+            <a:off x="-269926" y="6222582"/>
+            <a:ext cx="939853" cy="628211"/>
+          </a:xfrm>
+          <a:prstGeom prst="rect">
+            <a:avLst/>
+          </a:prstGeom>
+        </p:spPr>
+      </p:pic>
+      <p:cxnSp>
+        <p:nvCxnSpPr>
+          <p:cNvPr id="10" name="Straight Connector 9">
+            <a:extLst>
+              <a:ext uri="{FF2B5EF4-FFF2-40B4-BE49-F238E27FC236}">
+                <a16:creationId xmlns:a16="http://schemas.microsoft.com/office/drawing/2014/main" id="{6A15FC2A-3829-0CCD-C06B-E85DE06FA41D}"/>
+              </a:ext>
+            </a:extLst>
+          </p:cNvPr>
+          <p:cNvCxnSpPr>
+            <a:cxnSpLocks/>
+          </p:cNvCxnSpPr>
+          <p:nvPr/>
+        </p:nvCxnSpPr>
+        <p:spPr>
+          <a:xfrm flipV="1">
+            <a:off x="669927" y="6523348"/>
+            <a:ext cx="10580947" cy="1"/>
+          </a:xfrm>
+          <a:prstGeom prst="line">
+            <a:avLst/>
+          </a:prstGeom>
+          <a:ln>
+            <a:solidFill>
+              <a:schemeClr val="bg1"/>
+            </a:solidFill>
+          </a:ln>
+        </p:spPr>
+        <p:style>
+          <a:lnRef idx="1">
+            <a:schemeClr val="dk1"/>
+          </a:lnRef>
+          <a:fillRef idx="0">
+            <a:schemeClr val="dk1"/>
+          </a:fillRef>
+          <a:effectRef idx="0">
+            <a:schemeClr val="dk1"/>
+          </a:effectRef>
+          <a:fontRef idx="minor">
+            <a:schemeClr val="tx1"/>
+          </a:fontRef>
+        </p:style>
+      </p:cxnSp>
+      <p:sp>
+        <p:nvSpPr>
+          <p:cNvPr id="11" name="Slide Number Placeholder 2">
+            <a:extLst>
+              <a:ext uri="{FF2B5EF4-FFF2-40B4-BE49-F238E27FC236}">
+                <a16:creationId xmlns:a16="http://schemas.microsoft.com/office/drawing/2014/main" id="{AFA2FD39-B991-D040-4DE0-1FC0D1B831D4}"/>
+              </a:ext>
+            </a:extLst>
+          </p:cNvPr>
+          <p:cNvSpPr txBox="1">
+            <a:spLocks/>
+          </p:cNvSpPr>
+          <p:nvPr/>
+        </p:nvSpPr>
+        <p:spPr>
+          <a:xfrm>
+            <a:off x="8804750" y="6337394"/>
+            <a:ext cx="2825475" cy="365125"/>
+          </a:xfrm>
+          <a:prstGeom prst="rect">
+            <a:avLst/>
+          </a:prstGeom>
+        </p:spPr>
+        <p:txBody>
+          <a:bodyPr vert="horz" lIns="91440" tIns="45720" rIns="91440" bIns="45720" rtlCol="0" anchor="ctr"/>
+          <a:lstStyle>
+            <a:defPPr>
+              <a:defRPr lang="en-US"/>
+            </a:defPPr>
+            <a:lvl1pPr marL="0" algn="r" defTabSz="914400" rtl="0" eaLnBrk="1" latinLnBrk="0" hangingPunct="1">
+              <a:defRPr sz="1200" kern="1200">
+                <a:solidFill>
+                  <a:schemeClr val="tx1">
+                    <a:tint val="75000"/>
+                  </a:schemeClr>
+                </a:solidFill>
+                <a:latin typeface="+mn-lt"/>
+                <a:ea typeface="+mn-ea"/>
+                <a:cs typeface="+mn-cs"/>
+              </a:defRPr>
+            </a:lvl1pPr>
+            <a:lvl2pPr marL="457200" algn="l" defTabSz="914400" rtl="0" eaLnBrk="1" latinLnBrk="0" hangingPunct="1">
+              <a:defRPr sz="1800" kern="1200">
+                <a:solidFill>
+                  <a:schemeClr val="tx1"/>
+                </a:solidFill>
+                <a:latin typeface="+mn-lt"/>
+                <a:ea typeface="+mn-ea"/>
+                <a:cs typeface="+mn-cs"/>
+              </a:defRPr>
+            </a:lvl2pPr>
+            <a:lvl3pPr marL="914400" algn="l" defTabSz="914400" rtl="0" eaLnBrk="1" latinLnBrk="0" hangingPunct="1">
+              <a:defRPr sz="1800" kern="1200">
+                <a:solidFill>
+                  <a:schemeClr val="tx1"/>
+                </a:solidFill>
+                <a:latin typeface="+mn-lt"/>
+                <a:ea typeface="+mn-ea"/>
+                <a:cs typeface="+mn-cs"/>
+              </a:defRPr>
+            </a:lvl3pPr>
+            <a:lvl4pPr marL="1371600" algn="l" defTabSz="914400" rtl="0" eaLnBrk="1" latinLnBrk="0" hangingPunct="1">
+              <a:defRPr sz="1800" kern="1200">
+                <a:solidFill>
+                  <a:schemeClr val="tx1"/>
+                </a:solidFill>
+                <a:latin typeface="+mn-lt"/>
+                <a:ea typeface="+mn-ea"/>
+                <a:cs typeface="+mn-cs"/>
+              </a:defRPr>
+            </a:lvl4pPr>
+            <a:lvl5pPr marL="1828800" algn="l" defTabSz="914400" rtl="0" eaLnBrk="1" latinLnBrk="0" hangingPunct="1">
+              <a:defRPr sz="1800" kern="1200">
+                <a:solidFill>
+                  <a:schemeClr val="tx1"/>
+                </a:solidFill>
+                <a:latin typeface="+mn-lt"/>
+                <a:ea typeface="+mn-ea"/>
+                <a:cs typeface="+mn-cs"/>
+              </a:defRPr>
+            </a:lvl5pPr>
+            <a:lvl6pPr marL="2286000" algn="l" defTabSz="914400" rtl="0" eaLnBrk="1" latinLnBrk="0" hangingPunct="1">
+              <a:defRPr sz="1800" kern="1200">
+                <a:solidFill>
+                  <a:schemeClr val="tx1"/>
+                </a:solidFill>
+                <a:latin typeface="+mn-lt"/>
+                <a:ea typeface="+mn-ea"/>
+                <a:cs typeface="+mn-cs"/>
+              </a:defRPr>
+            </a:lvl6pPr>
+            <a:lvl7pPr marL="2743200" algn="l" defTabSz="914400" rtl="0" eaLnBrk="1" latinLnBrk="0" hangingPunct="1">
+              <a:defRPr sz="1800" kern="1200">
+                <a:solidFill>
+                  <a:schemeClr val="tx1"/>
+                </a:solidFill>
+                <a:latin typeface="+mn-lt"/>
+                <a:ea typeface="+mn-ea"/>
+                <a:cs typeface="+mn-cs"/>
+              </a:defRPr>
+            </a:lvl7pPr>
+            <a:lvl8pPr marL="3200400" algn="l" defTabSz="914400" rtl="0" eaLnBrk="1" latinLnBrk="0" hangingPunct="1">
+              <a:defRPr sz="1800" kern="1200">
+                <a:solidFill>
+                  <a:schemeClr val="tx1"/>
+                </a:solidFill>
+                <a:latin typeface="+mn-lt"/>
+                <a:ea typeface="+mn-ea"/>
+                <a:cs typeface="+mn-cs"/>
+              </a:defRPr>
+            </a:lvl8pPr>
+            <a:lvl9pPr marL="3657600" algn="l" defTabSz="914400" rtl="0" eaLnBrk="1" latinLnBrk="0" hangingPunct="1">
+              <a:defRPr sz="1800" kern="1200">
+                <a:solidFill>
+                  <a:schemeClr val="tx1"/>
+                </a:solidFill>
+                <a:latin typeface="+mn-lt"/>
+                <a:ea typeface="+mn-ea"/>
+                <a:cs typeface="+mn-cs"/>
+              </a:defRPr>
+            </a:lvl9pPr>
+          </a:lstStyle>
+          <a:p>
+            <a:fld id="{54B21BD1-F593-4F4E-86E9-52991719DFB8}" type="slidenum">
+              <a:rPr lang="en-GB" sz="1400" noProof="0" smtClean="0">
+                <a:solidFill>
+                  <a:schemeClr val="bg1"/>
+                </a:solidFill>
+                <a:latin typeface="Cambria" panose="02040503050406030204" pitchFamily="18" charset="0"/>
+                <a:ea typeface="Cambria" panose="02040503050406030204" pitchFamily="18" charset="0"/>
+              </a:rPr>
+              <a:pPr/>
+              <a:t>7</a:t>
+            </a:fld>
+            <a:endParaRPr lang="en-GB" sz="1400" noProof="0" dirty="0">
+              <a:solidFill>
+                <a:schemeClr val="bg1"/>
+              </a:solidFill>
+              <a:latin typeface="Cambria" panose="02040503050406030204" pitchFamily="18" charset="0"/>
+              <a:ea typeface="Cambria" panose="02040503050406030204" pitchFamily="18" charset="0"/>
+            </a:endParaRPr>
+          </a:p>
+        </p:txBody>
+      </p:sp>
+      <p:sp>
+        <p:nvSpPr>
+          <p:cNvPr id="12" name="TextBox 11">
+            <a:extLst>
+              <a:ext uri="{FF2B5EF4-FFF2-40B4-BE49-F238E27FC236}">
+                <a16:creationId xmlns:a16="http://schemas.microsoft.com/office/drawing/2014/main" id="{0A55999F-1D49-8B1F-B6DF-322AF6BF2B6A}"/>
+              </a:ext>
+            </a:extLst>
+          </p:cNvPr>
+          <p:cNvSpPr txBox="1"/>
+          <p:nvPr/>
+        </p:nvSpPr>
+        <p:spPr>
+          <a:xfrm>
+            <a:off x="3870960" y="6451133"/>
+            <a:ext cx="4450080" cy="335092"/>
+          </a:xfrm>
+          <a:prstGeom prst="rect">
+            <a:avLst/>
+          </a:prstGeom>
+          <a:noFill/>
+        </p:spPr>
+        <p:txBody>
+          <a:bodyPr wrap="square" rtlCol="0">
+            <a:spAutoFit/>
+          </a:bodyPr>
+          <a:lstStyle/>
+          <a:p>
+            <a:pPr defTabSz="825500">
+              <a:lnSpc>
+                <a:spcPct val="150000"/>
+              </a:lnSpc>
+              <a:tabLst>
+                <a:tab pos="3768725" algn="l"/>
+                <a:tab pos="4572000" algn="l"/>
+              </a:tabLst>
+            </a:pPr>
+            <a:r>
+              <a:rPr lang="en-GB" sz="1200" noProof="0" dirty="0">
+                <a:solidFill>
+                  <a:schemeClr val="bg1"/>
+                </a:solidFill>
+                <a:latin typeface="Cambria" panose="02040503050406030204" pitchFamily="18" charset="0"/>
+                <a:ea typeface="Cambria" panose="02040503050406030204" pitchFamily="18" charset="0"/>
+                <a:cs typeface="Times New Roman" panose="02020603050405020304" pitchFamily="18" charset="0"/>
+              </a:rPr>
+              <a:t>André Barros | Advanced Data Analysis | 12th January 2026</a:t>
+            </a:r>
+            <a:endParaRPr lang="en-GB" sz="1200" i="1" noProof="0" dirty="0">
+              <a:solidFill>
+                <a:schemeClr val="bg1"/>
+              </a:solidFill>
+              <a:latin typeface="Cambria" panose="02040503050406030204" pitchFamily="18" charset="0"/>
+              <a:ea typeface="Cambria" panose="02040503050406030204" pitchFamily="18" charset="0"/>
+              <a:cs typeface="Times New Roman" panose="02020603050405020304" pitchFamily="18" charset="0"/>
+            </a:endParaRPr>
+          </a:p>
+        </p:txBody>
+      </p:sp>
+      <p:pic>
+        <p:nvPicPr>
+          <p:cNvPr id="14" name="Picture 13">
+            <a:extLst>
+              <a:ext uri="{FF2B5EF4-FFF2-40B4-BE49-F238E27FC236}">
+                <a16:creationId xmlns:a16="http://schemas.microsoft.com/office/drawing/2014/main" id="{8885E40B-EE98-5227-8578-79F403A751CA}"/>
+              </a:ext>
+            </a:extLst>
+          </p:cNvPr>
+          <p:cNvPicPr>
+            <a:picLocks noChangeAspect="1"/>
+          </p:cNvPicPr>
+          <p:nvPr/>
+        </p:nvPicPr>
+        <p:blipFill>
+          <a:blip r:embed="rId5"/>
+          <a:srcRect l="22765" t="18648" r="25605" b="15789"/>
+          <a:stretch>
+            <a:fillRect/>
+          </a:stretch>
+        </p:blipFill>
+        <p:spPr>
+          <a:xfrm>
+            <a:off x="11581065" y="6281675"/>
+            <a:ext cx="425229" cy="540000"/>
+          </a:xfrm>
+          <a:prstGeom prst="rect">
+            <a:avLst/>
+          </a:prstGeom>
+        </p:spPr>
+      </p:pic>
+      <p:sp>
+        <p:nvSpPr>
+          <p:cNvPr id="4" name="TextBox 3">
+            <a:extLst>
+              <a:ext uri="{FF2B5EF4-FFF2-40B4-BE49-F238E27FC236}">
+                <a16:creationId xmlns:a16="http://schemas.microsoft.com/office/drawing/2014/main" id="{8BB9A50C-743C-271F-70D7-E34DC3AF900E}"/>
+              </a:ext>
+            </a:extLst>
+          </p:cNvPr>
+          <p:cNvSpPr txBox="1"/>
+          <p:nvPr/>
+        </p:nvSpPr>
+        <p:spPr>
+          <a:xfrm>
+            <a:off x="222110" y="1529798"/>
+            <a:ext cx="11747779" cy="456472"/>
+          </a:xfrm>
+          <a:prstGeom prst="rect">
+            <a:avLst/>
+          </a:prstGeom>
+          <a:noFill/>
+        </p:spPr>
+        <p:txBody>
+          <a:bodyPr wrap="square" rtlCol="0">
+            <a:spAutoFit/>
+          </a:bodyPr>
+          <a:lstStyle/>
+          <a:p>
+            <a:pPr algn="just">
+              <a:lnSpc>
+                <a:spcPct val="150000"/>
+              </a:lnSpc>
+              <a:tabLst>
+                <a:tab pos="447675" algn="l"/>
+              </a:tabLst>
+            </a:pPr>
+            <a:r>
+              <a:rPr lang="en-GB" dirty="0">
+                <a:latin typeface="Cambria" panose="02040503050406030204" pitchFamily="18" charset="0"/>
+                <a:ea typeface="Cambria" panose="02040503050406030204" pitchFamily="18" charset="0"/>
+              </a:rPr>
+              <a:t>2.	</a:t>
+            </a:r>
+            <a:r>
+              <a:rPr lang="en-GB" u="sng" dirty="0">
+                <a:latin typeface="Cambria" panose="02040503050406030204" pitchFamily="18" charset="0"/>
+                <a:ea typeface="Cambria" panose="02040503050406030204" pitchFamily="18" charset="0"/>
+              </a:rPr>
+              <a:t>Save your own copy</a:t>
+            </a:r>
+            <a:endParaRPr lang="en-GB" sz="2400" b="1" dirty="0">
+              <a:latin typeface="Cambria" panose="02040503050406030204" pitchFamily="18" charset="0"/>
+              <a:ea typeface="Cambria" panose="02040503050406030204" pitchFamily="18" charset="0"/>
+            </a:endParaRPr>
+          </a:p>
+        </p:txBody>
+      </p:sp>
+      <p:pic>
+        <p:nvPicPr>
+          <p:cNvPr id="8" name="Picture 7">
+            <a:extLst>
+              <a:ext uri="{FF2B5EF4-FFF2-40B4-BE49-F238E27FC236}">
+                <a16:creationId xmlns:a16="http://schemas.microsoft.com/office/drawing/2014/main" id="{34DA4F9B-1EEA-3393-8A13-1F56013FC050}"/>
+              </a:ext>
+            </a:extLst>
+          </p:cNvPr>
+          <p:cNvPicPr>
+            <a:picLocks noChangeAspect="1"/>
+          </p:cNvPicPr>
+          <p:nvPr/>
+        </p:nvPicPr>
+        <p:blipFill>
+          <a:blip r:embed="rId6"/>
+          <a:srcRect r="41949" b="18241"/>
+          <a:stretch>
+            <a:fillRect/>
+          </a:stretch>
+        </p:blipFill>
+        <p:spPr>
+          <a:xfrm>
+            <a:off x="200001" y="2255377"/>
+            <a:ext cx="2886958" cy="3694273"/>
+          </a:xfrm>
+          <a:prstGeom prst="rect">
+            <a:avLst/>
+          </a:prstGeom>
+        </p:spPr>
+      </p:pic>
+      <p:sp>
+        <p:nvSpPr>
+          <p:cNvPr id="15" name="Rectangle: Rounded Corners 14">
+            <a:extLst>
+              <a:ext uri="{FF2B5EF4-FFF2-40B4-BE49-F238E27FC236}">
+                <a16:creationId xmlns:a16="http://schemas.microsoft.com/office/drawing/2014/main" id="{65A782FF-BA00-27A1-F4B9-EE6D98ABE094}"/>
+              </a:ext>
+            </a:extLst>
+          </p:cNvPr>
+          <p:cNvSpPr/>
+          <p:nvPr/>
+        </p:nvSpPr>
+        <p:spPr>
+          <a:xfrm>
+            <a:off x="669927" y="4083862"/>
+            <a:ext cx="1153235" cy="206256"/>
+          </a:xfrm>
+          <a:prstGeom prst="roundRect">
+            <a:avLst/>
+          </a:prstGeom>
+          <a:noFill/>
+          <a:ln>
+            <a:solidFill>
+              <a:srgbClr val="C00000"/>
+            </a:solidFill>
+          </a:ln>
+        </p:spPr>
+        <p:style>
+          <a:lnRef idx="2">
+            <a:schemeClr val="accent1">
+              <a:shade val="15000"/>
+            </a:schemeClr>
+          </a:lnRef>
+          <a:fillRef idx="1">
+            <a:schemeClr val="accent1"/>
+          </a:fillRef>
+          <a:effectRef idx="0">
+            <a:schemeClr val="accent1"/>
+          </a:effectRef>
+          <a:fontRef idx="minor">
+            <a:schemeClr val="lt1"/>
+          </a:fontRef>
+        </p:style>
+        <p:txBody>
+          <a:bodyPr rtlCol="0" anchor="ctr"/>
+          <a:lstStyle/>
+          <a:p>
+            <a:pPr algn="ctr"/>
+            <a:endParaRPr lang="pt-PT"/>
+          </a:p>
+        </p:txBody>
+      </p:sp>
+      <p:pic>
+        <p:nvPicPr>
+          <p:cNvPr id="17" name="Picture 16">
+            <a:extLst>
+              <a:ext uri="{FF2B5EF4-FFF2-40B4-BE49-F238E27FC236}">
+                <a16:creationId xmlns:a16="http://schemas.microsoft.com/office/drawing/2014/main" id="{5A189844-8582-DCE9-6B9F-3C4EBB496620}"/>
+              </a:ext>
+            </a:extLst>
+          </p:cNvPr>
+          <p:cNvPicPr>
+            <a:picLocks noChangeAspect="1"/>
+          </p:cNvPicPr>
+          <p:nvPr/>
+        </p:nvPicPr>
+        <p:blipFill>
+          <a:blip r:embed="rId7"/>
+          <a:stretch>
+            <a:fillRect/>
+          </a:stretch>
+        </p:blipFill>
+        <p:spPr>
+          <a:xfrm>
+            <a:off x="3556885" y="2273286"/>
+            <a:ext cx="3203229" cy="3306006"/>
+          </a:xfrm>
+          <a:prstGeom prst="rect">
+            <a:avLst/>
+          </a:prstGeom>
+        </p:spPr>
+      </p:pic>
+    </p:spTree>
+    <p:extLst>
+      <p:ext uri="{BB962C8B-B14F-4D97-AF65-F5344CB8AC3E}">
+        <p14:creationId xmlns:p14="http://schemas.microsoft.com/office/powerpoint/2010/main" val="3898382547"/>
+      </p:ext>
+    </p:extLst>
+  </p:cSld>
+  <p:clrMapOvr>
+    <a:masterClrMapping/>
+  </p:clrMapOvr>
+</p:sld>
+</file>
+
+<file path=ppt/slides/slide8.xml><?xml version="1.0" encoding="utf-8"?>
+<p:sld xmlns:a="http://schemas.openxmlformats.org/drawingml/2006/main" xmlns:r="http://schemas.openxmlformats.org/officeDocument/2006/relationships" xmlns:p="http://schemas.openxmlformats.org/presentationml/2006/main">
+  <p:cSld>
+    <p:spTree>
+      <p:nvGrpSpPr>
+        <p:cNvPr id="1" name="">
+          <a:extLst>
+            <a:ext uri="{FF2B5EF4-FFF2-40B4-BE49-F238E27FC236}">
+              <a16:creationId xmlns:a16="http://schemas.microsoft.com/office/drawing/2014/main" id="{00529CBD-B49A-3084-90F3-0D7834C0EE96}"/>
+            </a:ext>
+          </a:extLst>
+        </p:cNvPr>
+        <p:cNvGrpSpPr/>
+        <p:nvPr/>
+      </p:nvGrpSpPr>
+      <p:grpSpPr>
+        <a:xfrm>
+          <a:off x="0" y="0"/>
+          <a:ext cx="0" cy="0"/>
+          <a:chOff x="0" y="0"/>
+          <a:chExt cx="0" cy="0"/>
+        </a:xfrm>
+      </p:grpSpPr>
+      <p:pic>
+        <p:nvPicPr>
+          <p:cNvPr id="17" name="Picture 16">
+            <a:extLst>
+              <a:ext uri="{FF2B5EF4-FFF2-40B4-BE49-F238E27FC236}">
+                <a16:creationId xmlns:a16="http://schemas.microsoft.com/office/drawing/2014/main" id="{FED5154D-8E9B-10D4-6458-6DA83132A5EB}"/>
+              </a:ext>
+            </a:extLst>
+          </p:cNvPr>
+          <p:cNvPicPr>
+            <a:picLocks noChangeAspect="1"/>
+          </p:cNvPicPr>
+          <p:nvPr/>
+        </p:nvPicPr>
+        <p:blipFill>
+          <a:blip r:embed="rId3"/>
+          <a:srcRect b="6189"/>
+          <a:stretch>
+            <a:fillRect/>
+          </a:stretch>
+        </p:blipFill>
+        <p:spPr>
+          <a:xfrm>
+            <a:off x="318096" y="2100727"/>
+            <a:ext cx="3738265" cy="3619430"/>
+          </a:xfrm>
+          <a:prstGeom prst="rect">
+            <a:avLst/>
+          </a:prstGeom>
+        </p:spPr>
+      </p:pic>
+      <p:sp>
+        <p:nvSpPr>
+          <p:cNvPr id="7" name="TextBox 6">
+            <a:extLst>
+              <a:ext uri="{FF2B5EF4-FFF2-40B4-BE49-F238E27FC236}">
+                <a16:creationId xmlns:a16="http://schemas.microsoft.com/office/drawing/2014/main" id="{D3A9C648-9C0B-7C69-C62D-C0C5D02E6B31}"/>
+              </a:ext>
+            </a:extLst>
+          </p:cNvPr>
+          <p:cNvSpPr txBox="1"/>
+          <p:nvPr/>
+        </p:nvSpPr>
+        <p:spPr>
+          <a:xfrm>
+            <a:off x="318096" y="0"/>
+            <a:ext cx="11555807" cy="584775"/>
+          </a:xfrm>
+          <a:prstGeom prst="rect">
+            <a:avLst/>
+          </a:prstGeom>
+          <a:noFill/>
+        </p:spPr>
+        <p:txBody>
+          <a:bodyPr wrap="square" rtlCol="0">
+            <a:spAutoFit/>
+          </a:bodyPr>
+          <a:lstStyle/>
+          <a:p>
+            <a:r>
+              <a:rPr lang="en-GB" sz="3200" b="1" noProof="0" dirty="0">
+                <a:solidFill>
+                  <a:schemeClr val="bg1"/>
+                </a:solidFill>
+                <a:latin typeface="Cambria" panose="02040503050406030204" pitchFamily="18" charset="0"/>
+                <a:ea typeface="Cambria" panose="02040503050406030204" pitchFamily="18" charset="0"/>
+                <a:cs typeface="Times New Roman" panose="02020603050405020304" pitchFamily="18" charset="0"/>
+              </a:rPr>
+              <a:t>Course Material</a:t>
+            </a:r>
+          </a:p>
+        </p:txBody>
+      </p:sp>
+      <p:sp>
+        <p:nvSpPr>
+          <p:cNvPr id="13" name="TextBox 12">
+            <a:extLst>
+              <a:ext uri="{FF2B5EF4-FFF2-40B4-BE49-F238E27FC236}">
+                <a16:creationId xmlns:a16="http://schemas.microsoft.com/office/drawing/2014/main" id="{A2E1476E-12F5-E3E6-D696-3BCB301EE6FA}"/>
+              </a:ext>
+            </a:extLst>
+          </p:cNvPr>
+          <p:cNvSpPr txBox="1"/>
+          <p:nvPr/>
+        </p:nvSpPr>
+        <p:spPr>
+          <a:xfrm>
+            <a:off x="222111" y="800107"/>
+            <a:ext cx="11747779" cy="1039452"/>
+          </a:xfrm>
+          <a:prstGeom prst="rect">
+            <a:avLst/>
+          </a:prstGeom>
+          <a:noFill/>
+        </p:spPr>
+        <p:txBody>
+          <a:bodyPr wrap="square" rtlCol="0">
+            <a:spAutoFit/>
+          </a:bodyPr>
+          <a:lstStyle/>
+          <a:p>
+            <a:pPr algn="ctr">
+              <a:lnSpc>
+                <a:spcPct val="150000"/>
+              </a:lnSpc>
+            </a:pPr>
+            <a:r>
+              <a:rPr lang="en-GB" sz="2000" b="1" dirty="0">
+                <a:latin typeface="Cambria" panose="02040503050406030204" pitchFamily="18" charset="0"/>
+                <a:ea typeface="Cambria" panose="02040503050406030204" pitchFamily="18" charset="0"/>
+                <a:hlinkClick r:id="rId4"/>
+              </a:rPr>
+              <a:t>https://github.com/andrebolerbarros/Intro_R</a:t>
+            </a:r>
+            <a:endParaRPr lang="en-GB" sz="2000" b="1" dirty="0">
+              <a:latin typeface="Cambria" panose="02040503050406030204" pitchFamily="18" charset="0"/>
+              <a:ea typeface="Cambria" panose="02040503050406030204" pitchFamily="18" charset="0"/>
+            </a:endParaRPr>
+          </a:p>
+          <a:p>
+            <a:pPr marL="285750" indent="-285750" algn="just">
+              <a:lnSpc>
+                <a:spcPct val="150000"/>
+              </a:lnSpc>
+              <a:buFont typeface="Arial" panose="020B0604020202020204" pitchFamily="34" charset="0"/>
+              <a:buChar char="•"/>
+            </a:pPr>
+            <a:endParaRPr lang="en-GB" sz="2400" b="1" dirty="0">
+              <a:latin typeface="Cambria" panose="02040503050406030204" pitchFamily="18" charset="0"/>
+              <a:ea typeface="Cambria" panose="02040503050406030204" pitchFamily="18" charset="0"/>
+            </a:endParaRPr>
+          </a:p>
+        </p:txBody>
+      </p:sp>
+      <p:pic>
+        <p:nvPicPr>
+          <p:cNvPr id="9" name="Picture 8" descr="A white circle with black background&#10;&#10;Description automatically generated">
+            <a:extLst>
+              <a:ext uri="{FF2B5EF4-FFF2-40B4-BE49-F238E27FC236}">
+                <a16:creationId xmlns:a16="http://schemas.microsoft.com/office/drawing/2014/main" id="{E905D286-EE0C-C040-92B8-B2B74CB328E1}"/>
+              </a:ext>
+            </a:extLst>
+          </p:cNvPr>
+          <p:cNvPicPr>
+            <a:picLocks noChangeAspect="1"/>
+          </p:cNvPicPr>
+          <p:nvPr/>
+        </p:nvPicPr>
+        <p:blipFill>
+          <a:blip r:embed="rId5"/>
+          <a:srcRect t="19605" r="16255" b="22685"/>
+          <a:stretch>
+            <a:fillRect/>
+          </a:stretch>
+        </p:blipFill>
+        <p:spPr>
+          <a:xfrm>
+            <a:off x="-269926" y="6222582"/>
+            <a:ext cx="939853" cy="628211"/>
+          </a:xfrm>
+          <a:prstGeom prst="rect">
+            <a:avLst/>
+          </a:prstGeom>
+        </p:spPr>
+      </p:pic>
+      <p:cxnSp>
+        <p:nvCxnSpPr>
+          <p:cNvPr id="10" name="Straight Connector 9">
+            <a:extLst>
+              <a:ext uri="{FF2B5EF4-FFF2-40B4-BE49-F238E27FC236}">
+                <a16:creationId xmlns:a16="http://schemas.microsoft.com/office/drawing/2014/main" id="{8F78C4AE-9417-F1DA-86EB-39253672D1B4}"/>
+              </a:ext>
+            </a:extLst>
+          </p:cNvPr>
+          <p:cNvCxnSpPr>
+            <a:cxnSpLocks/>
+          </p:cNvCxnSpPr>
+          <p:nvPr/>
+        </p:nvCxnSpPr>
+        <p:spPr>
+          <a:xfrm flipV="1">
+            <a:off x="669927" y="6523348"/>
+            <a:ext cx="10580947" cy="1"/>
+          </a:xfrm>
+          <a:prstGeom prst="line">
+            <a:avLst/>
+          </a:prstGeom>
+          <a:ln>
+            <a:solidFill>
+              <a:schemeClr val="bg1"/>
+            </a:solidFill>
+          </a:ln>
+        </p:spPr>
+        <p:style>
+          <a:lnRef idx="1">
+            <a:schemeClr val="dk1"/>
+          </a:lnRef>
+          <a:fillRef idx="0">
+            <a:schemeClr val="dk1"/>
+          </a:fillRef>
+          <a:effectRef idx="0">
+            <a:schemeClr val="dk1"/>
+          </a:effectRef>
+          <a:fontRef idx="minor">
+            <a:schemeClr val="tx1"/>
+          </a:fontRef>
+        </p:style>
+      </p:cxnSp>
+      <p:sp>
+        <p:nvSpPr>
+          <p:cNvPr id="11" name="Slide Number Placeholder 2">
+            <a:extLst>
+              <a:ext uri="{FF2B5EF4-FFF2-40B4-BE49-F238E27FC236}">
+                <a16:creationId xmlns:a16="http://schemas.microsoft.com/office/drawing/2014/main" id="{A5B35666-5ACA-145A-137C-488E3DF30EF3}"/>
+              </a:ext>
+            </a:extLst>
+          </p:cNvPr>
+          <p:cNvSpPr txBox="1">
+            <a:spLocks/>
+          </p:cNvSpPr>
+          <p:nvPr/>
+        </p:nvSpPr>
+        <p:spPr>
+          <a:xfrm>
+            <a:off x="8804750" y="6337394"/>
+            <a:ext cx="2825475" cy="365125"/>
+          </a:xfrm>
+          <a:prstGeom prst="rect">
+            <a:avLst/>
+          </a:prstGeom>
+        </p:spPr>
+        <p:txBody>
+          <a:bodyPr vert="horz" lIns="91440" tIns="45720" rIns="91440" bIns="45720" rtlCol="0" anchor="ctr"/>
+          <a:lstStyle>
+            <a:defPPr>
+              <a:defRPr lang="en-US"/>
+            </a:defPPr>
+            <a:lvl1pPr marL="0" algn="r" defTabSz="914400" rtl="0" eaLnBrk="1" latinLnBrk="0" hangingPunct="1">
+              <a:defRPr sz="1200" kern="1200">
+                <a:solidFill>
+                  <a:schemeClr val="tx1">
+                    <a:tint val="75000"/>
+                  </a:schemeClr>
+                </a:solidFill>
+                <a:latin typeface="+mn-lt"/>
+                <a:ea typeface="+mn-ea"/>
+                <a:cs typeface="+mn-cs"/>
+              </a:defRPr>
+            </a:lvl1pPr>
+            <a:lvl2pPr marL="457200" algn="l" defTabSz="914400" rtl="0" eaLnBrk="1" latinLnBrk="0" hangingPunct="1">
+              <a:defRPr sz="1800" kern="1200">
+                <a:solidFill>
+                  <a:schemeClr val="tx1"/>
+                </a:solidFill>
+                <a:latin typeface="+mn-lt"/>
+                <a:ea typeface="+mn-ea"/>
+                <a:cs typeface="+mn-cs"/>
+              </a:defRPr>
+            </a:lvl2pPr>
+            <a:lvl3pPr marL="914400" algn="l" defTabSz="914400" rtl="0" eaLnBrk="1" latinLnBrk="0" hangingPunct="1">
+              <a:defRPr sz="1800" kern="1200">
+                <a:solidFill>
+                  <a:schemeClr val="tx1"/>
+                </a:solidFill>
+                <a:latin typeface="+mn-lt"/>
+                <a:ea typeface="+mn-ea"/>
+                <a:cs typeface="+mn-cs"/>
+              </a:defRPr>
+            </a:lvl3pPr>
+            <a:lvl4pPr marL="1371600" algn="l" defTabSz="914400" rtl="0" eaLnBrk="1" latinLnBrk="0" hangingPunct="1">
+              <a:defRPr sz="1800" kern="1200">
+                <a:solidFill>
+                  <a:schemeClr val="tx1"/>
+                </a:solidFill>
+                <a:latin typeface="+mn-lt"/>
+                <a:ea typeface="+mn-ea"/>
+                <a:cs typeface="+mn-cs"/>
+              </a:defRPr>
+            </a:lvl4pPr>
+            <a:lvl5pPr marL="1828800" algn="l" defTabSz="914400" rtl="0" eaLnBrk="1" latinLnBrk="0" hangingPunct="1">
+              <a:defRPr sz="1800" kern="1200">
+                <a:solidFill>
+                  <a:schemeClr val="tx1"/>
+                </a:solidFill>
+                <a:latin typeface="+mn-lt"/>
+                <a:ea typeface="+mn-ea"/>
+                <a:cs typeface="+mn-cs"/>
+              </a:defRPr>
+            </a:lvl5pPr>
+            <a:lvl6pPr marL="2286000" algn="l" defTabSz="914400" rtl="0" eaLnBrk="1" latinLnBrk="0" hangingPunct="1">
+              <a:defRPr sz="1800" kern="1200">
+                <a:solidFill>
+                  <a:schemeClr val="tx1"/>
+                </a:solidFill>
+                <a:latin typeface="+mn-lt"/>
+                <a:ea typeface="+mn-ea"/>
+                <a:cs typeface="+mn-cs"/>
+              </a:defRPr>
+            </a:lvl6pPr>
+            <a:lvl7pPr marL="2743200" algn="l" defTabSz="914400" rtl="0" eaLnBrk="1" latinLnBrk="0" hangingPunct="1">
+              <a:defRPr sz="1800" kern="1200">
+                <a:solidFill>
+                  <a:schemeClr val="tx1"/>
+                </a:solidFill>
+                <a:latin typeface="+mn-lt"/>
+                <a:ea typeface="+mn-ea"/>
+                <a:cs typeface="+mn-cs"/>
+              </a:defRPr>
+            </a:lvl7pPr>
+            <a:lvl8pPr marL="3200400" algn="l" defTabSz="914400" rtl="0" eaLnBrk="1" latinLnBrk="0" hangingPunct="1">
+              <a:defRPr sz="1800" kern="1200">
+                <a:solidFill>
+                  <a:schemeClr val="tx1"/>
+                </a:solidFill>
+                <a:latin typeface="+mn-lt"/>
+                <a:ea typeface="+mn-ea"/>
+                <a:cs typeface="+mn-cs"/>
+              </a:defRPr>
+            </a:lvl8pPr>
+            <a:lvl9pPr marL="3657600" algn="l" defTabSz="914400" rtl="0" eaLnBrk="1" latinLnBrk="0" hangingPunct="1">
+              <a:defRPr sz="1800" kern="1200">
+                <a:solidFill>
+                  <a:schemeClr val="tx1"/>
+                </a:solidFill>
+                <a:latin typeface="+mn-lt"/>
+                <a:ea typeface="+mn-ea"/>
+                <a:cs typeface="+mn-cs"/>
+              </a:defRPr>
+            </a:lvl9pPr>
+          </a:lstStyle>
+          <a:p>
+            <a:fld id="{54B21BD1-F593-4F4E-86E9-52991719DFB8}" type="slidenum">
+              <a:rPr lang="en-GB" sz="1400" noProof="0" smtClean="0">
+                <a:solidFill>
+                  <a:schemeClr val="bg1"/>
+                </a:solidFill>
+                <a:latin typeface="Cambria" panose="02040503050406030204" pitchFamily="18" charset="0"/>
+                <a:ea typeface="Cambria" panose="02040503050406030204" pitchFamily="18" charset="0"/>
+              </a:rPr>
+              <a:pPr/>
+              <a:t>8</a:t>
+            </a:fld>
+            <a:endParaRPr lang="en-GB" sz="1400" noProof="0" dirty="0">
+              <a:solidFill>
+                <a:schemeClr val="bg1"/>
+              </a:solidFill>
+              <a:latin typeface="Cambria" panose="02040503050406030204" pitchFamily="18" charset="0"/>
+              <a:ea typeface="Cambria" panose="02040503050406030204" pitchFamily="18" charset="0"/>
+            </a:endParaRPr>
+          </a:p>
+        </p:txBody>
+      </p:sp>
+      <p:sp>
+        <p:nvSpPr>
+          <p:cNvPr id="12" name="TextBox 11">
+            <a:extLst>
+              <a:ext uri="{FF2B5EF4-FFF2-40B4-BE49-F238E27FC236}">
+                <a16:creationId xmlns:a16="http://schemas.microsoft.com/office/drawing/2014/main" id="{EA75DBE1-F078-0DA9-4E9E-0394D868FED0}"/>
+              </a:ext>
+            </a:extLst>
+          </p:cNvPr>
+          <p:cNvSpPr txBox="1"/>
+          <p:nvPr/>
+        </p:nvSpPr>
+        <p:spPr>
+          <a:xfrm>
+            <a:off x="3870960" y="6451133"/>
+            <a:ext cx="4450080" cy="335092"/>
+          </a:xfrm>
+          <a:prstGeom prst="rect">
+            <a:avLst/>
+          </a:prstGeom>
+          <a:noFill/>
+        </p:spPr>
+        <p:txBody>
+          <a:bodyPr wrap="square" rtlCol="0">
+            <a:spAutoFit/>
+          </a:bodyPr>
+          <a:lstStyle/>
+          <a:p>
+            <a:pPr defTabSz="825500">
+              <a:lnSpc>
+                <a:spcPct val="150000"/>
+              </a:lnSpc>
+              <a:tabLst>
+                <a:tab pos="3768725" algn="l"/>
+                <a:tab pos="4572000" algn="l"/>
+              </a:tabLst>
+            </a:pPr>
+            <a:r>
+              <a:rPr lang="en-GB" sz="1200" noProof="0" dirty="0">
+                <a:solidFill>
+                  <a:schemeClr val="bg1"/>
+                </a:solidFill>
+                <a:latin typeface="Cambria" panose="02040503050406030204" pitchFamily="18" charset="0"/>
+                <a:ea typeface="Cambria" panose="02040503050406030204" pitchFamily="18" charset="0"/>
+                <a:cs typeface="Times New Roman" panose="02020603050405020304" pitchFamily="18" charset="0"/>
+              </a:rPr>
+              <a:t>André Barros | Advanced Data Analysis | 12th January 2026</a:t>
+            </a:r>
+            <a:endParaRPr lang="en-GB" sz="1200" i="1" noProof="0" dirty="0">
+              <a:solidFill>
+                <a:schemeClr val="bg1"/>
+              </a:solidFill>
+              <a:latin typeface="Cambria" panose="02040503050406030204" pitchFamily="18" charset="0"/>
+              <a:ea typeface="Cambria" panose="02040503050406030204" pitchFamily="18" charset="0"/>
+              <a:cs typeface="Times New Roman" panose="02020603050405020304" pitchFamily="18" charset="0"/>
+            </a:endParaRPr>
+          </a:p>
+        </p:txBody>
+      </p:sp>
+      <p:pic>
+        <p:nvPicPr>
+          <p:cNvPr id="14" name="Picture 13">
+            <a:extLst>
+              <a:ext uri="{FF2B5EF4-FFF2-40B4-BE49-F238E27FC236}">
+                <a16:creationId xmlns:a16="http://schemas.microsoft.com/office/drawing/2014/main" id="{9350AA1C-B10F-C701-8C08-C1EBF0415725}"/>
+              </a:ext>
+            </a:extLst>
+          </p:cNvPr>
+          <p:cNvPicPr>
+            <a:picLocks noChangeAspect="1"/>
+          </p:cNvPicPr>
+          <p:nvPr/>
+        </p:nvPicPr>
+        <p:blipFill>
+          <a:blip r:embed="rId6"/>
+          <a:srcRect l="22765" t="18648" r="25605" b="15789"/>
+          <a:stretch>
+            <a:fillRect/>
+          </a:stretch>
+        </p:blipFill>
+        <p:spPr>
+          <a:xfrm>
+            <a:off x="11581065" y="6281675"/>
+            <a:ext cx="425229" cy="540000"/>
+          </a:xfrm>
+          <a:prstGeom prst="rect">
+            <a:avLst/>
+          </a:prstGeom>
+        </p:spPr>
+      </p:pic>
+      <p:sp>
+        <p:nvSpPr>
+          <p:cNvPr id="4" name="TextBox 3">
+            <a:extLst>
+              <a:ext uri="{FF2B5EF4-FFF2-40B4-BE49-F238E27FC236}">
+                <a16:creationId xmlns:a16="http://schemas.microsoft.com/office/drawing/2014/main" id="{B1EEA1FE-0E17-6AD1-2AFA-014911C1B9A6}"/>
+              </a:ext>
+            </a:extLst>
+          </p:cNvPr>
+          <p:cNvSpPr txBox="1"/>
+          <p:nvPr/>
+        </p:nvSpPr>
+        <p:spPr>
+          <a:xfrm>
+            <a:off x="222110" y="1529798"/>
+            <a:ext cx="11747779" cy="456472"/>
+          </a:xfrm>
+          <a:prstGeom prst="rect">
+            <a:avLst/>
+          </a:prstGeom>
+          <a:noFill/>
+        </p:spPr>
+        <p:txBody>
+          <a:bodyPr wrap="square" rtlCol="0">
+            <a:spAutoFit/>
+          </a:bodyPr>
+          <a:lstStyle/>
+          <a:p>
+            <a:pPr algn="just">
+              <a:lnSpc>
+                <a:spcPct val="150000"/>
+              </a:lnSpc>
+              <a:tabLst>
+                <a:tab pos="447675" algn="l"/>
+              </a:tabLst>
+            </a:pPr>
+            <a:r>
+              <a:rPr lang="en-GB" dirty="0">
+                <a:latin typeface="Cambria" panose="02040503050406030204" pitchFamily="18" charset="0"/>
+                <a:ea typeface="Cambria" panose="02040503050406030204" pitchFamily="18" charset="0"/>
+              </a:rPr>
+              <a:t>3.	Change kernel (language)</a:t>
+            </a:r>
+            <a:endParaRPr lang="en-GB" sz="2400" b="1" dirty="0">
+              <a:latin typeface="Cambria" panose="02040503050406030204" pitchFamily="18" charset="0"/>
+              <a:ea typeface="Cambria" panose="02040503050406030204" pitchFamily="18" charset="0"/>
+            </a:endParaRPr>
+          </a:p>
+        </p:txBody>
+      </p:sp>
+      <p:sp>
+        <p:nvSpPr>
+          <p:cNvPr id="15" name="Rectangle: Rounded Corners 14">
+            <a:extLst>
+              <a:ext uri="{FF2B5EF4-FFF2-40B4-BE49-F238E27FC236}">
+                <a16:creationId xmlns:a16="http://schemas.microsoft.com/office/drawing/2014/main" id="{6478EFC7-F045-7079-8000-5B1307E810E4}"/>
+              </a:ext>
+            </a:extLst>
+          </p:cNvPr>
+          <p:cNvSpPr/>
+          <p:nvPr/>
+        </p:nvSpPr>
+        <p:spPr>
+          <a:xfrm>
+            <a:off x="1879960" y="4441372"/>
+            <a:ext cx="1153235" cy="206256"/>
+          </a:xfrm>
+          <a:prstGeom prst="roundRect">
+            <a:avLst/>
+          </a:prstGeom>
+          <a:noFill/>
+          <a:ln>
+            <a:solidFill>
+              <a:srgbClr val="C00000"/>
+            </a:solidFill>
+          </a:ln>
+        </p:spPr>
+        <p:style>
+          <a:lnRef idx="2">
+            <a:schemeClr val="accent1">
+              <a:shade val="15000"/>
+            </a:schemeClr>
+          </a:lnRef>
+          <a:fillRef idx="1">
+            <a:schemeClr val="accent1"/>
+          </a:fillRef>
+          <a:effectRef idx="0">
+            <a:schemeClr val="accent1"/>
+          </a:effectRef>
+          <a:fontRef idx="minor">
+            <a:schemeClr val="lt1"/>
+          </a:fontRef>
+        </p:style>
+        <p:txBody>
+          <a:bodyPr rtlCol="0" anchor="ctr"/>
+          <a:lstStyle/>
+          <a:p>
+            <a:pPr algn="ctr"/>
+            <a:endParaRPr lang="pt-PT"/>
+          </a:p>
+        </p:txBody>
+      </p:sp>
+      <p:pic>
+        <p:nvPicPr>
+          <p:cNvPr id="3" name="Picture 2">
+            <a:extLst>
+              <a:ext uri="{FF2B5EF4-FFF2-40B4-BE49-F238E27FC236}">
+                <a16:creationId xmlns:a16="http://schemas.microsoft.com/office/drawing/2014/main" id="{EAC31A07-C2E3-BA9B-D4A0-5DFF260C4AC0}"/>
+              </a:ext>
+            </a:extLst>
+          </p:cNvPr>
+          <p:cNvPicPr>
+            <a:picLocks noChangeAspect="1"/>
+          </p:cNvPicPr>
+          <p:nvPr/>
+        </p:nvPicPr>
+        <p:blipFill>
+          <a:blip r:embed="rId7"/>
+          <a:srcRect b="13023"/>
+          <a:stretch>
+            <a:fillRect/>
+          </a:stretch>
+        </p:blipFill>
+        <p:spPr>
+          <a:xfrm>
+            <a:off x="4249744" y="2100727"/>
+            <a:ext cx="3092693" cy="2450647"/>
+          </a:xfrm>
+          <a:prstGeom prst="rect">
+            <a:avLst/>
+          </a:prstGeom>
+        </p:spPr>
+      </p:pic>
+      <p:sp>
+        <p:nvSpPr>
+          <p:cNvPr id="5" name="Rectangle: Rounded Corners 4">
+            <a:extLst>
+              <a:ext uri="{FF2B5EF4-FFF2-40B4-BE49-F238E27FC236}">
+                <a16:creationId xmlns:a16="http://schemas.microsoft.com/office/drawing/2014/main" id="{3AF94B33-A8EB-1EDE-6D11-70FD40963897}"/>
+              </a:ext>
+            </a:extLst>
+          </p:cNvPr>
+          <p:cNvSpPr/>
+          <p:nvPr/>
+        </p:nvSpPr>
+        <p:spPr>
+          <a:xfrm>
+            <a:off x="4321798" y="2554884"/>
+            <a:ext cx="1240229" cy="377153"/>
+          </a:xfrm>
+          <a:prstGeom prst="roundRect">
+            <a:avLst/>
+          </a:prstGeom>
+          <a:noFill/>
+          <a:ln>
+            <a:solidFill>
+              <a:srgbClr val="C00000"/>
+            </a:solidFill>
+          </a:ln>
+        </p:spPr>
+        <p:style>
+          <a:lnRef idx="2">
+            <a:schemeClr val="accent1">
+              <a:shade val="15000"/>
+            </a:schemeClr>
+          </a:lnRef>
+          <a:fillRef idx="1">
+            <a:schemeClr val="accent1"/>
+          </a:fillRef>
+          <a:effectRef idx="0">
+            <a:schemeClr val="accent1"/>
+          </a:effectRef>
+          <a:fontRef idx="minor">
+            <a:schemeClr val="lt1"/>
+          </a:fontRef>
+        </p:style>
+        <p:txBody>
+          <a:bodyPr rtlCol="0" anchor="ctr"/>
+          <a:lstStyle/>
+          <a:p>
+            <a:pPr algn="ctr"/>
+            <a:endParaRPr lang="pt-PT"/>
+          </a:p>
+        </p:txBody>
+      </p:sp>
+    </p:spTree>
+    <p:extLst>
+      <p:ext uri="{BB962C8B-B14F-4D97-AF65-F5344CB8AC3E}">
+        <p14:creationId xmlns:p14="http://schemas.microsoft.com/office/powerpoint/2010/main" val="3811760795"/>
       </p:ext>
     </p:extLst>
   </p:cSld>

</xml_diff>

<commit_message>
Changed day 1 notebooks
</commit_message>
<xml_diff>
--- a/presentations/Intro_R_Session1.pptx
+++ b/presentations/Intro_R_Session1.pptx
@@ -5,17 +5,19 @@
     <p:sldMasterId id="2147483648" r:id="rId1"/>
   </p:sldMasterIdLst>
   <p:notesMasterIdLst>
-    <p:notesMasterId r:id="rId10"/>
+    <p:notesMasterId r:id="rId12"/>
   </p:notesMasterIdLst>
   <p:sldIdLst>
     <p:sldId id="289" r:id="rId2"/>
     <p:sldId id="878" r:id="rId3"/>
     <p:sldId id="879" r:id="rId4"/>
     <p:sldId id="880" r:id="rId5"/>
-    <p:sldId id="881" r:id="rId6"/>
-    <p:sldId id="882" r:id="rId7"/>
-    <p:sldId id="883" r:id="rId8"/>
-    <p:sldId id="884" r:id="rId9"/>
+    <p:sldId id="885" r:id="rId6"/>
+    <p:sldId id="886" r:id="rId7"/>
+    <p:sldId id="881" r:id="rId8"/>
+    <p:sldId id="882" r:id="rId9"/>
+    <p:sldId id="883" r:id="rId10"/>
+    <p:sldId id="884" r:id="rId11"/>
   </p:sldIdLst>
   <p:sldSz cx="12192000" cy="6858000"/>
   <p:notesSz cx="6858000" cy="9144000"/>
@@ -125,7 +127,7 @@
 <file path=ppt/revisionInfo.xml><?xml version="1.0" encoding="utf-8"?>
 <p1510:revInfo xmlns:a="http://schemas.openxmlformats.org/drawingml/2006/main" xmlns:r="http://schemas.openxmlformats.org/officeDocument/2006/relationships" xmlns:p1510="http://schemas.microsoft.com/office/powerpoint/2015/10/main">
   <p1510:revLst>
-    <p1510:client id="{80CB159F-E254-4E56-A497-3660E959EAF4}" v="14" dt="2026-01-12T09:54:29.274"/>
+    <p1510:client id="{80CB159F-E254-4E56-A497-3660E959EAF4}" v="35" dt="2026-01-12T10:27:10.092"/>
   </p1510:revLst>
 </p1510:revInfo>
 </file>
@@ -135,7 +137,7 @@
   <pc:docChgLst>
     <pc:chgData name="André Boler Cláudio da Silva Barros" userId="6a6e06a7-71d6-4753-8f49-a25f8eb0dc15" providerId="ADAL" clId="{6BE99AA9-1EEE-46D3-8261-83B0B634593B}"/>
     <pc:docChg chg="undo custSel addSld delSld modSld">
-      <pc:chgData name="André Boler Cláudio da Silva Barros" userId="6a6e06a7-71d6-4753-8f49-a25f8eb0dc15" providerId="ADAL" clId="{6BE99AA9-1EEE-46D3-8261-83B0B634593B}" dt="2026-01-12T09:54:40.856" v="1293" actId="1036"/>
+      <pc:chgData name="André Boler Cláudio da Silva Barros" userId="6a6e06a7-71d6-4753-8f49-a25f8eb0dc15" providerId="ADAL" clId="{6BE99AA9-1EEE-46D3-8261-83B0B634593B}" dt="2026-01-12T10:27:38.635" v="1706" actId="1076"/>
       <pc:docMkLst>
         <pc:docMk/>
       </pc:docMkLst>
@@ -486,6 +488,164 @@
           <pc:sldMk cId="19988374" sldId="885"/>
         </pc:sldMkLst>
       </pc:sldChg>
+      <pc:sldChg chg="addSp modSp add mod">
+        <pc:chgData name="André Boler Cláudio da Silva Barros" userId="6a6e06a7-71d6-4753-8f49-a25f8eb0dc15" providerId="ADAL" clId="{6BE99AA9-1EEE-46D3-8261-83B0B634593B}" dt="2026-01-12T10:21:27.063" v="1622" actId="1076"/>
+        <pc:sldMkLst>
+          <pc:docMk/>
+          <pc:sldMk cId="357586254" sldId="885"/>
+        </pc:sldMkLst>
+        <pc:spChg chg="add">
+          <ac:chgData name="André Boler Cláudio da Silva Barros" userId="6a6e06a7-71d6-4753-8f49-a25f8eb0dc15" providerId="ADAL" clId="{6BE99AA9-1EEE-46D3-8261-83B0B634593B}" dt="2026-01-12T10:16:59.825" v="1591"/>
+          <ac:spMkLst>
+            <pc:docMk/>
+            <pc:sldMk cId="357586254" sldId="885"/>
+            <ac:spMk id="2" creationId="{17629356-FE8C-3616-76B8-21B8513F2BDC}"/>
+          </ac:spMkLst>
+        </pc:spChg>
+        <pc:spChg chg="mod">
+          <ac:chgData name="André Boler Cláudio da Silva Barros" userId="6a6e06a7-71d6-4753-8f49-a25f8eb0dc15" providerId="ADAL" clId="{6BE99AA9-1EEE-46D3-8261-83B0B634593B}" dt="2026-01-12T10:11:07.295" v="1299" actId="20577"/>
+          <ac:spMkLst>
+            <pc:docMk/>
+            <pc:sldMk cId="357586254" sldId="885"/>
+            <ac:spMk id="7" creationId="{2CBD5C0E-B191-89ED-BF68-0C52AA475FB8}"/>
+          </ac:spMkLst>
+        </pc:spChg>
+        <pc:spChg chg="mod">
+          <ac:chgData name="André Boler Cláudio da Silva Barros" userId="6a6e06a7-71d6-4753-8f49-a25f8eb0dc15" providerId="ADAL" clId="{6BE99AA9-1EEE-46D3-8261-83B0B634593B}" dt="2026-01-12T10:16:46.236" v="1590" actId="20577"/>
+          <ac:spMkLst>
+            <pc:docMk/>
+            <pc:sldMk cId="357586254" sldId="885"/>
+            <ac:spMk id="13" creationId="{15F6DF6B-565A-2C86-7804-F86B08013386}"/>
+          </ac:spMkLst>
+        </pc:spChg>
+        <pc:grpChg chg="add mod">
+          <ac:chgData name="André Boler Cláudio da Silva Barros" userId="6a6e06a7-71d6-4753-8f49-a25f8eb0dc15" providerId="ADAL" clId="{6BE99AA9-1EEE-46D3-8261-83B0B634593B}" dt="2026-01-12T10:19:10.530" v="1619" actId="12789"/>
+          <ac:grpSpMkLst>
+            <pc:docMk/>
+            <pc:sldMk cId="357586254" sldId="885"/>
+            <ac:grpSpMk id="6" creationId="{E6E2C7C7-18F0-DC25-8049-76CD99F76829}"/>
+          </ac:grpSpMkLst>
+        </pc:grpChg>
+        <pc:picChg chg="add mod modCrop">
+          <ac:chgData name="André Boler Cláudio da Silva Barros" userId="6a6e06a7-71d6-4753-8f49-a25f8eb0dc15" providerId="ADAL" clId="{6BE99AA9-1EEE-46D3-8261-83B0B634593B}" dt="2026-01-12T10:18:45.953" v="1618" actId="164"/>
+          <ac:picMkLst>
+            <pc:docMk/>
+            <pc:sldMk cId="357586254" sldId="885"/>
+            <ac:picMk id="3" creationId="{452ABECC-5D4F-82E9-9130-B858FC0DF1E3}"/>
+          </ac:picMkLst>
+        </pc:picChg>
+        <pc:picChg chg="add mod">
+          <ac:chgData name="André Boler Cláudio da Silva Barros" userId="6a6e06a7-71d6-4753-8f49-a25f8eb0dc15" providerId="ADAL" clId="{6BE99AA9-1EEE-46D3-8261-83B0B634593B}" dt="2026-01-12T10:19:10.530" v="1619" actId="12789"/>
+          <ac:picMkLst>
+            <pc:docMk/>
+            <pc:sldMk cId="357586254" sldId="885"/>
+            <ac:picMk id="4" creationId="{4329CB09-8782-CB6B-ADFE-01EE10DC66A3}"/>
+          </ac:picMkLst>
+        </pc:picChg>
+        <pc:picChg chg="add mod">
+          <ac:chgData name="André Boler Cláudio da Silva Barros" userId="6a6e06a7-71d6-4753-8f49-a25f8eb0dc15" providerId="ADAL" clId="{6BE99AA9-1EEE-46D3-8261-83B0B634593B}" dt="2026-01-12T10:18:45.953" v="1618" actId="164"/>
+          <ac:picMkLst>
+            <pc:docMk/>
+            <pc:sldMk cId="357586254" sldId="885"/>
+            <ac:picMk id="5" creationId="{86F33D38-5AAF-F757-6592-34C22401BA5F}"/>
+          </ac:picMkLst>
+        </pc:picChg>
+        <pc:picChg chg="add mod">
+          <ac:chgData name="André Boler Cláudio da Silva Barros" userId="6a6e06a7-71d6-4753-8f49-a25f8eb0dc15" providerId="ADAL" clId="{6BE99AA9-1EEE-46D3-8261-83B0B634593B}" dt="2026-01-12T10:21:27.063" v="1622" actId="1076"/>
+          <ac:picMkLst>
+            <pc:docMk/>
+            <pc:sldMk cId="357586254" sldId="885"/>
+            <ac:picMk id="15" creationId="{0BE2B919-856B-93CE-3517-1D233E1A8E88}"/>
+          </ac:picMkLst>
+        </pc:picChg>
+        <pc:picChg chg="add mod">
+          <ac:chgData name="André Boler Cláudio da Silva Barros" userId="6a6e06a7-71d6-4753-8f49-a25f8eb0dc15" providerId="ADAL" clId="{6BE99AA9-1EEE-46D3-8261-83B0B634593B}" dt="2026-01-12T10:13:24.396" v="1320" actId="1076"/>
+          <ac:picMkLst>
+            <pc:docMk/>
+            <pc:sldMk cId="357586254" sldId="885"/>
+            <ac:picMk id="1026" creationId="{BFE5A4A4-73A9-8389-674C-30A99DC66538}"/>
+          </ac:picMkLst>
+        </pc:picChg>
+      </pc:sldChg>
+      <pc:sldChg chg="addSp delSp modSp add mod">
+        <pc:chgData name="André Boler Cláudio da Silva Barros" userId="6a6e06a7-71d6-4753-8f49-a25f8eb0dc15" providerId="ADAL" clId="{6BE99AA9-1EEE-46D3-8261-83B0B634593B}" dt="2026-01-12T10:27:38.635" v="1706" actId="1076"/>
+        <pc:sldMkLst>
+          <pc:docMk/>
+          <pc:sldMk cId="3106891909" sldId="886"/>
+        </pc:sldMkLst>
+        <pc:spChg chg="mod">
+          <ac:chgData name="André Boler Cláudio da Silva Barros" userId="6a6e06a7-71d6-4753-8f49-a25f8eb0dc15" providerId="ADAL" clId="{6BE99AA9-1EEE-46D3-8261-83B0B634593B}" dt="2026-01-12T10:22:44.951" v="1658" actId="20577"/>
+          <ac:spMkLst>
+            <pc:docMk/>
+            <pc:sldMk cId="3106891909" sldId="886"/>
+            <ac:spMk id="13" creationId="{4F9E6795-287B-DDC2-A981-ABFC373EB0F3}"/>
+          </ac:spMkLst>
+        </pc:spChg>
+        <pc:grpChg chg="del">
+          <ac:chgData name="André Boler Cláudio da Silva Barros" userId="6a6e06a7-71d6-4753-8f49-a25f8eb0dc15" providerId="ADAL" clId="{6BE99AA9-1EEE-46D3-8261-83B0B634593B}" dt="2026-01-12T10:22:49.369" v="1659" actId="478"/>
+          <ac:grpSpMkLst>
+            <pc:docMk/>
+            <pc:sldMk cId="3106891909" sldId="886"/>
+            <ac:grpSpMk id="6" creationId="{28F812D4-7C16-96EC-FD99-501E0AAB5207}"/>
+          </ac:grpSpMkLst>
+        </pc:grpChg>
+        <pc:picChg chg="add mod modCrop">
+          <ac:chgData name="André Boler Cláudio da Silva Barros" userId="6a6e06a7-71d6-4753-8f49-a25f8eb0dc15" providerId="ADAL" clId="{6BE99AA9-1EEE-46D3-8261-83B0B634593B}" dt="2026-01-12T10:23:37.024" v="1671" actId="12789"/>
+          <ac:picMkLst>
+            <pc:docMk/>
+            <pc:sldMk cId="3106891909" sldId="886"/>
+            <ac:picMk id="2" creationId="{A2B04370-7D20-A2CE-E36B-222DEFB0D46B}"/>
+          </ac:picMkLst>
+        </pc:picChg>
+        <pc:picChg chg="mod">
+          <ac:chgData name="André Boler Cláudio da Silva Barros" userId="6a6e06a7-71d6-4753-8f49-a25f8eb0dc15" providerId="ADAL" clId="{6BE99AA9-1EEE-46D3-8261-83B0B634593B}" dt="2026-01-12T10:23:37.024" v="1671" actId="12789"/>
+          <ac:picMkLst>
+            <pc:docMk/>
+            <pc:sldMk cId="3106891909" sldId="886"/>
+            <ac:picMk id="4" creationId="{A33E4144-6711-847F-CE67-B350E3324AE1}"/>
+          </ac:picMkLst>
+        </pc:picChg>
+        <pc:picChg chg="add del mod">
+          <ac:chgData name="André Boler Cláudio da Silva Barros" userId="6a6e06a7-71d6-4753-8f49-a25f8eb0dc15" providerId="ADAL" clId="{6BE99AA9-1EEE-46D3-8261-83B0B634593B}" dt="2026-01-12T10:27:18.263" v="1700" actId="478"/>
+          <ac:picMkLst>
+            <pc:docMk/>
+            <pc:sldMk cId="3106891909" sldId="886"/>
+            <ac:picMk id="5" creationId="{34E38961-8AA8-7713-61F2-FE4E35521BDE}"/>
+          </ac:picMkLst>
+        </pc:picChg>
+        <pc:picChg chg="add mod modCrop">
+          <ac:chgData name="André Boler Cláudio da Silva Barros" userId="6a6e06a7-71d6-4753-8f49-a25f8eb0dc15" providerId="ADAL" clId="{6BE99AA9-1EEE-46D3-8261-83B0B634593B}" dt="2026-01-12T10:27:31.720" v="1704" actId="1076"/>
+          <ac:picMkLst>
+            <pc:docMk/>
+            <pc:sldMk cId="3106891909" sldId="886"/>
+            <ac:picMk id="8" creationId="{545D93D0-8A53-7C7F-E36E-153B15A94416}"/>
+          </ac:picMkLst>
+        </pc:picChg>
+        <pc:picChg chg="add mod">
+          <ac:chgData name="André Boler Cláudio da Silva Barros" userId="6a6e06a7-71d6-4753-8f49-a25f8eb0dc15" providerId="ADAL" clId="{6BE99AA9-1EEE-46D3-8261-83B0B634593B}" dt="2026-01-12T10:27:38.635" v="1706" actId="1076"/>
+          <ac:picMkLst>
+            <pc:docMk/>
+            <pc:sldMk cId="3106891909" sldId="886"/>
+            <ac:picMk id="15" creationId="{1479AE7D-C0A7-654E-FDE7-C9B85AFA4F53}"/>
+          </ac:picMkLst>
+        </pc:picChg>
+        <pc:picChg chg="del">
+          <ac:chgData name="André Boler Cláudio da Silva Barros" userId="6a6e06a7-71d6-4753-8f49-a25f8eb0dc15" providerId="ADAL" clId="{6BE99AA9-1EEE-46D3-8261-83B0B634593B}" dt="2026-01-12T10:23:38.812" v="1672" actId="478"/>
+          <ac:picMkLst>
+            <pc:docMk/>
+            <pc:sldMk cId="3106891909" sldId="886"/>
+            <ac:picMk id="15" creationId="{CA243845-3531-DF1F-B67C-F0011B7C35AE}"/>
+          </ac:picMkLst>
+        </pc:picChg>
+        <pc:picChg chg="add del mod modCrop">
+          <ac:chgData name="André Boler Cláudio da Silva Barros" userId="6a6e06a7-71d6-4753-8f49-a25f8eb0dc15" providerId="ADAL" clId="{6BE99AA9-1EEE-46D3-8261-83B0B634593B}" dt="2026-01-12T10:25:23.044" v="1682" actId="478"/>
+          <ac:picMkLst>
+            <pc:docMk/>
+            <pc:sldMk cId="3106891909" sldId="886"/>
+            <ac:picMk id="16" creationId="{6EA059E3-4B2B-30DA-08E1-2E06697D81A7}"/>
+          </ac:picMkLst>
+        </pc:picChg>
+      </pc:sldChg>
       <pc:sldChg chg="del">
         <pc:chgData name="André Boler Cláudio da Silva Barros" userId="6a6e06a7-71d6-4753-8f49-a25f8eb0dc15" providerId="ADAL" clId="{6BE99AA9-1EEE-46D3-8261-83B0B634593B}" dt="2026-01-12T09:21:56.604" v="548" actId="47"/>
         <pc:sldMkLst>
@@ -1226,6 +1386,121 @@
 </p:notes>
 </file>
 
+<file path=ppt/notesSlides/notesSlide10.xml><?xml version="1.0" encoding="utf-8"?>
+<p:notes xmlns:a="http://schemas.openxmlformats.org/drawingml/2006/main" xmlns:r="http://schemas.openxmlformats.org/officeDocument/2006/relationships" xmlns:p="http://schemas.openxmlformats.org/presentationml/2006/main">
+  <p:cSld>
+    <p:spTree>
+      <p:nvGrpSpPr>
+        <p:cNvPr id="1" name="">
+          <a:extLst>
+            <a:ext uri="{FF2B5EF4-FFF2-40B4-BE49-F238E27FC236}">
+              <a16:creationId xmlns:a16="http://schemas.microsoft.com/office/drawing/2014/main" id="{03D6918A-7F94-DE9B-058E-EDEC77446835}"/>
+            </a:ext>
+          </a:extLst>
+        </p:cNvPr>
+        <p:cNvGrpSpPr/>
+        <p:nvPr/>
+      </p:nvGrpSpPr>
+      <p:grpSpPr>
+        <a:xfrm>
+          <a:off x="0" y="0"/>
+          <a:ext cx="0" cy="0"/>
+          <a:chOff x="0" y="0"/>
+          <a:chExt cx="0" cy="0"/>
+        </a:xfrm>
+      </p:grpSpPr>
+      <p:sp>
+        <p:nvSpPr>
+          <p:cNvPr id="2" name="Slide Image Placeholder 1">
+            <a:extLst>
+              <a:ext uri="{FF2B5EF4-FFF2-40B4-BE49-F238E27FC236}">
+                <a16:creationId xmlns:a16="http://schemas.microsoft.com/office/drawing/2014/main" id="{165B448D-442E-8019-334A-E57F86BDF4A4}"/>
+              </a:ext>
+            </a:extLst>
+          </p:cNvPr>
+          <p:cNvSpPr>
+            <a:spLocks noGrp="1" noRot="1" noChangeAspect="1"/>
+          </p:cNvSpPr>
+          <p:nvPr>
+            <p:ph type="sldImg"/>
+          </p:nvPr>
+        </p:nvSpPr>
+        <p:spPr/>
+        <p:txBody>
+          <a:bodyPr/>
+          <a:lstStyle/>
+          <a:p>
+            <a:endParaRPr lang="pt-PT"/>
+          </a:p>
+        </p:txBody>
+      </p:sp>
+      <p:sp>
+        <p:nvSpPr>
+          <p:cNvPr id="3" name="Notes Placeholder 2">
+            <a:extLst>
+              <a:ext uri="{FF2B5EF4-FFF2-40B4-BE49-F238E27FC236}">
+                <a16:creationId xmlns:a16="http://schemas.microsoft.com/office/drawing/2014/main" id="{98889B37-069F-C478-C68E-AFEF73F4BCAC}"/>
+              </a:ext>
+            </a:extLst>
+          </p:cNvPr>
+          <p:cNvSpPr>
+            <a:spLocks noGrp="1"/>
+          </p:cNvSpPr>
+          <p:nvPr>
+            <p:ph type="body" idx="1"/>
+          </p:nvPr>
+        </p:nvSpPr>
+        <p:spPr/>
+        <p:txBody>
+          <a:bodyPr/>
+          <a:lstStyle/>
+          <a:p>
+            <a:endParaRPr lang="pt-PT" dirty="0"/>
+          </a:p>
+        </p:txBody>
+      </p:sp>
+      <p:sp>
+        <p:nvSpPr>
+          <p:cNvPr id="4" name="Slide Number Placeholder 3">
+            <a:extLst>
+              <a:ext uri="{FF2B5EF4-FFF2-40B4-BE49-F238E27FC236}">
+                <a16:creationId xmlns:a16="http://schemas.microsoft.com/office/drawing/2014/main" id="{74E616D3-FE16-4766-4520-96A1D5757621}"/>
+              </a:ext>
+            </a:extLst>
+          </p:cNvPr>
+          <p:cNvSpPr>
+            <a:spLocks noGrp="1"/>
+          </p:cNvSpPr>
+          <p:nvPr>
+            <p:ph type="sldNum" sz="quarter" idx="5"/>
+          </p:nvPr>
+        </p:nvSpPr>
+        <p:spPr/>
+        <p:txBody>
+          <a:bodyPr/>
+          <a:lstStyle/>
+          <a:p>
+            <a:fld id="{304CD7C7-91BF-4B50-A187-D8898A81460C}" type="slidenum">
+              <a:rPr lang="en-GB" smtClean="0"/>
+              <a:t>10</a:t>
+            </a:fld>
+            <a:endParaRPr lang="en-GB"/>
+          </a:p>
+        </p:txBody>
+      </p:sp>
+    </p:spTree>
+    <p:extLst>
+      <p:ext uri="{BB962C8B-B14F-4D97-AF65-F5344CB8AC3E}">
+        <p14:creationId xmlns:p14="http://schemas.microsoft.com/office/powerpoint/2010/main" val="690028706"/>
+      </p:ext>
+    </p:extLst>
+  </p:cSld>
+  <p:clrMapOvr>
+    <a:masterClrMapping/>
+  </p:clrMapOvr>
+</p:notes>
+</file>
+
 <file path=ppt/notesSlides/notesSlide2.xml><?xml version="1.0" encoding="utf-8"?>
 <p:notes xmlns:a="http://schemas.openxmlformats.org/drawingml/2006/main" xmlns:r="http://schemas.openxmlformats.org/officeDocument/2006/relationships" xmlns:p="http://schemas.openxmlformats.org/presentationml/2006/main">
   <p:cSld>
@@ -1579,6 +1854,236 @@
         <p:cNvPr id="1" name="">
           <a:extLst>
             <a:ext uri="{FF2B5EF4-FFF2-40B4-BE49-F238E27FC236}">
+              <a16:creationId xmlns:a16="http://schemas.microsoft.com/office/drawing/2014/main" id="{07486204-AE93-247B-5B68-5469B6E330AD}"/>
+            </a:ext>
+          </a:extLst>
+        </p:cNvPr>
+        <p:cNvGrpSpPr/>
+        <p:nvPr/>
+      </p:nvGrpSpPr>
+      <p:grpSpPr>
+        <a:xfrm>
+          <a:off x="0" y="0"/>
+          <a:ext cx="0" cy="0"/>
+          <a:chOff x="0" y="0"/>
+          <a:chExt cx="0" cy="0"/>
+        </a:xfrm>
+      </p:grpSpPr>
+      <p:sp>
+        <p:nvSpPr>
+          <p:cNvPr id="2" name="Slide Image Placeholder 1">
+            <a:extLst>
+              <a:ext uri="{FF2B5EF4-FFF2-40B4-BE49-F238E27FC236}">
+                <a16:creationId xmlns:a16="http://schemas.microsoft.com/office/drawing/2014/main" id="{789623AC-9B1F-1DA5-C749-982B60F555E8}"/>
+              </a:ext>
+            </a:extLst>
+          </p:cNvPr>
+          <p:cNvSpPr>
+            <a:spLocks noGrp="1" noRot="1" noChangeAspect="1"/>
+          </p:cNvSpPr>
+          <p:nvPr>
+            <p:ph type="sldImg"/>
+          </p:nvPr>
+        </p:nvSpPr>
+        <p:spPr/>
+        <p:txBody>
+          <a:bodyPr/>
+          <a:lstStyle/>
+          <a:p>
+            <a:endParaRPr lang="pt-PT"/>
+          </a:p>
+        </p:txBody>
+      </p:sp>
+      <p:sp>
+        <p:nvSpPr>
+          <p:cNvPr id="3" name="Notes Placeholder 2">
+            <a:extLst>
+              <a:ext uri="{FF2B5EF4-FFF2-40B4-BE49-F238E27FC236}">
+                <a16:creationId xmlns:a16="http://schemas.microsoft.com/office/drawing/2014/main" id="{F6BFFDA8-2147-782A-556A-F9403F3AE75E}"/>
+              </a:ext>
+            </a:extLst>
+          </p:cNvPr>
+          <p:cNvSpPr>
+            <a:spLocks noGrp="1"/>
+          </p:cNvSpPr>
+          <p:nvPr>
+            <p:ph type="body" idx="1"/>
+          </p:nvPr>
+        </p:nvSpPr>
+        <p:spPr/>
+        <p:txBody>
+          <a:bodyPr/>
+          <a:lstStyle/>
+          <a:p>
+            <a:endParaRPr lang="pt-PT" dirty="0"/>
+          </a:p>
+        </p:txBody>
+      </p:sp>
+      <p:sp>
+        <p:nvSpPr>
+          <p:cNvPr id="4" name="Slide Number Placeholder 3">
+            <a:extLst>
+              <a:ext uri="{FF2B5EF4-FFF2-40B4-BE49-F238E27FC236}">
+                <a16:creationId xmlns:a16="http://schemas.microsoft.com/office/drawing/2014/main" id="{3DFCAD4D-635A-2B69-B20F-61317C3C2D4B}"/>
+              </a:ext>
+            </a:extLst>
+          </p:cNvPr>
+          <p:cNvSpPr>
+            <a:spLocks noGrp="1"/>
+          </p:cNvSpPr>
+          <p:nvPr>
+            <p:ph type="sldNum" sz="quarter" idx="5"/>
+          </p:nvPr>
+        </p:nvSpPr>
+        <p:spPr/>
+        <p:txBody>
+          <a:bodyPr/>
+          <a:lstStyle/>
+          <a:p>
+            <a:fld id="{304CD7C7-91BF-4B50-A187-D8898A81460C}" type="slidenum">
+              <a:rPr lang="en-GB" smtClean="0"/>
+              <a:t>5</a:t>
+            </a:fld>
+            <a:endParaRPr lang="en-GB"/>
+          </a:p>
+        </p:txBody>
+      </p:sp>
+    </p:spTree>
+    <p:extLst>
+      <p:ext uri="{BB962C8B-B14F-4D97-AF65-F5344CB8AC3E}">
+        <p14:creationId xmlns:p14="http://schemas.microsoft.com/office/powerpoint/2010/main" val="2436068134"/>
+      </p:ext>
+    </p:extLst>
+  </p:cSld>
+  <p:clrMapOvr>
+    <a:masterClrMapping/>
+  </p:clrMapOvr>
+</p:notes>
+</file>
+
+<file path=ppt/notesSlides/notesSlide6.xml><?xml version="1.0" encoding="utf-8"?>
+<p:notes xmlns:a="http://schemas.openxmlformats.org/drawingml/2006/main" xmlns:r="http://schemas.openxmlformats.org/officeDocument/2006/relationships" xmlns:p="http://schemas.openxmlformats.org/presentationml/2006/main">
+  <p:cSld>
+    <p:spTree>
+      <p:nvGrpSpPr>
+        <p:cNvPr id="1" name="">
+          <a:extLst>
+            <a:ext uri="{FF2B5EF4-FFF2-40B4-BE49-F238E27FC236}">
+              <a16:creationId xmlns:a16="http://schemas.microsoft.com/office/drawing/2014/main" id="{ADF79B5F-41C4-01AD-445E-83F518795AF9}"/>
+            </a:ext>
+          </a:extLst>
+        </p:cNvPr>
+        <p:cNvGrpSpPr/>
+        <p:nvPr/>
+      </p:nvGrpSpPr>
+      <p:grpSpPr>
+        <a:xfrm>
+          <a:off x="0" y="0"/>
+          <a:ext cx="0" cy="0"/>
+          <a:chOff x="0" y="0"/>
+          <a:chExt cx="0" cy="0"/>
+        </a:xfrm>
+      </p:grpSpPr>
+      <p:sp>
+        <p:nvSpPr>
+          <p:cNvPr id="2" name="Slide Image Placeholder 1">
+            <a:extLst>
+              <a:ext uri="{FF2B5EF4-FFF2-40B4-BE49-F238E27FC236}">
+                <a16:creationId xmlns:a16="http://schemas.microsoft.com/office/drawing/2014/main" id="{8643F1FA-AE4F-FDC7-F7B3-F9D990B04D07}"/>
+              </a:ext>
+            </a:extLst>
+          </p:cNvPr>
+          <p:cNvSpPr>
+            <a:spLocks noGrp="1" noRot="1" noChangeAspect="1"/>
+          </p:cNvSpPr>
+          <p:nvPr>
+            <p:ph type="sldImg"/>
+          </p:nvPr>
+        </p:nvSpPr>
+        <p:spPr/>
+        <p:txBody>
+          <a:bodyPr/>
+          <a:lstStyle/>
+          <a:p>
+            <a:endParaRPr lang="pt-PT"/>
+          </a:p>
+        </p:txBody>
+      </p:sp>
+      <p:sp>
+        <p:nvSpPr>
+          <p:cNvPr id="3" name="Notes Placeholder 2">
+            <a:extLst>
+              <a:ext uri="{FF2B5EF4-FFF2-40B4-BE49-F238E27FC236}">
+                <a16:creationId xmlns:a16="http://schemas.microsoft.com/office/drawing/2014/main" id="{CDCA96C0-15C3-F055-3B4F-C2DA48648709}"/>
+              </a:ext>
+            </a:extLst>
+          </p:cNvPr>
+          <p:cNvSpPr>
+            <a:spLocks noGrp="1"/>
+          </p:cNvSpPr>
+          <p:nvPr>
+            <p:ph type="body" idx="1"/>
+          </p:nvPr>
+        </p:nvSpPr>
+        <p:spPr/>
+        <p:txBody>
+          <a:bodyPr/>
+          <a:lstStyle/>
+          <a:p>
+            <a:endParaRPr lang="pt-PT" dirty="0"/>
+          </a:p>
+        </p:txBody>
+      </p:sp>
+      <p:sp>
+        <p:nvSpPr>
+          <p:cNvPr id="4" name="Slide Number Placeholder 3">
+            <a:extLst>
+              <a:ext uri="{FF2B5EF4-FFF2-40B4-BE49-F238E27FC236}">
+                <a16:creationId xmlns:a16="http://schemas.microsoft.com/office/drawing/2014/main" id="{7E8EA7DA-62EF-DCCB-0344-8EA8C0731E01}"/>
+              </a:ext>
+            </a:extLst>
+          </p:cNvPr>
+          <p:cNvSpPr>
+            <a:spLocks noGrp="1"/>
+          </p:cNvSpPr>
+          <p:nvPr>
+            <p:ph type="sldNum" sz="quarter" idx="5"/>
+          </p:nvPr>
+        </p:nvSpPr>
+        <p:spPr/>
+        <p:txBody>
+          <a:bodyPr/>
+          <a:lstStyle/>
+          <a:p>
+            <a:fld id="{304CD7C7-91BF-4B50-A187-D8898A81460C}" type="slidenum">
+              <a:rPr lang="en-GB" smtClean="0"/>
+              <a:t>6</a:t>
+            </a:fld>
+            <a:endParaRPr lang="en-GB"/>
+          </a:p>
+        </p:txBody>
+      </p:sp>
+    </p:spTree>
+    <p:extLst>
+      <p:ext uri="{BB962C8B-B14F-4D97-AF65-F5344CB8AC3E}">
+        <p14:creationId xmlns:p14="http://schemas.microsoft.com/office/powerpoint/2010/main" val="3434631840"/>
+      </p:ext>
+    </p:extLst>
+  </p:cSld>
+  <p:clrMapOvr>
+    <a:masterClrMapping/>
+  </p:clrMapOvr>
+</p:notes>
+</file>
+
+<file path=ppt/notesSlides/notesSlide7.xml><?xml version="1.0" encoding="utf-8"?>
+<p:notes xmlns:a="http://schemas.openxmlformats.org/drawingml/2006/main" xmlns:r="http://schemas.openxmlformats.org/officeDocument/2006/relationships" xmlns:p="http://schemas.openxmlformats.org/presentationml/2006/main">
+  <p:cSld>
+    <p:spTree>
+      <p:nvGrpSpPr>
+        <p:cNvPr id="1" name="">
+          <a:extLst>
+            <a:ext uri="{FF2B5EF4-FFF2-40B4-BE49-F238E27FC236}">
               <a16:creationId xmlns:a16="http://schemas.microsoft.com/office/drawing/2014/main" id="{8A8ECE07-AA92-7A03-F66B-C0DF4D51EC82}"/>
             </a:ext>
           </a:extLst>
@@ -1667,7 +2172,7 @@
           <a:p>
             <a:fld id="{304CD7C7-91BF-4B50-A187-D8898A81460C}" type="slidenum">
               <a:rPr lang="en-GB" smtClean="0"/>
-              <a:t>5</a:t>
+              <a:t>7</a:t>
             </a:fld>
             <a:endParaRPr lang="en-GB"/>
           </a:p>
@@ -1686,7 +2191,7 @@
 </p:notes>
 </file>
 
-<file path=ppt/notesSlides/notesSlide6.xml><?xml version="1.0" encoding="utf-8"?>
+<file path=ppt/notesSlides/notesSlide8.xml><?xml version="1.0" encoding="utf-8"?>
 <p:notes xmlns:a="http://schemas.openxmlformats.org/drawingml/2006/main" xmlns:r="http://schemas.openxmlformats.org/officeDocument/2006/relationships" xmlns:p="http://schemas.openxmlformats.org/presentationml/2006/main">
   <p:cSld>
     <p:spTree>
@@ -1782,7 +2287,7 @@
           <a:p>
             <a:fld id="{304CD7C7-91BF-4B50-A187-D8898A81460C}" type="slidenum">
               <a:rPr lang="en-GB" smtClean="0"/>
-              <a:t>6</a:t>
+              <a:t>8</a:t>
             </a:fld>
             <a:endParaRPr lang="en-GB"/>
           </a:p>
@@ -1801,7 +2306,7 @@
 </p:notes>
 </file>
 
-<file path=ppt/notesSlides/notesSlide7.xml><?xml version="1.0" encoding="utf-8"?>
+<file path=ppt/notesSlides/notesSlide9.xml><?xml version="1.0" encoding="utf-8"?>
 <p:notes xmlns:a="http://schemas.openxmlformats.org/drawingml/2006/main" xmlns:r="http://schemas.openxmlformats.org/officeDocument/2006/relationships" xmlns:p="http://schemas.openxmlformats.org/presentationml/2006/main">
   <p:cSld>
     <p:spTree>
@@ -1897,7 +2402,7 @@
           <a:p>
             <a:fld id="{304CD7C7-91BF-4B50-A187-D8898A81460C}" type="slidenum">
               <a:rPr lang="en-GB" smtClean="0"/>
-              <a:t>7</a:t>
+              <a:t>9</a:t>
             </a:fld>
             <a:endParaRPr lang="en-GB"/>
           </a:p>
@@ -1907,121 +2412,6 @@
     <p:extLst>
       <p:ext uri="{BB962C8B-B14F-4D97-AF65-F5344CB8AC3E}">
         <p14:creationId xmlns:p14="http://schemas.microsoft.com/office/powerpoint/2010/main" val="3896732663"/>
-      </p:ext>
-    </p:extLst>
-  </p:cSld>
-  <p:clrMapOvr>
-    <a:masterClrMapping/>
-  </p:clrMapOvr>
-</p:notes>
-</file>
-
-<file path=ppt/notesSlides/notesSlide8.xml><?xml version="1.0" encoding="utf-8"?>
-<p:notes xmlns:a="http://schemas.openxmlformats.org/drawingml/2006/main" xmlns:r="http://schemas.openxmlformats.org/officeDocument/2006/relationships" xmlns:p="http://schemas.openxmlformats.org/presentationml/2006/main">
-  <p:cSld>
-    <p:spTree>
-      <p:nvGrpSpPr>
-        <p:cNvPr id="1" name="">
-          <a:extLst>
-            <a:ext uri="{FF2B5EF4-FFF2-40B4-BE49-F238E27FC236}">
-              <a16:creationId xmlns:a16="http://schemas.microsoft.com/office/drawing/2014/main" id="{03D6918A-7F94-DE9B-058E-EDEC77446835}"/>
-            </a:ext>
-          </a:extLst>
-        </p:cNvPr>
-        <p:cNvGrpSpPr/>
-        <p:nvPr/>
-      </p:nvGrpSpPr>
-      <p:grpSpPr>
-        <a:xfrm>
-          <a:off x="0" y="0"/>
-          <a:ext cx="0" cy="0"/>
-          <a:chOff x="0" y="0"/>
-          <a:chExt cx="0" cy="0"/>
-        </a:xfrm>
-      </p:grpSpPr>
-      <p:sp>
-        <p:nvSpPr>
-          <p:cNvPr id="2" name="Slide Image Placeholder 1">
-            <a:extLst>
-              <a:ext uri="{FF2B5EF4-FFF2-40B4-BE49-F238E27FC236}">
-                <a16:creationId xmlns:a16="http://schemas.microsoft.com/office/drawing/2014/main" id="{165B448D-442E-8019-334A-E57F86BDF4A4}"/>
-              </a:ext>
-            </a:extLst>
-          </p:cNvPr>
-          <p:cNvSpPr>
-            <a:spLocks noGrp="1" noRot="1" noChangeAspect="1"/>
-          </p:cNvSpPr>
-          <p:nvPr>
-            <p:ph type="sldImg"/>
-          </p:nvPr>
-        </p:nvSpPr>
-        <p:spPr/>
-        <p:txBody>
-          <a:bodyPr/>
-          <a:lstStyle/>
-          <a:p>
-            <a:endParaRPr lang="pt-PT"/>
-          </a:p>
-        </p:txBody>
-      </p:sp>
-      <p:sp>
-        <p:nvSpPr>
-          <p:cNvPr id="3" name="Notes Placeholder 2">
-            <a:extLst>
-              <a:ext uri="{FF2B5EF4-FFF2-40B4-BE49-F238E27FC236}">
-                <a16:creationId xmlns:a16="http://schemas.microsoft.com/office/drawing/2014/main" id="{98889B37-069F-C478-C68E-AFEF73F4BCAC}"/>
-              </a:ext>
-            </a:extLst>
-          </p:cNvPr>
-          <p:cNvSpPr>
-            <a:spLocks noGrp="1"/>
-          </p:cNvSpPr>
-          <p:nvPr>
-            <p:ph type="body" idx="1"/>
-          </p:nvPr>
-        </p:nvSpPr>
-        <p:spPr/>
-        <p:txBody>
-          <a:bodyPr/>
-          <a:lstStyle/>
-          <a:p>
-            <a:endParaRPr lang="pt-PT" dirty="0"/>
-          </a:p>
-        </p:txBody>
-      </p:sp>
-      <p:sp>
-        <p:nvSpPr>
-          <p:cNvPr id="4" name="Slide Number Placeholder 3">
-            <a:extLst>
-              <a:ext uri="{FF2B5EF4-FFF2-40B4-BE49-F238E27FC236}">
-                <a16:creationId xmlns:a16="http://schemas.microsoft.com/office/drawing/2014/main" id="{74E616D3-FE16-4766-4520-96A1D5757621}"/>
-              </a:ext>
-            </a:extLst>
-          </p:cNvPr>
-          <p:cNvSpPr>
-            <a:spLocks noGrp="1"/>
-          </p:cNvSpPr>
-          <p:nvPr>
-            <p:ph type="sldNum" sz="quarter" idx="5"/>
-          </p:nvPr>
-        </p:nvSpPr>
-        <p:spPr/>
-        <p:txBody>
-          <a:bodyPr/>
-          <a:lstStyle/>
-          <a:p>
-            <a:fld id="{304CD7C7-91BF-4B50-A187-D8898A81460C}" type="slidenum">
-              <a:rPr lang="en-GB" smtClean="0"/>
-              <a:t>8</a:t>
-            </a:fld>
-            <a:endParaRPr lang="en-GB"/>
-          </a:p>
-        </p:txBody>
-      </p:sp>
-    </p:spTree>
-    <p:extLst>
-      <p:ext uri="{BB962C8B-B14F-4D97-AF65-F5344CB8AC3E}">
-        <p14:creationId xmlns:p14="http://schemas.microsoft.com/office/powerpoint/2010/main" val="690028706"/>
       </p:ext>
     </p:extLst>
   </p:cSld>
@@ -5643,6 +6033,669 @@
 </p:sld>
 </file>
 
+<file path=ppt/slides/slide10.xml><?xml version="1.0" encoding="utf-8"?>
+<p:sld xmlns:a="http://schemas.openxmlformats.org/drawingml/2006/main" xmlns:r="http://schemas.openxmlformats.org/officeDocument/2006/relationships" xmlns:p="http://schemas.openxmlformats.org/presentationml/2006/main">
+  <p:cSld>
+    <p:spTree>
+      <p:nvGrpSpPr>
+        <p:cNvPr id="1" name="">
+          <a:extLst>
+            <a:ext uri="{FF2B5EF4-FFF2-40B4-BE49-F238E27FC236}">
+              <a16:creationId xmlns:a16="http://schemas.microsoft.com/office/drawing/2014/main" id="{00529CBD-B49A-3084-90F3-0D7834C0EE96}"/>
+            </a:ext>
+          </a:extLst>
+        </p:cNvPr>
+        <p:cNvGrpSpPr/>
+        <p:nvPr/>
+      </p:nvGrpSpPr>
+      <p:grpSpPr>
+        <a:xfrm>
+          <a:off x="0" y="0"/>
+          <a:ext cx="0" cy="0"/>
+          <a:chOff x="0" y="0"/>
+          <a:chExt cx="0" cy="0"/>
+        </a:xfrm>
+      </p:grpSpPr>
+      <p:pic>
+        <p:nvPicPr>
+          <p:cNvPr id="17" name="Picture 16">
+            <a:extLst>
+              <a:ext uri="{FF2B5EF4-FFF2-40B4-BE49-F238E27FC236}">
+                <a16:creationId xmlns:a16="http://schemas.microsoft.com/office/drawing/2014/main" id="{FED5154D-8E9B-10D4-6458-6DA83132A5EB}"/>
+              </a:ext>
+            </a:extLst>
+          </p:cNvPr>
+          <p:cNvPicPr>
+            <a:picLocks noChangeAspect="1"/>
+          </p:cNvPicPr>
+          <p:nvPr/>
+        </p:nvPicPr>
+        <p:blipFill>
+          <a:blip r:embed="rId3"/>
+          <a:srcRect b="6189"/>
+          <a:stretch>
+            <a:fillRect/>
+          </a:stretch>
+        </p:blipFill>
+        <p:spPr>
+          <a:xfrm>
+            <a:off x="318096" y="2100727"/>
+            <a:ext cx="3738265" cy="3619430"/>
+          </a:xfrm>
+          <a:prstGeom prst="rect">
+            <a:avLst/>
+          </a:prstGeom>
+        </p:spPr>
+      </p:pic>
+      <p:sp>
+        <p:nvSpPr>
+          <p:cNvPr id="7" name="TextBox 6">
+            <a:extLst>
+              <a:ext uri="{FF2B5EF4-FFF2-40B4-BE49-F238E27FC236}">
+                <a16:creationId xmlns:a16="http://schemas.microsoft.com/office/drawing/2014/main" id="{D3A9C648-9C0B-7C69-C62D-C0C5D02E6B31}"/>
+              </a:ext>
+            </a:extLst>
+          </p:cNvPr>
+          <p:cNvSpPr txBox="1"/>
+          <p:nvPr/>
+        </p:nvSpPr>
+        <p:spPr>
+          <a:xfrm>
+            <a:off x="318096" y="0"/>
+            <a:ext cx="11555807" cy="584775"/>
+          </a:xfrm>
+          <a:prstGeom prst="rect">
+            <a:avLst/>
+          </a:prstGeom>
+          <a:noFill/>
+        </p:spPr>
+        <p:txBody>
+          <a:bodyPr wrap="square" rtlCol="0">
+            <a:spAutoFit/>
+          </a:bodyPr>
+          <a:lstStyle/>
+          <a:p>
+            <a:r>
+              <a:rPr lang="en-GB" sz="3200" b="1" noProof="0" dirty="0">
+                <a:solidFill>
+                  <a:schemeClr val="bg1"/>
+                </a:solidFill>
+                <a:latin typeface="Cambria" panose="02040503050406030204" pitchFamily="18" charset="0"/>
+                <a:ea typeface="Cambria" panose="02040503050406030204" pitchFamily="18" charset="0"/>
+                <a:cs typeface="Times New Roman" panose="02020603050405020304" pitchFamily="18" charset="0"/>
+              </a:rPr>
+              <a:t>Course Material</a:t>
+            </a:r>
+          </a:p>
+        </p:txBody>
+      </p:sp>
+      <p:sp>
+        <p:nvSpPr>
+          <p:cNvPr id="13" name="TextBox 12">
+            <a:extLst>
+              <a:ext uri="{FF2B5EF4-FFF2-40B4-BE49-F238E27FC236}">
+                <a16:creationId xmlns:a16="http://schemas.microsoft.com/office/drawing/2014/main" id="{A2E1476E-12F5-E3E6-D696-3BCB301EE6FA}"/>
+              </a:ext>
+            </a:extLst>
+          </p:cNvPr>
+          <p:cNvSpPr txBox="1"/>
+          <p:nvPr/>
+        </p:nvSpPr>
+        <p:spPr>
+          <a:xfrm>
+            <a:off x="222111" y="800107"/>
+            <a:ext cx="11747779" cy="1039452"/>
+          </a:xfrm>
+          <a:prstGeom prst="rect">
+            <a:avLst/>
+          </a:prstGeom>
+          <a:noFill/>
+        </p:spPr>
+        <p:txBody>
+          <a:bodyPr wrap="square" rtlCol="0">
+            <a:spAutoFit/>
+          </a:bodyPr>
+          <a:lstStyle/>
+          <a:p>
+            <a:pPr algn="ctr">
+              <a:lnSpc>
+                <a:spcPct val="150000"/>
+              </a:lnSpc>
+            </a:pPr>
+            <a:r>
+              <a:rPr lang="en-GB" sz="2000" b="1" dirty="0">
+                <a:latin typeface="Cambria" panose="02040503050406030204" pitchFamily="18" charset="0"/>
+                <a:ea typeface="Cambria" panose="02040503050406030204" pitchFamily="18" charset="0"/>
+                <a:hlinkClick r:id="rId4"/>
+              </a:rPr>
+              <a:t>https://github.com/andrebolerbarros/Intro_R</a:t>
+            </a:r>
+            <a:endParaRPr lang="en-GB" sz="2000" b="1" dirty="0">
+              <a:latin typeface="Cambria" panose="02040503050406030204" pitchFamily="18" charset="0"/>
+              <a:ea typeface="Cambria" panose="02040503050406030204" pitchFamily="18" charset="0"/>
+            </a:endParaRPr>
+          </a:p>
+          <a:p>
+            <a:pPr marL="285750" indent="-285750" algn="just">
+              <a:lnSpc>
+                <a:spcPct val="150000"/>
+              </a:lnSpc>
+              <a:buFont typeface="Arial" panose="020B0604020202020204" pitchFamily="34" charset="0"/>
+              <a:buChar char="•"/>
+            </a:pPr>
+            <a:endParaRPr lang="en-GB" sz="2400" b="1" dirty="0">
+              <a:latin typeface="Cambria" panose="02040503050406030204" pitchFamily="18" charset="0"/>
+              <a:ea typeface="Cambria" panose="02040503050406030204" pitchFamily="18" charset="0"/>
+            </a:endParaRPr>
+          </a:p>
+        </p:txBody>
+      </p:sp>
+      <p:pic>
+        <p:nvPicPr>
+          <p:cNvPr id="9" name="Picture 8" descr="A white circle with black background&#10;&#10;Description automatically generated">
+            <a:extLst>
+              <a:ext uri="{FF2B5EF4-FFF2-40B4-BE49-F238E27FC236}">
+                <a16:creationId xmlns:a16="http://schemas.microsoft.com/office/drawing/2014/main" id="{E905D286-EE0C-C040-92B8-B2B74CB328E1}"/>
+              </a:ext>
+            </a:extLst>
+          </p:cNvPr>
+          <p:cNvPicPr>
+            <a:picLocks noChangeAspect="1"/>
+          </p:cNvPicPr>
+          <p:nvPr/>
+        </p:nvPicPr>
+        <p:blipFill>
+          <a:blip r:embed="rId5"/>
+          <a:srcRect t="19605" r="16255" b="22685"/>
+          <a:stretch>
+            <a:fillRect/>
+          </a:stretch>
+        </p:blipFill>
+        <p:spPr>
+          <a:xfrm>
+            <a:off x="-269926" y="6222582"/>
+            <a:ext cx="939853" cy="628211"/>
+          </a:xfrm>
+          <a:prstGeom prst="rect">
+            <a:avLst/>
+          </a:prstGeom>
+        </p:spPr>
+      </p:pic>
+      <p:cxnSp>
+        <p:nvCxnSpPr>
+          <p:cNvPr id="10" name="Straight Connector 9">
+            <a:extLst>
+              <a:ext uri="{FF2B5EF4-FFF2-40B4-BE49-F238E27FC236}">
+                <a16:creationId xmlns:a16="http://schemas.microsoft.com/office/drawing/2014/main" id="{8F78C4AE-9417-F1DA-86EB-39253672D1B4}"/>
+              </a:ext>
+            </a:extLst>
+          </p:cNvPr>
+          <p:cNvCxnSpPr>
+            <a:cxnSpLocks/>
+          </p:cNvCxnSpPr>
+          <p:nvPr/>
+        </p:nvCxnSpPr>
+        <p:spPr>
+          <a:xfrm flipV="1">
+            <a:off x="669927" y="6523348"/>
+            <a:ext cx="10580947" cy="1"/>
+          </a:xfrm>
+          <a:prstGeom prst="line">
+            <a:avLst/>
+          </a:prstGeom>
+          <a:ln>
+            <a:solidFill>
+              <a:schemeClr val="bg1"/>
+            </a:solidFill>
+          </a:ln>
+        </p:spPr>
+        <p:style>
+          <a:lnRef idx="1">
+            <a:schemeClr val="dk1"/>
+          </a:lnRef>
+          <a:fillRef idx="0">
+            <a:schemeClr val="dk1"/>
+          </a:fillRef>
+          <a:effectRef idx="0">
+            <a:schemeClr val="dk1"/>
+          </a:effectRef>
+          <a:fontRef idx="minor">
+            <a:schemeClr val="tx1"/>
+          </a:fontRef>
+        </p:style>
+      </p:cxnSp>
+      <p:sp>
+        <p:nvSpPr>
+          <p:cNvPr id="11" name="Slide Number Placeholder 2">
+            <a:extLst>
+              <a:ext uri="{FF2B5EF4-FFF2-40B4-BE49-F238E27FC236}">
+                <a16:creationId xmlns:a16="http://schemas.microsoft.com/office/drawing/2014/main" id="{A5B35666-5ACA-145A-137C-488E3DF30EF3}"/>
+              </a:ext>
+            </a:extLst>
+          </p:cNvPr>
+          <p:cNvSpPr txBox="1">
+            <a:spLocks/>
+          </p:cNvSpPr>
+          <p:nvPr/>
+        </p:nvSpPr>
+        <p:spPr>
+          <a:xfrm>
+            <a:off x="8804750" y="6337394"/>
+            <a:ext cx="2825475" cy="365125"/>
+          </a:xfrm>
+          <a:prstGeom prst="rect">
+            <a:avLst/>
+          </a:prstGeom>
+        </p:spPr>
+        <p:txBody>
+          <a:bodyPr vert="horz" lIns="91440" tIns="45720" rIns="91440" bIns="45720" rtlCol="0" anchor="ctr"/>
+          <a:lstStyle>
+            <a:defPPr>
+              <a:defRPr lang="en-US"/>
+            </a:defPPr>
+            <a:lvl1pPr marL="0" algn="r" defTabSz="914400" rtl="0" eaLnBrk="1" latinLnBrk="0" hangingPunct="1">
+              <a:defRPr sz="1200" kern="1200">
+                <a:solidFill>
+                  <a:schemeClr val="tx1">
+                    <a:tint val="75000"/>
+                  </a:schemeClr>
+                </a:solidFill>
+                <a:latin typeface="+mn-lt"/>
+                <a:ea typeface="+mn-ea"/>
+                <a:cs typeface="+mn-cs"/>
+              </a:defRPr>
+            </a:lvl1pPr>
+            <a:lvl2pPr marL="457200" algn="l" defTabSz="914400" rtl="0" eaLnBrk="1" latinLnBrk="0" hangingPunct="1">
+              <a:defRPr sz="1800" kern="1200">
+                <a:solidFill>
+                  <a:schemeClr val="tx1"/>
+                </a:solidFill>
+                <a:latin typeface="+mn-lt"/>
+                <a:ea typeface="+mn-ea"/>
+                <a:cs typeface="+mn-cs"/>
+              </a:defRPr>
+            </a:lvl2pPr>
+            <a:lvl3pPr marL="914400" algn="l" defTabSz="914400" rtl="0" eaLnBrk="1" latinLnBrk="0" hangingPunct="1">
+              <a:defRPr sz="1800" kern="1200">
+                <a:solidFill>
+                  <a:schemeClr val="tx1"/>
+                </a:solidFill>
+                <a:latin typeface="+mn-lt"/>
+                <a:ea typeface="+mn-ea"/>
+                <a:cs typeface="+mn-cs"/>
+              </a:defRPr>
+            </a:lvl3pPr>
+            <a:lvl4pPr marL="1371600" algn="l" defTabSz="914400" rtl="0" eaLnBrk="1" latinLnBrk="0" hangingPunct="1">
+              <a:defRPr sz="1800" kern="1200">
+                <a:solidFill>
+                  <a:schemeClr val="tx1"/>
+                </a:solidFill>
+                <a:latin typeface="+mn-lt"/>
+                <a:ea typeface="+mn-ea"/>
+                <a:cs typeface="+mn-cs"/>
+              </a:defRPr>
+            </a:lvl4pPr>
+            <a:lvl5pPr marL="1828800" algn="l" defTabSz="914400" rtl="0" eaLnBrk="1" latinLnBrk="0" hangingPunct="1">
+              <a:defRPr sz="1800" kern="1200">
+                <a:solidFill>
+                  <a:schemeClr val="tx1"/>
+                </a:solidFill>
+                <a:latin typeface="+mn-lt"/>
+                <a:ea typeface="+mn-ea"/>
+                <a:cs typeface="+mn-cs"/>
+              </a:defRPr>
+            </a:lvl5pPr>
+            <a:lvl6pPr marL="2286000" algn="l" defTabSz="914400" rtl="0" eaLnBrk="1" latinLnBrk="0" hangingPunct="1">
+              <a:defRPr sz="1800" kern="1200">
+                <a:solidFill>
+                  <a:schemeClr val="tx1"/>
+                </a:solidFill>
+                <a:latin typeface="+mn-lt"/>
+                <a:ea typeface="+mn-ea"/>
+                <a:cs typeface="+mn-cs"/>
+              </a:defRPr>
+            </a:lvl6pPr>
+            <a:lvl7pPr marL="2743200" algn="l" defTabSz="914400" rtl="0" eaLnBrk="1" latinLnBrk="0" hangingPunct="1">
+              <a:defRPr sz="1800" kern="1200">
+                <a:solidFill>
+                  <a:schemeClr val="tx1"/>
+                </a:solidFill>
+                <a:latin typeface="+mn-lt"/>
+                <a:ea typeface="+mn-ea"/>
+                <a:cs typeface="+mn-cs"/>
+              </a:defRPr>
+            </a:lvl7pPr>
+            <a:lvl8pPr marL="3200400" algn="l" defTabSz="914400" rtl="0" eaLnBrk="1" latinLnBrk="0" hangingPunct="1">
+              <a:defRPr sz="1800" kern="1200">
+                <a:solidFill>
+                  <a:schemeClr val="tx1"/>
+                </a:solidFill>
+                <a:latin typeface="+mn-lt"/>
+                <a:ea typeface="+mn-ea"/>
+                <a:cs typeface="+mn-cs"/>
+              </a:defRPr>
+            </a:lvl8pPr>
+            <a:lvl9pPr marL="3657600" algn="l" defTabSz="914400" rtl="0" eaLnBrk="1" latinLnBrk="0" hangingPunct="1">
+              <a:defRPr sz="1800" kern="1200">
+                <a:solidFill>
+                  <a:schemeClr val="tx1"/>
+                </a:solidFill>
+                <a:latin typeface="+mn-lt"/>
+                <a:ea typeface="+mn-ea"/>
+                <a:cs typeface="+mn-cs"/>
+              </a:defRPr>
+            </a:lvl9pPr>
+          </a:lstStyle>
+          <a:p>
+            <a:fld id="{54B21BD1-F593-4F4E-86E9-52991719DFB8}" type="slidenum">
+              <a:rPr lang="en-GB" sz="1400" noProof="0" smtClean="0">
+                <a:solidFill>
+                  <a:schemeClr val="bg1"/>
+                </a:solidFill>
+                <a:latin typeface="Cambria" panose="02040503050406030204" pitchFamily="18" charset="0"/>
+                <a:ea typeface="Cambria" panose="02040503050406030204" pitchFamily="18" charset="0"/>
+              </a:rPr>
+              <a:pPr/>
+              <a:t>10</a:t>
+            </a:fld>
+            <a:endParaRPr lang="en-GB" sz="1400" noProof="0" dirty="0">
+              <a:solidFill>
+                <a:schemeClr val="bg1"/>
+              </a:solidFill>
+              <a:latin typeface="Cambria" panose="02040503050406030204" pitchFamily="18" charset="0"/>
+              <a:ea typeface="Cambria" panose="02040503050406030204" pitchFamily="18" charset="0"/>
+            </a:endParaRPr>
+          </a:p>
+        </p:txBody>
+      </p:sp>
+      <p:sp>
+        <p:nvSpPr>
+          <p:cNvPr id="12" name="TextBox 11">
+            <a:extLst>
+              <a:ext uri="{FF2B5EF4-FFF2-40B4-BE49-F238E27FC236}">
+                <a16:creationId xmlns:a16="http://schemas.microsoft.com/office/drawing/2014/main" id="{EA75DBE1-F078-0DA9-4E9E-0394D868FED0}"/>
+              </a:ext>
+            </a:extLst>
+          </p:cNvPr>
+          <p:cNvSpPr txBox="1"/>
+          <p:nvPr/>
+        </p:nvSpPr>
+        <p:spPr>
+          <a:xfrm>
+            <a:off x="3870960" y="6451133"/>
+            <a:ext cx="4450080" cy="335092"/>
+          </a:xfrm>
+          <a:prstGeom prst="rect">
+            <a:avLst/>
+          </a:prstGeom>
+          <a:noFill/>
+        </p:spPr>
+        <p:txBody>
+          <a:bodyPr wrap="square" rtlCol="0">
+            <a:spAutoFit/>
+          </a:bodyPr>
+          <a:lstStyle/>
+          <a:p>
+            <a:pPr defTabSz="825500">
+              <a:lnSpc>
+                <a:spcPct val="150000"/>
+              </a:lnSpc>
+              <a:tabLst>
+                <a:tab pos="3768725" algn="l"/>
+                <a:tab pos="4572000" algn="l"/>
+              </a:tabLst>
+            </a:pPr>
+            <a:r>
+              <a:rPr lang="en-GB" sz="1200" noProof="0" dirty="0">
+                <a:solidFill>
+                  <a:schemeClr val="bg1"/>
+                </a:solidFill>
+                <a:latin typeface="Cambria" panose="02040503050406030204" pitchFamily="18" charset="0"/>
+                <a:ea typeface="Cambria" panose="02040503050406030204" pitchFamily="18" charset="0"/>
+                <a:cs typeface="Times New Roman" panose="02020603050405020304" pitchFamily="18" charset="0"/>
+              </a:rPr>
+              <a:t>André Barros | Advanced Data Analysis | 12th January 2026</a:t>
+            </a:r>
+            <a:endParaRPr lang="en-GB" sz="1200" i="1" noProof="0" dirty="0">
+              <a:solidFill>
+                <a:schemeClr val="bg1"/>
+              </a:solidFill>
+              <a:latin typeface="Cambria" panose="02040503050406030204" pitchFamily="18" charset="0"/>
+              <a:ea typeface="Cambria" panose="02040503050406030204" pitchFamily="18" charset="0"/>
+              <a:cs typeface="Times New Roman" panose="02020603050405020304" pitchFamily="18" charset="0"/>
+            </a:endParaRPr>
+          </a:p>
+        </p:txBody>
+      </p:sp>
+      <p:pic>
+        <p:nvPicPr>
+          <p:cNvPr id="14" name="Picture 13">
+            <a:extLst>
+              <a:ext uri="{FF2B5EF4-FFF2-40B4-BE49-F238E27FC236}">
+                <a16:creationId xmlns:a16="http://schemas.microsoft.com/office/drawing/2014/main" id="{9350AA1C-B10F-C701-8C08-C1EBF0415725}"/>
+              </a:ext>
+            </a:extLst>
+          </p:cNvPr>
+          <p:cNvPicPr>
+            <a:picLocks noChangeAspect="1"/>
+          </p:cNvPicPr>
+          <p:nvPr/>
+        </p:nvPicPr>
+        <p:blipFill>
+          <a:blip r:embed="rId6"/>
+          <a:srcRect l="22765" t="18648" r="25605" b="15789"/>
+          <a:stretch>
+            <a:fillRect/>
+          </a:stretch>
+        </p:blipFill>
+        <p:spPr>
+          <a:xfrm>
+            <a:off x="11581065" y="6281675"/>
+            <a:ext cx="425229" cy="540000"/>
+          </a:xfrm>
+          <a:prstGeom prst="rect">
+            <a:avLst/>
+          </a:prstGeom>
+        </p:spPr>
+      </p:pic>
+      <p:sp>
+        <p:nvSpPr>
+          <p:cNvPr id="4" name="TextBox 3">
+            <a:extLst>
+              <a:ext uri="{FF2B5EF4-FFF2-40B4-BE49-F238E27FC236}">
+                <a16:creationId xmlns:a16="http://schemas.microsoft.com/office/drawing/2014/main" id="{B1EEA1FE-0E17-6AD1-2AFA-014911C1B9A6}"/>
+              </a:ext>
+            </a:extLst>
+          </p:cNvPr>
+          <p:cNvSpPr txBox="1"/>
+          <p:nvPr/>
+        </p:nvSpPr>
+        <p:spPr>
+          <a:xfrm>
+            <a:off x="222110" y="1529798"/>
+            <a:ext cx="11747779" cy="456472"/>
+          </a:xfrm>
+          <a:prstGeom prst="rect">
+            <a:avLst/>
+          </a:prstGeom>
+          <a:noFill/>
+        </p:spPr>
+        <p:txBody>
+          <a:bodyPr wrap="square" rtlCol="0">
+            <a:spAutoFit/>
+          </a:bodyPr>
+          <a:lstStyle/>
+          <a:p>
+            <a:pPr algn="just">
+              <a:lnSpc>
+                <a:spcPct val="150000"/>
+              </a:lnSpc>
+              <a:tabLst>
+                <a:tab pos="447675" algn="l"/>
+              </a:tabLst>
+            </a:pPr>
+            <a:r>
+              <a:rPr lang="en-GB" dirty="0">
+                <a:latin typeface="Cambria" panose="02040503050406030204" pitchFamily="18" charset="0"/>
+                <a:ea typeface="Cambria" panose="02040503050406030204" pitchFamily="18" charset="0"/>
+              </a:rPr>
+              <a:t>3.	Change kernel (language)</a:t>
+            </a:r>
+            <a:endParaRPr lang="en-GB" sz="2400" b="1" dirty="0">
+              <a:latin typeface="Cambria" panose="02040503050406030204" pitchFamily="18" charset="0"/>
+              <a:ea typeface="Cambria" panose="02040503050406030204" pitchFamily="18" charset="0"/>
+            </a:endParaRPr>
+          </a:p>
+        </p:txBody>
+      </p:sp>
+      <p:sp>
+        <p:nvSpPr>
+          <p:cNvPr id="15" name="Rectangle: Rounded Corners 14">
+            <a:extLst>
+              <a:ext uri="{FF2B5EF4-FFF2-40B4-BE49-F238E27FC236}">
+                <a16:creationId xmlns:a16="http://schemas.microsoft.com/office/drawing/2014/main" id="{6478EFC7-F045-7079-8000-5B1307E810E4}"/>
+              </a:ext>
+            </a:extLst>
+          </p:cNvPr>
+          <p:cNvSpPr/>
+          <p:nvPr/>
+        </p:nvSpPr>
+        <p:spPr>
+          <a:xfrm>
+            <a:off x="1879960" y="4441372"/>
+            <a:ext cx="1153235" cy="206256"/>
+          </a:xfrm>
+          <a:prstGeom prst="roundRect">
+            <a:avLst/>
+          </a:prstGeom>
+          <a:noFill/>
+          <a:ln>
+            <a:solidFill>
+              <a:srgbClr val="C00000"/>
+            </a:solidFill>
+          </a:ln>
+        </p:spPr>
+        <p:style>
+          <a:lnRef idx="2">
+            <a:schemeClr val="accent1">
+              <a:shade val="15000"/>
+            </a:schemeClr>
+          </a:lnRef>
+          <a:fillRef idx="1">
+            <a:schemeClr val="accent1"/>
+          </a:fillRef>
+          <a:effectRef idx="0">
+            <a:schemeClr val="accent1"/>
+          </a:effectRef>
+          <a:fontRef idx="minor">
+            <a:schemeClr val="lt1"/>
+          </a:fontRef>
+        </p:style>
+        <p:txBody>
+          <a:bodyPr rtlCol="0" anchor="ctr"/>
+          <a:lstStyle/>
+          <a:p>
+            <a:pPr algn="ctr"/>
+            <a:endParaRPr lang="pt-PT"/>
+          </a:p>
+        </p:txBody>
+      </p:sp>
+      <p:pic>
+        <p:nvPicPr>
+          <p:cNvPr id="3" name="Picture 2">
+            <a:extLst>
+              <a:ext uri="{FF2B5EF4-FFF2-40B4-BE49-F238E27FC236}">
+                <a16:creationId xmlns:a16="http://schemas.microsoft.com/office/drawing/2014/main" id="{EAC31A07-C2E3-BA9B-D4A0-5DFF260C4AC0}"/>
+              </a:ext>
+            </a:extLst>
+          </p:cNvPr>
+          <p:cNvPicPr>
+            <a:picLocks noChangeAspect="1"/>
+          </p:cNvPicPr>
+          <p:nvPr/>
+        </p:nvPicPr>
+        <p:blipFill>
+          <a:blip r:embed="rId7"/>
+          <a:srcRect b="13023"/>
+          <a:stretch>
+            <a:fillRect/>
+          </a:stretch>
+        </p:blipFill>
+        <p:spPr>
+          <a:xfrm>
+            <a:off x="4249744" y="2100727"/>
+            <a:ext cx="3092693" cy="2450647"/>
+          </a:xfrm>
+          <a:prstGeom prst="rect">
+            <a:avLst/>
+          </a:prstGeom>
+        </p:spPr>
+      </p:pic>
+      <p:sp>
+        <p:nvSpPr>
+          <p:cNvPr id="5" name="Rectangle: Rounded Corners 4">
+            <a:extLst>
+              <a:ext uri="{FF2B5EF4-FFF2-40B4-BE49-F238E27FC236}">
+                <a16:creationId xmlns:a16="http://schemas.microsoft.com/office/drawing/2014/main" id="{3AF94B33-A8EB-1EDE-6D11-70FD40963897}"/>
+              </a:ext>
+            </a:extLst>
+          </p:cNvPr>
+          <p:cNvSpPr/>
+          <p:nvPr/>
+        </p:nvSpPr>
+        <p:spPr>
+          <a:xfrm>
+            <a:off x="4321798" y="2554884"/>
+            <a:ext cx="1240229" cy="377153"/>
+          </a:xfrm>
+          <a:prstGeom prst="roundRect">
+            <a:avLst/>
+          </a:prstGeom>
+          <a:noFill/>
+          <a:ln>
+            <a:solidFill>
+              <a:srgbClr val="C00000"/>
+            </a:solidFill>
+          </a:ln>
+        </p:spPr>
+        <p:style>
+          <a:lnRef idx="2">
+            <a:schemeClr val="accent1">
+              <a:shade val="15000"/>
+            </a:schemeClr>
+          </a:lnRef>
+          <a:fillRef idx="1">
+            <a:schemeClr val="accent1"/>
+          </a:fillRef>
+          <a:effectRef idx="0">
+            <a:schemeClr val="accent1"/>
+          </a:effectRef>
+          <a:fontRef idx="minor">
+            <a:schemeClr val="lt1"/>
+          </a:fontRef>
+        </p:style>
+        <p:txBody>
+          <a:bodyPr rtlCol="0" anchor="ctr"/>
+          <a:lstStyle/>
+          <a:p>
+            <a:pPr algn="ctr"/>
+            <a:endParaRPr lang="pt-PT"/>
+          </a:p>
+        </p:txBody>
+      </p:sp>
+    </p:spTree>
+    <p:extLst>
+      <p:ext uri="{BB962C8B-B14F-4D97-AF65-F5344CB8AC3E}">
+        <p14:creationId xmlns:p14="http://schemas.microsoft.com/office/powerpoint/2010/main" val="3811760795"/>
+      </p:ext>
+    </p:extLst>
+  </p:cSld>
+  <p:clrMapOvr>
+    <a:masterClrMapping/>
+  </p:clrMapOvr>
+</p:sld>
+</file>
+
 <file path=ppt/slides/slide2.xml><?xml version="1.0" encoding="utf-8"?>
 <p:sld xmlns:a="http://schemas.openxmlformats.org/drawingml/2006/main" xmlns:r="http://schemas.openxmlformats.org/officeDocument/2006/relationships" xmlns:p="http://schemas.openxmlformats.org/presentationml/2006/main">
   <p:cSld>
@@ -7281,7 +8334,7 @@
         <p:cNvPr id="1" name="">
           <a:extLst>
             <a:ext uri="{FF2B5EF4-FFF2-40B4-BE49-F238E27FC236}">
-              <a16:creationId xmlns:a16="http://schemas.microsoft.com/office/drawing/2014/main" id="{41B03D2A-E05D-784C-AB79-877EE1C75007}"/>
+              <a16:creationId xmlns:a16="http://schemas.microsoft.com/office/drawing/2014/main" id="{89C75C42-3AAC-CE32-C4A6-6AD1B56095D8}"/>
             </a:ext>
           </a:extLst>
         </p:cNvPr>
@@ -7301,7 +8354,7 @@
           <p:cNvPr id="7" name="TextBox 6">
             <a:extLst>
               <a:ext uri="{FF2B5EF4-FFF2-40B4-BE49-F238E27FC236}">
-                <a16:creationId xmlns:a16="http://schemas.microsoft.com/office/drawing/2014/main" id="{17481CE0-F07B-F803-7223-D798EA199F0B}"/>
+                <a16:creationId xmlns:a16="http://schemas.microsoft.com/office/drawing/2014/main" id="{2CBD5C0E-B191-89ED-BF68-0C52AA475FB8}"/>
               </a:ext>
             </a:extLst>
           </p:cNvPr>
@@ -7333,7 +8386,7 @@
                 <a:ea typeface="Cambria" panose="02040503050406030204" pitchFamily="18" charset="0"/>
                 <a:cs typeface="Times New Roman" panose="02020603050405020304" pitchFamily="18" charset="0"/>
               </a:rPr>
-              <a:t>Course Material</a:t>
+              <a:t>Why R</a:t>
             </a:r>
           </a:p>
         </p:txBody>
@@ -7343,7 +8396,7 @@
           <p:cNvPr id="13" name="TextBox 12">
             <a:extLst>
               <a:ext uri="{FF2B5EF4-FFF2-40B4-BE49-F238E27FC236}">
-                <a16:creationId xmlns:a16="http://schemas.microsoft.com/office/drawing/2014/main" id="{B6AC6DE2-2E99-4842-94A4-942D9ADDA612}"/>
+                <a16:creationId xmlns:a16="http://schemas.microsoft.com/office/drawing/2014/main" id="{15F6DF6B-565A-2C86-7804-F86B08013386}"/>
               </a:ext>
             </a:extLst>
           </p:cNvPr>
@@ -7353,7 +8406,7 @@
         <p:spPr>
           <a:xfrm>
             <a:off x="222111" y="800107"/>
-            <a:ext cx="11747779" cy="1039452"/>
+            <a:ext cx="11747779" cy="3809441"/>
           </a:xfrm>
           <a:prstGeom prst="rect">
             <a:avLst/>
@@ -7366,32 +8419,112 @@
           </a:bodyPr>
           <a:lstStyle/>
           <a:p>
-            <a:pPr algn="ctr">
-              <a:lnSpc>
-                <a:spcPct val="150000"/>
-              </a:lnSpc>
-            </a:pPr>
-            <a:r>
-              <a:rPr lang="en-GB" sz="2000" b="1" dirty="0">
-                <a:latin typeface="Cambria" panose="02040503050406030204" pitchFamily="18" charset="0"/>
-                <a:ea typeface="Cambria" panose="02040503050406030204" pitchFamily="18" charset="0"/>
-                <a:hlinkClick r:id="rId3"/>
-              </a:rPr>
-              <a:t>https://github.com/andrebolerbarros/Intro_R</a:t>
-            </a:r>
-            <a:endParaRPr lang="en-GB" sz="2000" b="1" dirty="0">
-              <a:latin typeface="Cambria" panose="02040503050406030204" pitchFamily="18" charset="0"/>
-              <a:ea typeface="Cambria" panose="02040503050406030204" pitchFamily="18" charset="0"/>
-            </a:endParaRPr>
-          </a:p>
-          <a:p>
-            <a:pPr marL="285750" indent="-285750" algn="just">
+            <a:pPr marL="268288" lvl="1" indent="-268288" algn="just">
               <a:lnSpc>
                 <a:spcPct val="150000"/>
               </a:lnSpc>
               <a:buFont typeface="Arial" panose="020B0604020202020204" pitchFamily="34" charset="0"/>
               <a:buChar char="•"/>
             </a:pPr>
+            <a:endParaRPr lang="en-GB" sz="2000" noProof="0" dirty="0">
+              <a:latin typeface="Cambria" panose="02040503050406030204" pitchFamily="18" charset="0"/>
+              <a:ea typeface="Cambria" panose="02040503050406030204" pitchFamily="18" charset="0"/>
+            </a:endParaRPr>
+          </a:p>
+          <a:p>
+            <a:pPr marL="268288" lvl="1" indent="-268288" algn="just">
+              <a:lnSpc>
+                <a:spcPct val="150000"/>
+              </a:lnSpc>
+              <a:buFont typeface="Arial" panose="020B0604020202020204" pitchFamily="34" charset="0"/>
+              <a:buChar char="•"/>
+            </a:pPr>
+            <a:endParaRPr lang="en-GB" sz="2000" dirty="0">
+              <a:latin typeface="Cambria" panose="02040503050406030204" pitchFamily="18" charset="0"/>
+              <a:ea typeface="Cambria" panose="02040503050406030204" pitchFamily="18" charset="0"/>
+            </a:endParaRPr>
+          </a:p>
+          <a:p>
+            <a:pPr marL="268288" lvl="1" indent="-268288" algn="just">
+              <a:lnSpc>
+                <a:spcPct val="150000"/>
+              </a:lnSpc>
+              <a:buFont typeface="Arial" panose="020B0604020202020204" pitchFamily="34" charset="0"/>
+              <a:buChar char="•"/>
+            </a:pPr>
+            <a:r>
+              <a:rPr lang="en-GB" sz="2000" noProof="0" dirty="0">
+                <a:latin typeface="Cambria" panose="02040503050406030204" pitchFamily="18" charset="0"/>
+                <a:ea typeface="Cambria" panose="02040503050406030204" pitchFamily="18" charset="0"/>
+              </a:rPr>
+              <a:t>Statistical Analysis &amp; Data Visualization</a:t>
+            </a:r>
+          </a:p>
+          <a:p>
+            <a:pPr marL="268288" lvl="1" indent="-268288" algn="just">
+              <a:lnSpc>
+                <a:spcPct val="150000"/>
+              </a:lnSpc>
+              <a:buFont typeface="Arial" panose="020B0604020202020204" pitchFamily="34" charset="0"/>
+              <a:buChar char="•"/>
+            </a:pPr>
+            <a:r>
+              <a:rPr lang="en-GB" sz="2000" dirty="0">
+                <a:latin typeface="Cambria" panose="02040503050406030204" pitchFamily="18" charset="0"/>
+                <a:ea typeface="Cambria" panose="02040503050406030204" pitchFamily="18" charset="0"/>
+              </a:rPr>
+              <a:t>Free-to-use, Open Source</a:t>
+            </a:r>
+          </a:p>
+          <a:p>
+            <a:pPr marL="268288" lvl="1" indent="-268288" algn="just">
+              <a:lnSpc>
+                <a:spcPct val="150000"/>
+              </a:lnSpc>
+              <a:buFont typeface="Arial" panose="020B0604020202020204" pitchFamily="34" charset="0"/>
+              <a:buChar char="•"/>
+            </a:pPr>
+            <a:r>
+              <a:rPr lang="en-GB" sz="2000" dirty="0">
+                <a:latin typeface="Cambria" panose="02040503050406030204" pitchFamily="18" charset="0"/>
+                <a:ea typeface="Cambria" panose="02040503050406030204" pitchFamily="18" charset="0"/>
+              </a:rPr>
+              <a:t>Thousands of curated &amp; up-to-date packages</a:t>
+            </a:r>
+          </a:p>
+          <a:p>
+            <a:pPr marL="268288" lvl="1" indent="-268288" algn="just">
+              <a:lnSpc>
+                <a:spcPct val="150000"/>
+              </a:lnSpc>
+              <a:buFont typeface="Arial" panose="020B0604020202020204" pitchFamily="34" charset="0"/>
+              <a:buChar char="•"/>
+            </a:pPr>
+            <a:endParaRPr lang="en-GB" sz="2000" dirty="0">
+              <a:latin typeface="Cambria" panose="02040503050406030204" pitchFamily="18" charset="0"/>
+              <a:ea typeface="Cambria" panose="02040503050406030204" pitchFamily="18" charset="0"/>
+            </a:endParaRPr>
+          </a:p>
+          <a:p>
+            <a:pPr marL="0" lvl="1" algn="just">
+              <a:lnSpc>
+                <a:spcPct val="150000"/>
+              </a:lnSpc>
+            </a:pPr>
+            <a:r>
+              <a:rPr lang="en-GB" sz="2000" b="1" dirty="0">
+                <a:latin typeface="Cambria" panose="02040503050406030204" pitchFamily="18" charset="0"/>
+                <a:ea typeface="Cambria" panose="02040503050406030204" pitchFamily="18" charset="0"/>
+              </a:rPr>
+              <a:t>Integrated Development Environment (IDE)</a:t>
+            </a:r>
+          </a:p>
+          <a:p>
+            <a:pPr algn="just">
+              <a:lnSpc>
+                <a:spcPct val="150000"/>
+              </a:lnSpc>
+            </a:pPr>
             <a:endParaRPr lang="en-GB" sz="2400" b="1" dirty="0">
               <a:latin typeface="Cambria" panose="02040503050406030204" pitchFamily="18" charset="0"/>
               <a:ea typeface="Cambria" panose="02040503050406030204" pitchFamily="18" charset="0"/>
@@ -7404,7 +8537,7 @@
           <p:cNvPr id="9" name="Picture 8" descr="A white circle with black background&#10;&#10;Description automatically generated">
             <a:extLst>
               <a:ext uri="{FF2B5EF4-FFF2-40B4-BE49-F238E27FC236}">
-                <a16:creationId xmlns:a16="http://schemas.microsoft.com/office/drawing/2014/main" id="{54D672F2-7EB4-9D78-3451-D57F25CBA19D}"/>
+                <a16:creationId xmlns:a16="http://schemas.microsoft.com/office/drawing/2014/main" id="{B2819DE6-CF24-6B35-8E74-3E8EF04DA706}"/>
               </a:ext>
             </a:extLst>
           </p:cNvPr>
@@ -7414,7 +8547,7 @@
           <p:nvPr/>
         </p:nvPicPr>
         <p:blipFill>
-          <a:blip r:embed="rId4"/>
+          <a:blip r:embed="rId3"/>
           <a:srcRect t="19605" r="16255" b="22685"/>
           <a:stretch>
             <a:fillRect/>
@@ -7435,7 +8568,7 @@
           <p:cNvPr id="10" name="Straight Connector 9">
             <a:extLst>
               <a:ext uri="{FF2B5EF4-FFF2-40B4-BE49-F238E27FC236}">
-                <a16:creationId xmlns:a16="http://schemas.microsoft.com/office/drawing/2014/main" id="{C297771C-30AF-60EA-4E3A-110E1C668F48}"/>
+                <a16:creationId xmlns:a16="http://schemas.microsoft.com/office/drawing/2014/main" id="{C8711B6B-7683-AB7F-AD2D-6A9DCC7B528B}"/>
               </a:ext>
             </a:extLst>
           </p:cNvPr>
@@ -7478,7 +8611,7 @@
           <p:cNvPr id="11" name="Slide Number Placeholder 2">
             <a:extLst>
               <a:ext uri="{FF2B5EF4-FFF2-40B4-BE49-F238E27FC236}">
-                <a16:creationId xmlns:a16="http://schemas.microsoft.com/office/drawing/2014/main" id="{8F4B6486-8CD6-6307-4718-2E4143CAFD9E}"/>
+                <a16:creationId xmlns:a16="http://schemas.microsoft.com/office/drawing/2014/main" id="{546160FC-3C43-22B8-E8AC-18FEDD721D6B}"/>
               </a:ext>
             </a:extLst>
           </p:cNvPr>
@@ -7606,6 +8739,1338 @@
               </a:rPr>
               <a:pPr/>
               <a:t>5</a:t>
+            </a:fld>
+            <a:endParaRPr lang="en-GB" sz="1400" noProof="0" dirty="0">
+              <a:solidFill>
+                <a:schemeClr val="bg1"/>
+              </a:solidFill>
+              <a:latin typeface="Cambria" panose="02040503050406030204" pitchFamily="18" charset="0"/>
+              <a:ea typeface="Cambria" panose="02040503050406030204" pitchFamily="18" charset="0"/>
+            </a:endParaRPr>
+          </a:p>
+        </p:txBody>
+      </p:sp>
+      <p:sp>
+        <p:nvSpPr>
+          <p:cNvPr id="12" name="TextBox 11">
+            <a:extLst>
+              <a:ext uri="{FF2B5EF4-FFF2-40B4-BE49-F238E27FC236}">
+                <a16:creationId xmlns:a16="http://schemas.microsoft.com/office/drawing/2014/main" id="{94EDFD33-EB61-FA2C-9AE4-97BCA9403651}"/>
+              </a:ext>
+            </a:extLst>
+          </p:cNvPr>
+          <p:cNvSpPr txBox="1"/>
+          <p:nvPr/>
+        </p:nvSpPr>
+        <p:spPr>
+          <a:xfrm>
+            <a:off x="3870960" y="6451133"/>
+            <a:ext cx="4450080" cy="335092"/>
+          </a:xfrm>
+          <a:prstGeom prst="rect">
+            <a:avLst/>
+          </a:prstGeom>
+          <a:noFill/>
+        </p:spPr>
+        <p:txBody>
+          <a:bodyPr wrap="square" rtlCol="0">
+            <a:spAutoFit/>
+          </a:bodyPr>
+          <a:lstStyle/>
+          <a:p>
+            <a:pPr defTabSz="825500">
+              <a:lnSpc>
+                <a:spcPct val="150000"/>
+              </a:lnSpc>
+              <a:tabLst>
+                <a:tab pos="3768725" algn="l"/>
+                <a:tab pos="4572000" algn="l"/>
+              </a:tabLst>
+            </a:pPr>
+            <a:r>
+              <a:rPr lang="en-GB" sz="1200" noProof="0" dirty="0">
+                <a:solidFill>
+                  <a:schemeClr val="bg1"/>
+                </a:solidFill>
+                <a:latin typeface="Cambria" panose="02040503050406030204" pitchFamily="18" charset="0"/>
+                <a:ea typeface="Cambria" panose="02040503050406030204" pitchFamily="18" charset="0"/>
+                <a:cs typeface="Times New Roman" panose="02020603050405020304" pitchFamily="18" charset="0"/>
+              </a:rPr>
+              <a:t>André Barros | Advanced Data Analysis | 12th January 2026</a:t>
+            </a:r>
+            <a:endParaRPr lang="en-GB" sz="1200" i="1" noProof="0" dirty="0">
+              <a:solidFill>
+                <a:schemeClr val="bg1"/>
+              </a:solidFill>
+              <a:latin typeface="Cambria" panose="02040503050406030204" pitchFamily="18" charset="0"/>
+              <a:ea typeface="Cambria" panose="02040503050406030204" pitchFamily="18" charset="0"/>
+              <a:cs typeface="Times New Roman" panose="02020603050405020304" pitchFamily="18" charset="0"/>
+            </a:endParaRPr>
+          </a:p>
+        </p:txBody>
+      </p:sp>
+      <p:pic>
+        <p:nvPicPr>
+          <p:cNvPr id="14" name="Picture 13">
+            <a:extLst>
+              <a:ext uri="{FF2B5EF4-FFF2-40B4-BE49-F238E27FC236}">
+                <a16:creationId xmlns:a16="http://schemas.microsoft.com/office/drawing/2014/main" id="{E8E8A257-8B6A-56D0-CC17-32F41C752189}"/>
+              </a:ext>
+            </a:extLst>
+          </p:cNvPr>
+          <p:cNvPicPr>
+            <a:picLocks noChangeAspect="1"/>
+          </p:cNvPicPr>
+          <p:nvPr/>
+        </p:nvPicPr>
+        <p:blipFill>
+          <a:blip r:embed="rId4"/>
+          <a:srcRect l="22765" t="18648" r="25605" b="15789"/>
+          <a:stretch>
+            <a:fillRect/>
+          </a:stretch>
+        </p:blipFill>
+        <p:spPr>
+          <a:xfrm>
+            <a:off x="11581065" y="6281675"/>
+            <a:ext cx="425229" cy="540000"/>
+          </a:xfrm>
+          <a:prstGeom prst="rect">
+            <a:avLst/>
+          </a:prstGeom>
+        </p:spPr>
+      </p:pic>
+      <p:pic>
+        <p:nvPicPr>
+          <p:cNvPr id="1026" name="Picture 2" descr="R: R Logo">
+            <a:extLst>
+              <a:ext uri="{FF2B5EF4-FFF2-40B4-BE49-F238E27FC236}">
+                <a16:creationId xmlns:a16="http://schemas.microsoft.com/office/drawing/2014/main" id="{BFE5A4A4-73A9-8389-674C-30A99DC66538}"/>
+              </a:ext>
+            </a:extLst>
+          </p:cNvPr>
+          <p:cNvPicPr>
+            <a:picLocks noChangeAspect="1" noChangeArrowheads="1"/>
+          </p:cNvPicPr>
+          <p:nvPr/>
+        </p:nvPicPr>
+        <p:blipFill>
+          <a:blip r:embed="rId5">
+            <a:extLst>
+              <a:ext uri="{28A0092B-C50C-407E-A947-70E740481C1C}">
+                <a14:useLocalDpi xmlns:a14="http://schemas.microsoft.com/office/drawing/2010/main" val="0"/>
+              </a:ext>
+            </a:extLst>
+          </a:blip>
+          <a:srcRect/>
+          <a:stretch>
+            <a:fillRect/>
+          </a:stretch>
+        </p:blipFill>
+        <p:spPr bwMode="auto">
+          <a:xfrm>
+            <a:off x="318096" y="885541"/>
+            <a:ext cx="927304" cy="718661"/>
+          </a:xfrm>
+          <a:prstGeom prst="rect">
+            <a:avLst/>
+          </a:prstGeom>
+          <a:noFill/>
+          <a:extLst>
+            <a:ext uri="{909E8E84-426E-40DD-AFC4-6F175D3DCCD1}">
+              <a14:hiddenFill xmlns:a14="http://schemas.microsoft.com/office/drawing/2010/main">
+                <a:solidFill>
+                  <a:srgbClr val="FFFFFF"/>
+                </a:solidFill>
+              </a14:hiddenFill>
+            </a:ext>
+          </a:extLst>
+        </p:spPr>
+      </p:pic>
+      <p:pic>
+        <p:nvPicPr>
+          <p:cNvPr id="4" name="Picture 3">
+            <a:extLst>
+              <a:ext uri="{FF2B5EF4-FFF2-40B4-BE49-F238E27FC236}">
+                <a16:creationId xmlns:a16="http://schemas.microsoft.com/office/drawing/2014/main" id="{4329CB09-8782-CB6B-ADFE-01EE10DC66A3}"/>
+              </a:ext>
+            </a:extLst>
+          </p:cNvPr>
+          <p:cNvPicPr>
+            <a:picLocks noChangeAspect="1"/>
+          </p:cNvPicPr>
+          <p:nvPr/>
+        </p:nvPicPr>
+        <p:blipFill>
+          <a:blip r:embed="rId6"/>
+          <a:stretch>
+            <a:fillRect/>
+          </a:stretch>
+        </p:blipFill>
+        <p:spPr>
+          <a:xfrm>
+            <a:off x="3309773" y="4395442"/>
+            <a:ext cx="1289078" cy="1494256"/>
+          </a:xfrm>
+          <a:prstGeom prst="rect">
+            <a:avLst/>
+          </a:prstGeom>
+        </p:spPr>
+      </p:pic>
+      <p:grpSp>
+        <p:nvGrpSpPr>
+          <p:cNvPr id="6" name="Group 5">
+            <a:extLst>
+              <a:ext uri="{FF2B5EF4-FFF2-40B4-BE49-F238E27FC236}">
+                <a16:creationId xmlns:a16="http://schemas.microsoft.com/office/drawing/2014/main" id="{E6E2C7C7-18F0-DC25-8049-76CD99F76829}"/>
+              </a:ext>
+            </a:extLst>
+          </p:cNvPr>
+          <p:cNvGrpSpPr/>
+          <p:nvPr/>
+        </p:nvGrpSpPr>
+        <p:grpSpPr>
+          <a:xfrm>
+            <a:off x="669927" y="4188724"/>
+            <a:ext cx="2164300" cy="1907693"/>
+            <a:chOff x="669927" y="4188724"/>
+            <a:chExt cx="2164300" cy="1907693"/>
+          </a:xfrm>
+        </p:grpSpPr>
+        <p:pic>
+          <p:nvPicPr>
+            <p:cNvPr id="3" name="Picture 2">
+              <a:extLst>
+                <a:ext uri="{FF2B5EF4-FFF2-40B4-BE49-F238E27FC236}">
+                  <a16:creationId xmlns:a16="http://schemas.microsoft.com/office/drawing/2014/main" id="{452ABECC-5D4F-82E9-9130-B858FC0DF1E3}"/>
+                </a:ext>
+              </a:extLst>
+            </p:cNvPr>
+            <p:cNvPicPr>
+              <a:picLocks noChangeAspect="1"/>
+            </p:cNvPicPr>
+            <p:nvPr/>
+          </p:nvPicPr>
+          <p:blipFill>
+            <a:blip r:embed="rId7"/>
+            <a:srcRect t="32456" b="32887"/>
+            <a:stretch>
+              <a:fillRect/>
+            </a:stretch>
+          </p:blipFill>
+          <p:spPr>
+            <a:xfrm>
+              <a:off x="669927" y="4188724"/>
+              <a:ext cx="2164300" cy="750077"/>
+            </a:xfrm>
+            <a:prstGeom prst="rect">
+              <a:avLst/>
+            </a:prstGeom>
+          </p:spPr>
+        </p:pic>
+        <p:pic>
+          <p:nvPicPr>
+            <p:cNvPr id="5" name="Picture 4">
+              <a:extLst>
+                <a:ext uri="{FF2B5EF4-FFF2-40B4-BE49-F238E27FC236}">
+                  <a16:creationId xmlns:a16="http://schemas.microsoft.com/office/drawing/2014/main" id="{86F33D38-5AAF-F757-6592-34C22401BA5F}"/>
+                </a:ext>
+              </a:extLst>
+            </p:cNvPr>
+            <p:cNvPicPr>
+              <a:picLocks noChangeAspect="1"/>
+            </p:cNvPicPr>
+            <p:nvPr/>
+          </p:nvPicPr>
+          <p:blipFill>
+            <a:blip r:embed="rId8"/>
+            <a:stretch>
+              <a:fillRect/>
+            </a:stretch>
+          </p:blipFill>
+          <p:spPr>
+            <a:xfrm>
+              <a:off x="693643" y="5011016"/>
+              <a:ext cx="2116868" cy="1085401"/>
+            </a:xfrm>
+            <a:prstGeom prst="rect">
+              <a:avLst/>
+            </a:prstGeom>
+          </p:spPr>
+        </p:pic>
+      </p:grpSp>
+      <p:pic>
+        <p:nvPicPr>
+          <p:cNvPr id="15" name="Picture 14">
+            <a:extLst>
+              <a:ext uri="{FF2B5EF4-FFF2-40B4-BE49-F238E27FC236}">
+                <a16:creationId xmlns:a16="http://schemas.microsoft.com/office/drawing/2014/main" id="{0BE2B919-856B-93CE-3517-1D233E1A8E88}"/>
+              </a:ext>
+            </a:extLst>
+          </p:cNvPr>
+          <p:cNvPicPr>
+            <a:picLocks noChangeAspect="1"/>
+          </p:cNvPicPr>
+          <p:nvPr/>
+        </p:nvPicPr>
+        <p:blipFill>
+          <a:blip r:embed="rId9"/>
+          <a:stretch>
+            <a:fillRect/>
+          </a:stretch>
+        </p:blipFill>
+        <p:spPr>
+          <a:xfrm>
+            <a:off x="6028392" y="2203969"/>
+            <a:ext cx="5941497" cy="3936045"/>
+          </a:xfrm>
+          <a:prstGeom prst="rect">
+            <a:avLst/>
+          </a:prstGeom>
+        </p:spPr>
+      </p:pic>
+    </p:spTree>
+    <p:extLst>
+      <p:ext uri="{BB962C8B-B14F-4D97-AF65-F5344CB8AC3E}">
+        <p14:creationId xmlns:p14="http://schemas.microsoft.com/office/powerpoint/2010/main" val="357586254"/>
+      </p:ext>
+    </p:extLst>
+  </p:cSld>
+  <p:clrMapOvr>
+    <a:masterClrMapping/>
+  </p:clrMapOvr>
+</p:sld>
+</file>
+
+<file path=ppt/slides/slide6.xml><?xml version="1.0" encoding="utf-8"?>
+<p:sld xmlns:a="http://schemas.openxmlformats.org/drawingml/2006/main" xmlns:r="http://schemas.openxmlformats.org/officeDocument/2006/relationships" xmlns:p="http://schemas.openxmlformats.org/presentationml/2006/main">
+  <p:cSld>
+    <p:spTree>
+      <p:nvGrpSpPr>
+        <p:cNvPr id="1" name="">
+          <a:extLst>
+            <a:ext uri="{FF2B5EF4-FFF2-40B4-BE49-F238E27FC236}">
+              <a16:creationId xmlns:a16="http://schemas.microsoft.com/office/drawing/2014/main" id="{53E46964-F237-FD0D-F04D-777A760AC40C}"/>
+            </a:ext>
+          </a:extLst>
+        </p:cNvPr>
+        <p:cNvGrpSpPr/>
+        <p:nvPr/>
+      </p:nvGrpSpPr>
+      <p:grpSpPr>
+        <a:xfrm>
+          <a:off x="0" y="0"/>
+          <a:ext cx="0" cy="0"/>
+          <a:chOff x="0" y="0"/>
+          <a:chExt cx="0" cy="0"/>
+        </a:xfrm>
+      </p:grpSpPr>
+      <p:sp>
+        <p:nvSpPr>
+          <p:cNvPr id="7" name="TextBox 6">
+            <a:extLst>
+              <a:ext uri="{FF2B5EF4-FFF2-40B4-BE49-F238E27FC236}">
+                <a16:creationId xmlns:a16="http://schemas.microsoft.com/office/drawing/2014/main" id="{5EC235C6-2F59-AFC6-9572-F92C19FD463B}"/>
+              </a:ext>
+            </a:extLst>
+          </p:cNvPr>
+          <p:cNvSpPr txBox="1"/>
+          <p:nvPr/>
+        </p:nvSpPr>
+        <p:spPr>
+          <a:xfrm>
+            <a:off x="318096" y="0"/>
+            <a:ext cx="11555807" cy="584775"/>
+          </a:xfrm>
+          <a:prstGeom prst="rect">
+            <a:avLst/>
+          </a:prstGeom>
+          <a:noFill/>
+        </p:spPr>
+        <p:txBody>
+          <a:bodyPr wrap="square" rtlCol="0">
+            <a:spAutoFit/>
+          </a:bodyPr>
+          <a:lstStyle/>
+          <a:p>
+            <a:r>
+              <a:rPr lang="en-GB" sz="3200" b="1" noProof="0" dirty="0">
+                <a:solidFill>
+                  <a:schemeClr val="bg1"/>
+                </a:solidFill>
+                <a:latin typeface="Cambria" panose="02040503050406030204" pitchFamily="18" charset="0"/>
+                <a:ea typeface="Cambria" panose="02040503050406030204" pitchFamily="18" charset="0"/>
+                <a:cs typeface="Times New Roman" panose="02020603050405020304" pitchFamily="18" charset="0"/>
+              </a:rPr>
+              <a:t>Why R</a:t>
+            </a:r>
+          </a:p>
+        </p:txBody>
+      </p:sp>
+      <p:sp>
+        <p:nvSpPr>
+          <p:cNvPr id="13" name="TextBox 12">
+            <a:extLst>
+              <a:ext uri="{FF2B5EF4-FFF2-40B4-BE49-F238E27FC236}">
+                <a16:creationId xmlns:a16="http://schemas.microsoft.com/office/drawing/2014/main" id="{4F9E6795-287B-DDC2-A981-ABFC373EB0F3}"/>
+              </a:ext>
+            </a:extLst>
+          </p:cNvPr>
+          <p:cNvSpPr txBox="1"/>
+          <p:nvPr/>
+        </p:nvSpPr>
+        <p:spPr>
+          <a:xfrm>
+            <a:off x="222111" y="800107"/>
+            <a:ext cx="11747779" cy="3809441"/>
+          </a:xfrm>
+          <a:prstGeom prst="rect">
+            <a:avLst/>
+          </a:prstGeom>
+          <a:noFill/>
+        </p:spPr>
+        <p:txBody>
+          <a:bodyPr wrap="square" rtlCol="0">
+            <a:spAutoFit/>
+          </a:bodyPr>
+          <a:lstStyle/>
+          <a:p>
+            <a:pPr marL="268288" lvl="1" indent="-268288" algn="just">
+              <a:lnSpc>
+                <a:spcPct val="150000"/>
+              </a:lnSpc>
+              <a:buFont typeface="Arial" panose="020B0604020202020204" pitchFamily="34" charset="0"/>
+              <a:buChar char="•"/>
+            </a:pPr>
+            <a:endParaRPr lang="en-GB" sz="2000" noProof="0" dirty="0">
+              <a:latin typeface="Cambria" panose="02040503050406030204" pitchFamily="18" charset="0"/>
+              <a:ea typeface="Cambria" panose="02040503050406030204" pitchFamily="18" charset="0"/>
+            </a:endParaRPr>
+          </a:p>
+          <a:p>
+            <a:pPr marL="268288" lvl="1" indent="-268288" algn="just">
+              <a:lnSpc>
+                <a:spcPct val="150000"/>
+              </a:lnSpc>
+              <a:buFont typeface="Arial" panose="020B0604020202020204" pitchFamily="34" charset="0"/>
+              <a:buChar char="•"/>
+            </a:pPr>
+            <a:endParaRPr lang="en-GB" sz="2000" dirty="0">
+              <a:latin typeface="Cambria" panose="02040503050406030204" pitchFamily="18" charset="0"/>
+              <a:ea typeface="Cambria" panose="02040503050406030204" pitchFamily="18" charset="0"/>
+            </a:endParaRPr>
+          </a:p>
+          <a:p>
+            <a:pPr marL="268288" lvl="1" indent="-268288" algn="just">
+              <a:lnSpc>
+                <a:spcPct val="150000"/>
+              </a:lnSpc>
+              <a:buFont typeface="Arial" panose="020B0604020202020204" pitchFamily="34" charset="0"/>
+              <a:buChar char="•"/>
+            </a:pPr>
+            <a:r>
+              <a:rPr lang="en-GB" sz="2000" noProof="0" dirty="0">
+                <a:latin typeface="Cambria" panose="02040503050406030204" pitchFamily="18" charset="0"/>
+                <a:ea typeface="Cambria" panose="02040503050406030204" pitchFamily="18" charset="0"/>
+              </a:rPr>
+              <a:t>Statistical Analysis &amp; Data Visualization</a:t>
+            </a:r>
+          </a:p>
+          <a:p>
+            <a:pPr marL="268288" lvl="1" indent="-268288" algn="just">
+              <a:lnSpc>
+                <a:spcPct val="150000"/>
+              </a:lnSpc>
+              <a:buFont typeface="Arial" panose="020B0604020202020204" pitchFamily="34" charset="0"/>
+              <a:buChar char="•"/>
+            </a:pPr>
+            <a:r>
+              <a:rPr lang="en-GB" sz="2000" dirty="0">
+                <a:latin typeface="Cambria" panose="02040503050406030204" pitchFamily="18" charset="0"/>
+                <a:ea typeface="Cambria" panose="02040503050406030204" pitchFamily="18" charset="0"/>
+              </a:rPr>
+              <a:t>Free-to-use, Open Source</a:t>
+            </a:r>
+          </a:p>
+          <a:p>
+            <a:pPr marL="268288" lvl="1" indent="-268288" algn="just">
+              <a:lnSpc>
+                <a:spcPct val="150000"/>
+              </a:lnSpc>
+              <a:buFont typeface="Arial" panose="020B0604020202020204" pitchFamily="34" charset="0"/>
+              <a:buChar char="•"/>
+            </a:pPr>
+            <a:r>
+              <a:rPr lang="en-GB" sz="2000" dirty="0">
+                <a:latin typeface="Cambria" panose="02040503050406030204" pitchFamily="18" charset="0"/>
+                <a:ea typeface="Cambria" panose="02040503050406030204" pitchFamily="18" charset="0"/>
+              </a:rPr>
+              <a:t>Thousands of curated &amp; up-to-date packages</a:t>
+            </a:r>
+          </a:p>
+          <a:p>
+            <a:pPr marL="268288" lvl="1" indent="-268288" algn="just">
+              <a:lnSpc>
+                <a:spcPct val="150000"/>
+              </a:lnSpc>
+              <a:buFont typeface="Arial" panose="020B0604020202020204" pitchFamily="34" charset="0"/>
+              <a:buChar char="•"/>
+            </a:pPr>
+            <a:endParaRPr lang="en-GB" sz="2000" dirty="0">
+              <a:latin typeface="Cambria" panose="02040503050406030204" pitchFamily="18" charset="0"/>
+              <a:ea typeface="Cambria" panose="02040503050406030204" pitchFamily="18" charset="0"/>
+            </a:endParaRPr>
+          </a:p>
+          <a:p>
+            <a:pPr marL="0" lvl="1" algn="just">
+              <a:lnSpc>
+                <a:spcPct val="150000"/>
+              </a:lnSpc>
+            </a:pPr>
+            <a:r>
+              <a:rPr lang="en-GB" sz="2000" b="1" dirty="0">
+                <a:latin typeface="Cambria" panose="02040503050406030204" pitchFamily="18" charset="0"/>
+                <a:ea typeface="Cambria" panose="02040503050406030204" pitchFamily="18" charset="0"/>
+              </a:rPr>
+              <a:t>Literate Programming </a:t>
+            </a:r>
+          </a:p>
+          <a:p>
+            <a:pPr algn="just">
+              <a:lnSpc>
+                <a:spcPct val="150000"/>
+              </a:lnSpc>
+            </a:pPr>
+            <a:endParaRPr lang="en-GB" sz="2400" b="1" dirty="0">
+              <a:latin typeface="Cambria" panose="02040503050406030204" pitchFamily="18" charset="0"/>
+              <a:ea typeface="Cambria" panose="02040503050406030204" pitchFamily="18" charset="0"/>
+            </a:endParaRPr>
+          </a:p>
+        </p:txBody>
+      </p:sp>
+      <p:pic>
+        <p:nvPicPr>
+          <p:cNvPr id="9" name="Picture 8" descr="A white circle with black background&#10;&#10;Description automatically generated">
+            <a:extLst>
+              <a:ext uri="{FF2B5EF4-FFF2-40B4-BE49-F238E27FC236}">
+                <a16:creationId xmlns:a16="http://schemas.microsoft.com/office/drawing/2014/main" id="{8776AEC1-77B1-C92D-5393-CBFAAB0A6250}"/>
+              </a:ext>
+            </a:extLst>
+          </p:cNvPr>
+          <p:cNvPicPr>
+            <a:picLocks noChangeAspect="1"/>
+          </p:cNvPicPr>
+          <p:nvPr/>
+        </p:nvPicPr>
+        <p:blipFill>
+          <a:blip r:embed="rId3"/>
+          <a:srcRect t="19605" r="16255" b="22685"/>
+          <a:stretch>
+            <a:fillRect/>
+          </a:stretch>
+        </p:blipFill>
+        <p:spPr>
+          <a:xfrm>
+            <a:off x="-269926" y="6222582"/>
+            <a:ext cx="939853" cy="628211"/>
+          </a:xfrm>
+          <a:prstGeom prst="rect">
+            <a:avLst/>
+          </a:prstGeom>
+        </p:spPr>
+      </p:pic>
+      <p:cxnSp>
+        <p:nvCxnSpPr>
+          <p:cNvPr id="10" name="Straight Connector 9">
+            <a:extLst>
+              <a:ext uri="{FF2B5EF4-FFF2-40B4-BE49-F238E27FC236}">
+                <a16:creationId xmlns:a16="http://schemas.microsoft.com/office/drawing/2014/main" id="{954E7BA6-EE4D-72C8-93CC-D72B20710D02}"/>
+              </a:ext>
+            </a:extLst>
+          </p:cNvPr>
+          <p:cNvCxnSpPr>
+            <a:cxnSpLocks/>
+          </p:cNvCxnSpPr>
+          <p:nvPr/>
+        </p:nvCxnSpPr>
+        <p:spPr>
+          <a:xfrm flipV="1">
+            <a:off x="669927" y="6523348"/>
+            <a:ext cx="10580947" cy="1"/>
+          </a:xfrm>
+          <a:prstGeom prst="line">
+            <a:avLst/>
+          </a:prstGeom>
+          <a:ln>
+            <a:solidFill>
+              <a:schemeClr val="bg1"/>
+            </a:solidFill>
+          </a:ln>
+        </p:spPr>
+        <p:style>
+          <a:lnRef idx="1">
+            <a:schemeClr val="dk1"/>
+          </a:lnRef>
+          <a:fillRef idx="0">
+            <a:schemeClr val="dk1"/>
+          </a:fillRef>
+          <a:effectRef idx="0">
+            <a:schemeClr val="dk1"/>
+          </a:effectRef>
+          <a:fontRef idx="minor">
+            <a:schemeClr val="tx1"/>
+          </a:fontRef>
+        </p:style>
+      </p:cxnSp>
+      <p:sp>
+        <p:nvSpPr>
+          <p:cNvPr id="11" name="Slide Number Placeholder 2">
+            <a:extLst>
+              <a:ext uri="{FF2B5EF4-FFF2-40B4-BE49-F238E27FC236}">
+                <a16:creationId xmlns:a16="http://schemas.microsoft.com/office/drawing/2014/main" id="{415B45FD-F0B2-1103-E4BD-F649D6DD3785}"/>
+              </a:ext>
+            </a:extLst>
+          </p:cNvPr>
+          <p:cNvSpPr txBox="1">
+            <a:spLocks/>
+          </p:cNvSpPr>
+          <p:nvPr/>
+        </p:nvSpPr>
+        <p:spPr>
+          <a:xfrm>
+            <a:off x="8804750" y="6337394"/>
+            <a:ext cx="2825475" cy="365125"/>
+          </a:xfrm>
+          <a:prstGeom prst="rect">
+            <a:avLst/>
+          </a:prstGeom>
+        </p:spPr>
+        <p:txBody>
+          <a:bodyPr vert="horz" lIns="91440" tIns="45720" rIns="91440" bIns="45720" rtlCol="0" anchor="ctr"/>
+          <a:lstStyle>
+            <a:defPPr>
+              <a:defRPr lang="en-US"/>
+            </a:defPPr>
+            <a:lvl1pPr marL="0" algn="r" defTabSz="914400" rtl="0" eaLnBrk="1" latinLnBrk="0" hangingPunct="1">
+              <a:defRPr sz="1200" kern="1200">
+                <a:solidFill>
+                  <a:schemeClr val="tx1">
+                    <a:tint val="75000"/>
+                  </a:schemeClr>
+                </a:solidFill>
+                <a:latin typeface="+mn-lt"/>
+                <a:ea typeface="+mn-ea"/>
+                <a:cs typeface="+mn-cs"/>
+              </a:defRPr>
+            </a:lvl1pPr>
+            <a:lvl2pPr marL="457200" algn="l" defTabSz="914400" rtl="0" eaLnBrk="1" latinLnBrk="0" hangingPunct="1">
+              <a:defRPr sz="1800" kern="1200">
+                <a:solidFill>
+                  <a:schemeClr val="tx1"/>
+                </a:solidFill>
+                <a:latin typeface="+mn-lt"/>
+                <a:ea typeface="+mn-ea"/>
+                <a:cs typeface="+mn-cs"/>
+              </a:defRPr>
+            </a:lvl2pPr>
+            <a:lvl3pPr marL="914400" algn="l" defTabSz="914400" rtl="0" eaLnBrk="1" latinLnBrk="0" hangingPunct="1">
+              <a:defRPr sz="1800" kern="1200">
+                <a:solidFill>
+                  <a:schemeClr val="tx1"/>
+                </a:solidFill>
+                <a:latin typeface="+mn-lt"/>
+                <a:ea typeface="+mn-ea"/>
+                <a:cs typeface="+mn-cs"/>
+              </a:defRPr>
+            </a:lvl3pPr>
+            <a:lvl4pPr marL="1371600" algn="l" defTabSz="914400" rtl="0" eaLnBrk="1" latinLnBrk="0" hangingPunct="1">
+              <a:defRPr sz="1800" kern="1200">
+                <a:solidFill>
+                  <a:schemeClr val="tx1"/>
+                </a:solidFill>
+                <a:latin typeface="+mn-lt"/>
+                <a:ea typeface="+mn-ea"/>
+                <a:cs typeface="+mn-cs"/>
+              </a:defRPr>
+            </a:lvl4pPr>
+            <a:lvl5pPr marL="1828800" algn="l" defTabSz="914400" rtl="0" eaLnBrk="1" latinLnBrk="0" hangingPunct="1">
+              <a:defRPr sz="1800" kern="1200">
+                <a:solidFill>
+                  <a:schemeClr val="tx1"/>
+                </a:solidFill>
+                <a:latin typeface="+mn-lt"/>
+                <a:ea typeface="+mn-ea"/>
+                <a:cs typeface="+mn-cs"/>
+              </a:defRPr>
+            </a:lvl5pPr>
+            <a:lvl6pPr marL="2286000" algn="l" defTabSz="914400" rtl="0" eaLnBrk="1" latinLnBrk="0" hangingPunct="1">
+              <a:defRPr sz="1800" kern="1200">
+                <a:solidFill>
+                  <a:schemeClr val="tx1"/>
+                </a:solidFill>
+                <a:latin typeface="+mn-lt"/>
+                <a:ea typeface="+mn-ea"/>
+                <a:cs typeface="+mn-cs"/>
+              </a:defRPr>
+            </a:lvl6pPr>
+            <a:lvl7pPr marL="2743200" algn="l" defTabSz="914400" rtl="0" eaLnBrk="1" latinLnBrk="0" hangingPunct="1">
+              <a:defRPr sz="1800" kern="1200">
+                <a:solidFill>
+                  <a:schemeClr val="tx1"/>
+                </a:solidFill>
+                <a:latin typeface="+mn-lt"/>
+                <a:ea typeface="+mn-ea"/>
+                <a:cs typeface="+mn-cs"/>
+              </a:defRPr>
+            </a:lvl7pPr>
+            <a:lvl8pPr marL="3200400" algn="l" defTabSz="914400" rtl="0" eaLnBrk="1" latinLnBrk="0" hangingPunct="1">
+              <a:defRPr sz="1800" kern="1200">
+                <a:solidFill>
+                  <a:schemeClr val="tx1"/>
+                </a:solidFill>
+                <a:latin typeface="+mn-lt"/>
+                <a:ea typeface="+mn-ea"/>
+                <a:cs typeface="+mn-cs"/>
+              </a:defRPr>
+            </a:lvl8pPr>
+            <a:lvl9pPr marL="3657600" algn="l" defTabSz="914400" rtl="0" eaLnBrk="1" latinLnBrk="0" hangingPunct="1">
+              <a:defRPr sz="1800" kern="1200">
+                <a:solidFill>
+                  <a:schemeClr val="tx1"/>
+                </a:solidFill>
+                <a:latin typeface="+mn-lt"/>
+                <a:ea typeface="+mn-ea"/>
+                <a:cs typeface="+mn-cs"/>
+              </a:defRPr>
+            </a:lvl9pPr>
+          </a:lstStyle>
+          <a:p>
+            <a:fld id="{54B21BD1-F593-4F4E-86E9-52991719DFB8}" type="slidenum">
+              <a:rPr lang="en-GB" sz="1400" noProof="0" smtClean="0">
+                <a:solidFill>
+                  <a:schemeClr val="bg1"/>
+                </a:solidFill>
+                <a:latin typeface="Cambria" panose="02040503050406030204" pitchFamily="18" charset="0"/>
+                <a:ea typeface="Cambria" panose="02040503050406030204" pitchFamily="18" charset="0"/>
+              </a:rPr>
+              <a:pPr/>
+              <a:t>6</a:t>
+            </a:fld>
+            <a:endParaRPr lang="en-GB" sz="1400" noProof="0" dirty="0">
+              <a:solidFill>
+                <a:schemeClr val="bg1"/>
+              </a:solidFill>
+              <a:latin typeface="Cambria" panose="02040503050406030204" pitchFamily="18" charset="0"/>
+              <a:ea typeface="Cambria" panose="02040503050406030204" pitchFamily="18" charset="0"/>
+            </a:endParaRPr>
+          </a:p>
+        </p:txBody>
+      </p:sp>
+      <p:sp>
+        <p:nvSpPr>
+          <p:cNvPr id="12" name="TextBox 11">
+            <a:extLst>
+              <a:ext uri="{FF2B5EF4-FFF2-40B4-BE49-F238E27FC236}">
+                <a16:creationId xmlns:a16="http://schemas.microsoft.com/office/drawing/2014/main" id="{CFDE85BC-83B6-1CC3-7CAE-A4DBBEEBB12C}"/>
+              </a:ext>
+            </a:extLst>
+          </p:cNvPr>
+          <p:cNvSpPr txBox="1"/>
+          <p:nvPr/>
+        </p:nvSpPr>
+        <p:spPr>
+          <a:xfrm>
+            <a:off x="3870960" y="6451133"/>
+            <a:ext cx="4450080" cy="335092"/>
+          </a:xfrm>
+          <a:prstGeom prst="rect">
+            <a:avLst/>
+          </a:prstGeom>
+          <a:noFill/>
+        </p:spPr>
+        <p:txBody>
+          <a:bodyPr wrap="square" rtlCol="0">
+            <a:spAutoFit/>
+          </a:bodyPr>
+          <a:lstStyle/>
+          <a:p>
+            <a:pPr defTabSz="825500">
+              <a:lnSpc>
+                <a:spcPct val="150000"/>
+              </a:lnSpc>
+              <a:tabLst>
+                <a:tab pos="3768725" algn="l"/>
+                <a:tab pos="4572000" algn="l"/>
+              </a:tabLst>
+            </a:pPr>
+            <a:r>
+              <a:rPr lang="en-GB" sz="1200" noProof="0" dirty="0">
+                <a:solidFill>
+                  <a:schemeClr val="bg1"/>
+                </a:solidFill>
+                <a:latin typeface="Cambria" panose="02040503050406030204" pitchFamily="18" charset="0"/>
+                <a:ea typeface="Cambria" panose="02040503050406030204" pitchFamily="18" charset="0"/>
+                <a:cs typeface="Times New Roman" panose="02020603050405020304" pitchFamily="18" charset="0"/>
+              </a:rPr>
+              <a:t>André Barros | Advanced Data Analysis | 12th January 2026</a:t>
+            </a:r>
+            <a:endParaRPr lang="en-GB" sz="1200" i="1" noProof="0" dirty="0">
+              <a:solidFill>
+                <a:schemeClr val="bg1"/>
+              </a:solidFill>
+              <a:latin typeface="Cambria" panose="02040503050406030204" pitchFamily="18" charset="0"/>
+              <a:ea typeface="Cambria" panose="02040503050406030204" pitchFamily="18" charset="0"/>
+              <a:cs typeface="Times New Roman" panose="02020603050405020304" pitchFamily="18" charset="0"/>
+            </a:endParaRPr>
+          </a:p>
+        </p:txBody>
+      </p:sp>
+      <p:pic>
+        <p:nvPicPr>
+          <p:cNvPr id="14" name="Picture 13">
+            <a:extLst>
+              <a:ext uri="{FF2B5EF4-FFF2-40B4-BE49-F238E27FC236}">
+                <a16:creationId xmlns:a16="http://schemas.microsoft.com/office/drawing/2014/main" id="{0E8AD1A3-C365-A322-9C3A-2D7B23504C41}"/>
+              </a:ext>
+            </a:extLst>
+          </p:cNvPr>
+          <p:cNvPicPr>
+            <a:picLocks noChangeAspect="1"/>
+          </p:cNvPicPr>
+          <p:nvPr/>
+        </p:nvPicPr>
+        <p:blipFill>
+          <a:blip r:embed="rId4"/>
+          <a:srcRect l="22765" t="18648" r="25605" b="15789"/>
+          <a:stretch>
+            <a:fillRect/>
+          </a:stretch>
+        </p:blipFill>
+        <p:spPr>
+          <a:xfrm>
+            <a:off x="11581065" y="6281675"/>
+            <a:ext cx="425229" cy="540000"/>
+          </a:xfrm>
+          <a:prstGeom prst="rect">
+            <a:avLst/>
+          </a:prstGeom>
+        </p:spPr>
+      </p:pic>
+      <p:pic>
+        <p:nvPicPr>
+          <p:cNvPr id="1026" name="Picture 2" descr="R: R Logo">
+            <a:extLst>
+              <a:ext uri="{FF2B5EF4-FFF2-40B4-BE49-F238E27FC236}">
+                <a16:creationId xmlns:a16="http://schemas.microsoft.com/office/drawing/2014/main" id="{6074DE48-C4A3-A335-4747-30DA36D4A183}"/>
+              </a:ext>
+            </a:extLst>
+          </p:cNvPr>
+          <p:cNvPicPr>
+            <a:picLocks noChangeAspect="1" noChangeArrowheads="1"/>
+          </p:cNvPicPr>
+          <p:nvPr/>
+        </p:nvPicPr>
+        <p:blipFill>
+          <a:blip r:embed="rId5">
+            <a:extLst>
+              <a:ext uri="{28A0092B-C50C-407E-A947-70E740481C1C}">
+                <a14:useLocalDpi xmlns:a14="http://schemas.microsoft.com/office/drawing/2010/main" val="0"/>
+              </a:ext>
+            </a:extLst>
+          </a:blip>
+          <a:srcRect/>
+          <a:stretch>
+            <a:fillRect/>
+          </a:stretch>
+        </p:blipFill>
+        <p:spPr bwMode="auto">
+          <a:xfrm>
+            <a:off x="318096" y="885541"/>
+            <a:ext cx="927304" cy="718661"/>
+          </a:xfrm>
+          <a:prstGeom prst="rect">
+            <a:avLst/>
+          </a:prstGeom>
+          <a:noFill/>
+          <a:extLst>
+            <a:ext uri="{909E8E84-426E-40DD-AFC4-6F175D3DCCD1}">
+              <a14:hiddenFill xmlns:a14="http://schemas.microsoft.com/office/drawing/2010/main">
+                <a:solidFill>
+                  <a:srgbClr val="FFFFFF"/>
+                </a:solidFill>
+              </a14:hiddenFill>
+            </a:ext>
+          </a:extLst>
+        </p:spPr>
+      </p:pic>
+      <p:pic>
+        <p:nvPicPr>
+          <p:cNvPr id="4" name="Picture 3">
+            <a:extLst>
+              <a:ext uri="{FF2B5EF4-FFF2-40B4-BE49-F238E27FC236}">
+                <a16:creationId xmlns:a16="http://schemas.microsoft.com/office/drawing/2014/main" id="{A33E4144-6711-847F-CE67-B350E3324AE1}"/>
+              </a:ext>
+            </a:extLst>
+          </p:cNvPr>
+          <p:cNvPicPr>
+            <a:picLocks noChangeAspect="1"/>
+          </p:cNvPicPr>
+          <p:nvPr/>
+        </p:nvPicPr>
+        <p:blipFill>
+          <a:blip r:embed="rId6"/>
+          <a:stretch>
+            <a:fillRect/>
+          </a:stretch>
+        </p:blipFill>
+        <p:spPr>
+          <a:xfrm>
+            <a:off x="3309773" y="4395442"/>
+            <a:ext cx="1289078" cy="1494256"/>
+          </a:xfrm>
+          <a:prstGeom prst="rect">
+            <a:avLst/>
+          </a:prstGeom>
+        </p:spPr>
+      </p:pic>
+      <p:pic>
+        <p:nvPicPr>
+          <p:cNvPr id="2" name="Picture 1">
+            <a:extLst>
+              <a:ext uri="{FF2B5EF4-FFF2-40B4-BE49-F238E27FC236}">
+                <a16:creationId xmlns:a16="http://schemas.microsoft.com/office/drawing/2014/main" id="{A2B04370-7D20-A2CE-E36B-222DEFB0D46B}"/>
+              </a:ext>
+            </a:extLst>
+          </p:cNvPr>
+          <p:cNvPicPr>
+            <a:picLocks noChangeAspect="1"/>
+          </p:cNvPicPr>
+          <p:nvPr/>
+        </p:nvPicPr>
+        <p:blipFill>
+          <a:blip r:embed="rId7"/>
+          <a:srcRect l="23966" t="36171" r="23421" b="43672"/>
+          <a:stretch>
+            <a:fillRect/>
+          </a:stretch>
+        </p:blipFill>
+        <p:spPr>
+          <a:xfrm>
+            <a:off x="222111" y="4885363"/>
+            <a:ext cx="2557570" cy="514415"/>
+          </a:xfrm>
+          <a:prstGeom prst="rect">
+            <a:avLst/>
+          </a:prstGeom>
+        </p:spPr>
+      </p:pic>
+      <p:pic>
+        <p:nvPicPr>
+          <p:cNvPr id="8" name="Picture 7">
+            <a:extLst>
+              <a:ext uri="{FF2B5EF4-FFF2-40B4-BE49-F238E27FC236}">
+                <a16:creationId xmlns:a16="http://schemas.microsoft.com/office/drawing/2014/main" id="{545D93D0-8A53-7C7F-E36E-153B15A94416}"/>
+              </a:ext>
+            </a:extLst>
+          </p:cNvPr>
+          <p:cNvPicPr>
+            <a:picLocks noChangeAspect="1"/>
+          </p:cNvPicPr>
+          <p:nvPr/>
+        </p:nvPicPr>
+        <p:blipFill>
+          <a:blip r:embed="rId8"/>
+          <a:srcRect r="6171"/>
+          <a:stretch>
+            <a:fillRect/>
+          </a:stretch>
+        </p:blipFill>
+        <p:spPr>
+          <a:xfrm>
+            <a:off x="8804750" y="3562180"/>
+            <a:ext cx="3377250" cy="2691635"/>
+          </a:xfrm>
+          <a:prstGeom prst="rect">
+            <a:avLst/>
+          </a:prstGeom>
+        </p:spPr>
+      </p:pic>
+      <p:pic>
+        <p:nvPicPr>
+          <p:cNvPr id="15" name="Picture 14">
+            <a:extLst>
+              <a:ext uri="{FF2B5EF4-FFF2-40B4-BE49-F238E27FC236}">
+                <a16:creationId xmlns:a16="http://schemas.microsoft.com/office/drawing/2014/main" id="{1479AE7D-C0A7-654E-FDE7-C9B85AFA4F53}"/>
+              </a:ext>
+            </a:extLst>
+          </p:cNvPr>
+          <p:cNvPicPr>
+            <a:picLocks noChangeAspect="1"/>
+          </p:cNvPicPr>
+          <p:nvPr/>
+        </p:nvPicPr>
+        <p:blipFill>
+          <a:blip r:embed="rId9"/>
+          <a:stretch>
+            <a:fillRect/>
+          </a:stretch>
+        </p:blipFill>
+        <p:spPr>
+          <a:xfrm>
+            <a:off x="5274600" y="3467864"/>
+            <a:ext cx="3421960" cy="2785951"/>
+          </a:xfrm>
+          <a:prstGeom prst="rect">
+            <a:avLst/>
+          </a:prstGeom>
+        </p:spPr>
+      </p:pic>
+    </p:spTree>
+    <p:extLst>
+      <p:ext uri="{BB962C8B-B14F-4D97-AF65-F5344CB8AC3E}">
+        <p14:creationId xmlns:p14="http://schemas.microsoft.com/office/powerpoint/2010/main" val="3106891909"/>
+      </p:ext>
+    </p:extLst>
+  </p:cSld>
+  <p:clrMapOvr>
+    <a:masterClrMapping/>
+  </p:clrMapOvr>
+</p:sld>
+</file>
+
+<file path=ppt/slides/slide7.xml><?xml version="1.0" encoding="utf-8"?>
+<p:sld xmlns:a="http://schemas.openxmlformats.org/drawingml/2006/main" xmlns:r="http://schemas.openxmlformats.org/officeDocument/2006/relationships" xmlns:p="http://schemas.openxmlformats.org/presentationml/2006/main">
+  <p:cSld>
+    <p:spTree>
+      <p:nvGrpSpPr>
+        <p:cNvPr id="1" name="">
+          <a:extLst>
+            <a:ext uri="{FF2B5EF4-FFF2-40B4-BE49-F238E27FC236}">
+              <a16:creationId xmlns:a16="http://schemas.microsoft.com/office/drawing/2014/main" id="{41B03D2A-E05D-784C-AB79-877EE1C75007}"/>
+            </a:ext>
+          </a:extLst>
+        </p:cNvPr>
+        <p:cNvGrpSpPr/>
+        <p:nvPr/>
+      </p:nvGrpSpPr>
+      <p:grpSpPr>
+        <a:xfrm>
+          <a:off x="0" y="0"/>
+          <a:ext cx="0" cy="0"/>
+          <a:chOff x="0" y="0"/>
+          <a:chExt cx="0" cy="0"/>
+        </a:xfrm>
+      </p:grpSpPr>
+      <p:sp>
+        <p:nvSpPr>
+          <p:cNvPr id="7" name="TextBox 6">
+            <a:extLst>
+              <a:ext uri="{FF2B5EF4-FFF2-40B4-BE49-F238E27FC236}">
+                <a16:creationId xmlns:a16="http://schemas.microsoft.com/office/drawing/2014/main" id="{17481CE0-F07B-F803-7223-D798EA199F0B}"/>
+              </a:ext>
+            </a:extLst>
+          </p:cNvPr>
+          <p:cNvSpPr txBox="1"/>
+          <p:nvPr/>
+        </p:nvSpPr>
+        <p:spPr>
+          <a:xfrm>
+            <a:off x="318096" y="0"/>
+            <a:ext cx="11555807" cy="584775"/>
+          </a:xfrm>
+          <a:prstGeom prst="rect">
+            <a:avLst/>
+          </a:prstGeom>
+          <a:noFill/>
+        </p:spPr>
+        <p:txBody>
+          <a:bodyPr wrap="square" rtlCol="0">
+            <a:spAutoFit/>
+          </a:bodyPr>
+          <a:lstStyle/>
+          <a:p>
+            <a:r>
+              <a:rPr lang="en-GB" sz="3200" b="1" noProof="0" dirty="0">
+                <a:solidFill>
+                  <a:schemeClr val="bg1"/>
+                </a:solidFill>
+                <a:latin typeface="Cambria" panose="02040503050406030204" pitchFamily="18" charset="0"/>
+                <a:ea typeface="Cambria" panose="02040503050406030204" pitchFamily="18" charset="0"/>
+                <a:cs typeface="Times New Roman" panose="02020603050405020304" pitchFamily="18" charset="0"/>
+              </a:rPr>
+              <a:t>Course Material</a:t>
+            </a:r>
+          </a:p>
+        </p:txBody>
+      </p:sp>
+      <p:sp>
+        <p:nvSpPr>
+          <p:cNvPr id="13" name="TextBox 12">
+            <a:extLst>
+              <a:ext uri="{FF2B5EF4-FFF2-40B4-BE49-F238E27FC236}">
+                <a16:creationId xmlns:a16="http://schemas.microsoft.com/office/drawing/2014/main" id="{B6AC6DE2-2E99-4842-94A4-942D9ADDA612}"/>
+              </a:ext>
+            </a:extLst>
+          </p:cNvPr>
+          <p:cNvSpPr txBox="1"/>
+          <p:nvPr/>
+        </p:nvSpPr>
+        <p:spPr>
+          <a:xfrm>
+            <a:off x="222111" y="800107"/>
+            <a:ext cx="11747779" cy="1039452"/>
+          </a:xfrm>
+          <a:prstGeom prst="rect">
+            <a:avLst/>
+          </a:prstGeom>
+          <a:noFill/>
+        </p:spPr>
+        <p:txBody>
+          <a:bodyPr wrap="square" rtlCol="0">
+            <a:spAutoFit/>
+          </a:bodyPr>
+          <a:lstStyle/>
+          <a:p>
+            <a:pPr algn="ctr">
+              <a:lnSpc>
+                <a:spcPct val="150000"/>
+              </a:lnSpc>
+            </a:pPr>
+            <a:r>
+              <a:rPr lang="en-GB" sz="2000" b="1" dirty="0">
+                <a:latin typeface="Cambria" panose="02040503050406030204" pitchFamily="18" charset="0"/>
+                <a:ea typeface="Cambria" panose="02040503050406030204" pitchFamily="18" charset="0"/>
+                <a:hlinkClick r:id="rId3"/>
+              </a:rPr>
+              <a:t>https://github.com/andrebolerbarros/Intro_R</a:t>
+            </a:r>
+            <a:endParaRPr lang="en-GB" sz="2000" b="1" dirty="0">
+              <a:latin typeface="Cambria" panose="02040503050406030204" pitchFamily="18" charset="0"/>
+              <a:ea typeface="Cambria" panose="02040503050406030204" pitchFamily="18" charset="0"/>
+            </a:endParaRPr>
+          </a:p>
+          <a:p>
+            <a:pPr marL="285750" indent="-285750" algn="just">
+              <a:lnSpc>
+                <a:spcPct val="150000"/>
+              </a:lnSpc>
+              <a:buFont typeface="Arial" panose="020B0604020202020204" pitchFamily="34" charset="0"/>
+              <a:buChar char="•"/>
+            </a:pPr>
+            <a:endParaRPr lang="en-GB" sz="2400" b="1" dirty="0">
+              <a:latin typeface="Cambria" panose="02040503050406030204" pitchFamily="18" charset="0"/>
+              <a:ea typeface="Cambria" panose="02040503050406030204" pitchFamily="18" charset="0"/>
+            </a:endParaRPr>
+          </a:p>
+        </p:txBody>
+      </p:sp>
+      <p:pic>
+        <p:nvPicPr>
+          <p:cNvPr id="9" name="Picture 8" descr="A white circle with black background&#10;&#10;Description automatically generated">
+            <a:extLst>
+              <a:ext uri="{FF2B5EF4-FFF2-40B4-BE49-F238E27FC236}">
+                <a16:creationId xmlns:a16="http://schemas.microsoft.com/office/drawing/2014/main" id="{54D672F2-7EB4-9D78-3451-D57F25CBA19D}"/>
+              </a:ext>
+            </a:extLst>
+          </p:cNvPr>
+          <p:cNvPicPr>
+            <a:picLocks noChangeAspect="1"/>
+          </p:cNvPicPr>
+          <p:nvPr/>
+        </p:nvPicPr>
+        <p:blipFill>
+          <a:blip r:embed="rId4"/>
+          <a:srcRect t="19605" r="16255" b="22685"/>
+          <a:stretch>
+            <a:fillRect/>
+          </a:stretch>
+        </p:blipFill>
+        <p:spPr>
+          <a:xfrm>
+            <a:off x="-269926" y="6222582"/>
+            <a:ext cx="939853" cy="628211"/>
+          </a:xfrm>
+          <a:prstGeom prst="rect">
+            <a:avLst/>
+          </a:prstGeom>
+        </p:spPr>
+      </p:pic>
+      <p:cxnSp>
+        <p:nvCxnSpPr>
+          <p:cNvPr id="10" name="Straight Connector 9">
+            <a:extLst>
+              <a:ext uri="{FF2B5EF4-FFF2-40B4-BE49-F238E27FC236}">
+                <a16:creationId xmlns:a16="http://schemas.microsoft.com/office/drawing/2014/main" id="{C297771C-30AF-60EA-4E3A-110E1C668F48}"/>
+              </a:ext>
+            </a:extLst>
+          </p:cNvPr>
+          <p:cNvCxnSpPr>
+            <a:cxnSpLocks/>
+          </p:cNvCxnSpPr>
+          <p:nvPr/>
+        </p:nvCxnSpPr>
+        <p:spPr>
+          <a:xfrm flipV="1">
+            <a:off x="669927" y="6523348"/>
+            <a:ext cx="10580947" cy="1"/>
+          </a:xfrm>
+          <a:prstGeom prst="line">
+            <a:avLst/>
+          </a:prstGeom>
+          <a:ln>
+            <a:solidFill>
+              <a:schemeClr val="bg1"/>
+            </a:solidFill>
+          </a:ln>
+        </p:spPr>
+        <p:style>
+          <a:lnRef idx="1">
+            <a:schemeClr val="dk1"/>
+          </a:lnRef>
+          <a:fillRef idx="0">
+            <a:schemeClr val="dk1"/>
+          </a:fillRef>
+          <a:effectRef idx="0">
+            <a:schemeClr val="dk1"/>
+          </a:effectRef>
+          <a:fontRef idx="minor">
+            <a:schemeClr val="tx1"/>
+          </a:fontRef>
+        </p:style>
+      </p:cxnSp>
+      <p:sp>
+        <p:nvSpPr>
+          <p:cNvPr id="11" name="Slide Number Placeholder 2">
+            <a:extLst>
+              <a:ext uri="{FF2B5EF4-FFF2-40B4-BE49-F238E27FC236}">
+                <a16:creationId xmlns:a16="http://schemas.microsoft.com/office/drawing/2014/main" id="{8F4B6486-8CD6-6307-4718-2E4143CAFD9E}"/>
+              </a:ext>
+            </a:extLst>
+          </p:cNvPr>
+          <p:cNvSpPr txBox="1">
+            <a:spLocks/>
+          </p:cNvSpPr>
+          <p:nvPr/>
+        </p:nvSpPr>
+        <p:spPr>
+          <a:xfrm>
+            <a:off x="8804750" y="6337394"/>
+            <a:ext cx="2825475" cy="365125"/>
+          </a:xfrm>
+          <a:prstGeom prst="rect">
+            <a:avLst/>
+          </a:prstGeom>
+        </p:spPr>
+        <p:txBody>
+          <a:bodyPr vert="horz" lIns="91440" tIns="45720" rIns="91440" bIns="45720" rtlCol="0" anchor="ctr"/>
+          <a:lstStyle>
+            <a:defPPr>
+              <a:defRPr lang="en-US"/>
+            </a:defPPr>
+            <a:lvl1pPr marL="0" algn="r" defTabSz="914400" rtl="0" eaLnBrk="1" latinLnBrk="0" hangingPunct="1">
+              <a:defRPr sz="1200" kern="1200">
+                <a:solidFill>
+                  <a:schemeClr val="tx1">
+                    <a:tint val="75000"/>
+                  </a:schemeClr>
+                </a:solidFill>
+                <a:latin typeface="+mn-lt"/>
+                <a:ea typeface="+mn-ea"/>
+                <a:cs typeface="+mn-cs"/>
+              </a:defRPr>
+            </a:lvl1pPr>
+            <a:lvl2pPr marL="457200" algn="l" defTabSz="914400" rtl="0" eaLnBrk="1" latinLnBrk="0" hangingPunct="1">
+              <a:defRPr sz="1800" kern="1200">
+                <a:solidFill>
+                  <a:schemeClr val="tx1"/>
+                </a:solidFill>
+                <a:latin typeface="+mn-lt"/>
+                <a:ea typeface="+mn-ea"/>
+                <a:cs typeface="+mn-cs"/>
+              </a:defRPr>
+            </a:lvl2pPr>
+            <a:lvl3pPr marL="914400" algn="l" defTabSz="914400" rtl="0" eaLnBrk="1" latinLnBrk="0" hangingPunct="1">
+              <a:defRPr sz="1800" kern="1200">
+                <a:solidFill>
+                  <a:schemeClr val="tx1"/>
+                </a:solidFill>
+                <a:latin typeface="+mn-lt"/>
+                <a:ea typeface="+mn-ea"/>
+                <a:cs typeface="+mn-cs"/>
+              </a:defRPr>
+            </a:lvl3pPr>
+            <a:lvl4pPr marL="1371600" algn="l" defTabSz="914400" rtl="0" eaLnBrk="1" latinLnBrk="0" hangingPunct="1">
+              <a:defRPr sz="1800" kern="1200">
+                <a:solidFill>
+                  <a:schemeClr val="tx1"/>
+                </a:solidFill>
+                <a:latin typeface="+mn-lt"/>
+                <a:ea typeface="+mn-ea"/>
+                <a:cs typeface="+mn-cs"/>
+              </a:defRPr>
+            </a:lvl4pPr>
+            <a:lvl5pPr marL="1828800" algn="l" defTabSz="914400" rtl="0" eaLnBrk="1" latinLnBrk="0" hangingPunct="1">
+              <a:defRPr sz="1800" kern="1200">
+                <a:solidFill>
+                  <a:schemeClr val="tx1"/>
+                </a:solidFill>
+                <a:latin typeface="+mn-lt"/>
+                <a:ea typeface="+mn-ea"/>
+                <a:cs typeface="+mn-cs"/>
+              </a:defRPr>
+            </a:lvl5pPr>
+            <a:lvl6pPr marL="2286000" algn="l" defTabSz="914400" rtl="0" eaLnBrk="1" latinLnBrk="0" hangingPunct="1">
+              <a:defRPr sz="1800" kern="1200">
+                <a:solidFill>
+                  <a:schemeClr val="tx1"/>
+                </a:solidFill>
+                <a:latin typeface="+mn-lt"/>
+                <a:ea typeface="+mn-ea"/>
+                <a:cs typeface="+mn-cs"/>
+              </a:defRPr>
+            </a:lvl6pPr>
+            <a:lvl7pPr marL="2743200" algn="l" defTabSz="914400" rtl="0" eaLnBrk="1" latinLnBrk="0" hangingPunct="1">
+              <a:defRPr sz="1800" kern="1200">
+                <a:solidFill>
+                  <a:schemeClr val="tx1"/>
+                </a:solidFill>
+                <a:latin typeface="+mn-lt"/>
+                <a:ea typeface="+mn-ea"/>
+                <a:cs typeface="+mn-cs"/>
+              </a:defRPr>
+            </a:lvl7pPr>
+            <a:lvl8pPr marL="3200400" algn="l" defTabSz="914400" rtl="0" eaLnBrk="1" latinLnBrk="0" hangingPunct="1">
+              <a:defRPr sz="1800" kern="1200">
+                <a:solidFill>
+                  <a:schemeClr val="tx1"/>
+                </a:solidFill>
+                <a:latin typeface="+mn-lt"/>
+                <a:ea typeface="+mn-ea"/>
+                <a:cs typeface="+mn-cs"/>
+              </a:defRPr>
+            </a:lvl8pPr>
+            <a:lvl9pPr marL="3657600" algn="l" defTabSz="914400" rtl="0" eaLnBrk="1" latinLnBrk="0" hangingPunct="1">
+              <a:defRPr sz="1800" kern="1200">
+                <a:solidFill>
+                  <a:schemeClr val="tx1"/>
+                </a:solidFill>
+                <a:latin typeface="+mn-lt"/>
+                <a:ea typeface="+mn-ea"/>
+                <a:cs typeface="+mn-cs"/>
+              </a:defRPr>
+            </a:lvl9pPr>
+          </a:lstStyle>
+          <a:p>
+            <a:fld id="{54B21BD1-F593-4F4E-86E9-52991719DFB8}" type="slidenum">
+              <a:rPr lang="en-GB" sz="1400" noProof="0" smtClean="0">
+                <a:solidFill>
+                  <a:schemeClr val="bg1"/>
+                </a:solidFill>
+                <a:latin typeface="Cambria" panose="02040503050406030204" pitchFamily="18" charset="0"/>
+                <a:ea typeface="Cambria" panose="02040503050406030204" pitchFamily="18" charset="0"/>
+              </a:rPr>
+              <a:pPr/>
+              <a:t>7</a:t>
             </a:fld>
             <a:endParaRPr lang="en-GB" sz="1400" noProof="0" dirty="0">
               <a:solidFill>
@@ -7817,7 +10282,7 @@
 </p:sld>
 </file>
 
-<file path=ppt/slides/slide6.xml><?xml version="1.0" encoding="utf-8"?>
+<file path=ppt/slides/slide8.xml><?xml version="1.0" encoding="utf-8"?>
 <p:sld xmlns:a="http://schemas.openxmlformats.org/drawingml/2006/main" xmlns:r="http://schemas.openxmlformats.org/officeDocument/2006/relationships" xmlns:p="http://schemas.openxmlformats.org/presentationml/2006/main">
   <p:cSld>
     <p:spTree>
@@ -8149,7 +10614,7 @@
                 <a:ea typeface="Cambria" panose="02040503050406030204" pitchFamily="18" charset="0"/>
               </a:rPr>
               <a:pPr/>
-              <a:t>6</a:t>
+              <a:t>8</a:t>
             </a:fld>
             <a:endParaRPr lang="en-GB" sz="1400" noProof="0" dirty="0">
               <a:solidFill>
@@ -8443,7 +10908,7 @@
 </p:sld>
 </file>
 
-<file path=ppt/slides/slide7.xml><?xml version="1.0" encoding="utf-8"?>
+<file path=ppt/slides/slide9.xml><?xml version="1.0" encoding="utf-8"?>
 <p:sld xmlns:a="http://schemas.openxmlformats.org/drawingml/2006/main" xmlns:r="http://schemas.openxmlformats.org/officeDocument/2006/relationships" xmlns:p="http://schemas.openxmlformats.org/presentationml/2006/main">
   <p:cSld>
     <p:spTree>
@@ -8775,7 +11240,7 @@
                 <a:ea typeface="Cambria" panose="02040503050406030204" pitchFamily="18" charset="0"/>
               </a:rPr>
               <a:pPr/>
-              <a:t>7</a:t>
+              <a:t>9</a:t>
             </a:fld>
             <a:endParaRPr lang="en-GB" sz="1400" noProof="0" dirty="0">
               <a:solidFill>
@@ -9051,669 +11516,6 @@
     <p:extLst>
       <p:ext uri="{BB962C8B-B14F-4D97-AF65-F5344CB8AC3E}">
         <p14:creationId xmlns:p14="http://schemas.microsoft.com/office/powerpoint/2010/main" val="3898382547"/>
-      </p:ext>
-    </p:extLst>
-  </p:cSld>
-  <p:clrMapOvr>
-    <a:masterClrMapping/>
-  </p:clrMapOvr>
-</p:sld>
-</file>
-
-<file path=ppt/slides/slide8.xml><?xml version="1.0" encoding="utf-8"?>
-<p:sld xmlns:a="http://schemas.openxmlformats.org/drawingml/2006/main" xmlns:r="http://schemas.openxmlformats.org/officeDocument/2006/relationships" xmlns:p="http://schemas.openxmlformats.org/presentationml/2006/main">
-  <p:cSld>
-    <p:spTree>
-      <p:nvGrpSpPr>
-        <p:cNvPr id="1" name="">
-          <a:extLst>
-            <a:ext uri="{FF2B5EF4-FFF2-40B4-BE49-F238E27FC236}">
-              <a16:creationId xmlns:a16="http://schemas.microsoft.com/office/drawing/2014/main" id="{00529CBD-B49A-3084-90F3-0D7834C0EE96}"/>
-            </a:ext>
-          </a:extLst>
-        </p:cNvPr>
-        <p:cNvGrpSpPr/>
-        <p:nvPr/>
-      </p:nvGrpSpPr>
-      <p:grpSpPr>
-        <a:xfrm>
-          <a:off x="0" y="0"/>
-          <a:ext cx="0" cy="0"/>
-          <a:chOff x="0" y="0"/>
-          <a:chExt cx="0" cy="0"/>
-        </a:xfrm>
-      </p:grpSpPr>
-      <p:pic>
-        <p:nvPicPr>
-          <p:cNvPr id="17" name="Picture 16">
-            <a:extLst>
-              <a:ext uri="{FF2B5EF4-FFF2-40B4-BE49-F238E27FC236}">
-                <a16:creationId xmlns:a16="http://schemas.microsoft.com/office/drawing/2014/main" id="{FED5154D-8E9B-10D4-6458-6DA83132A5EB}"/>
-              </a:ext>
-            </a:extLst>
-          </p:cNvPr>
-          <p:cNvPicPr>
-            <a:picLocks noChangeAspect="1"/>
-          </p:cNvPicPr>
-          <p:nvPr/>
-        </p:nvPicPr>
-        <p:blipFill>
-          <a:blip r:embed="rId3"/>
-          <a:srcRect b="6189"/>
-          <a:stretch>
-            <a:fillRect/>
-          </a:stretch>
-        </p:blipFill>
-        <p:spPr>
-          <a:xfrm>
-            <a:off x="318096" y="2100727"/>
-            <a:ext cx="3738265" cy="3619430"/>
-          </a:xfrm>
-          <a:prstGeom prst="rect">
-            <a:avLst/>
-          </a:prstGeom>
-        </p:spPr>
-      </p:pic>
-      <p:sp>
-        <p:nvSpPr>
-          <p:cNvPr id="7" name="TextBox 6">
-            <a:extLst>
-              <a:ext uri="{FF2B5EF4-FFF2-40B4-BE49-F238E27FC236}">
-                <a16:creationId xmlns:a16="http://schemas.microsoft.com/office/drawing/2014/main" id="{D3A9C648-9C0B-7C69-C62D-C0C5D02E6B31}"/>
-              </a:ext>
-            </a:extLst>
-          </p:cNvPr>
-          <p:cNvSpPr txBox="1"/>
-          <p:nvPr/>
-        </p:nvSpPr>
-        <p:spPr>
-          <a:xfrm>
-            <a:off x="318096" y="0"/>
-            <a:ext cx="11555807" cy="584775"/>
-          </a:xfrm>
-          <a:prstGeom prst="rect">
-            <a:avLst/>
-          </a:prstGeom>
-          <a:noFill/>
-        </p:spPr>
-        <p:txBody>
-          <a:bodyPr wrap="square" rtlCol="0">
-            <a:spAutoFit/>
-          </a:bodyPr>
-          <a:lstStyle/>
-          <a:p>
-            <a:r>
-              <a:rPr lang="en-GB" sz="3200" b="1" noProof="0" dirty="0">
-                <a:solidFill>
-                  <a:schemeClr val="bg1"/>
-                </a:solidFill>
-                <a:latin typeface="Cambria" panose="02040503050406030204" pitchFamily="18" charset="0"/>
-                <a:ea typeface="Cambria" panose="02040503050406030204" pitchFamily="18" charset="0"/>
-                <a:cs typeface="Times New Roman" panose="02020603050405020304" pitchFamily="18" charset="0"/>
-              </a:rPr>
-              <a:t>Course Material</a:t>
-            </a:r>
-          </a:p>
-        </p:txBody>
-      </p:sp>
-      <p:sp>
-        <p:nvSpPr>
-          <p:cNvPr id="13" name="TextBox 12">
-            <a:extLst>
-              <a:ext uri="{FF2B5EF4-FFF2-40B4-BE49-F238E27FC236}">
-                <a16:creationId xmlns:a16="http://schemas.microsoft.com/office/drawing/2014/main" id="{A2E1476E-12F5-E3E6-D696-3BCB301EE6FA}"/>
-              </a:ext>
-            </a:extLst>
-          </p:cNvPr>
-          <p:cNvSpPr txBox="1"/>
-          <p:nvPr/>
-        </p:nvSpPr>
-        <p:spPr>
-          <a:xfrm>
-            <a:off x="222111" y="800107"/>
-            <a:ext cx="11747779" cy="1039452"/>
-          </a:xfrm>
-          <a:prstGeom prst="rect">
-            <a:avLst/>
-          </a:prstGeom>
-          <a:noFill/>
-        </p:spPr>
-        <p:txBody>
-          <a:bodyPr wrap="square" rtlCol="0">
-            <a:spAutoFit/>
-          </a:bodyPr>
-          <a:lstStyle/>
-          <a:p>
-            <a:pPr algn="ctr">
-              <a:lnSpc>
-                <a:spcPct val="150000"/>
-              </a:lnSpc>
-            </a:pPr>
-            <a:r>
-              <a:rPr lang="en-GB" sz="2000" b="1" dirty="0">
-                <a:latin typeface="Cambria" panose="02040503050406030204" pitchFamily="18" charset="0"/>
-                <a:ea typeface="Cambria" panose="02040503050406030204" pitchFamily="18" charset="0"/>
-                <a:hlinkClick r:id="rId4"/>
-              </a:rPr>
-              <a:t>https://github.com/andrebolerbarros/Intro_R</a:t>
-            </a:r>
-            <a:endParaRPr lang="en-GB" sz="2000" b="1" dirty="0">
-              <a:latin typeface="Cambria" panose="02040503050406030204" pitchFamily="18" charset="0"/>
-              <a:ea typeface="Cambria" panose="02040503050406030204" pitchFamily="18" charset="0"/>
-            </a:endParaRPr>
-          </a:p>
-          <a:p>
-            <a:pPr marL="285750" indent="-285750" algn="just">
-              <a:lnSpc>
-                <a:spcPct val="150000"/>
-              </a:lnSpc>
-              <a:buFont typeface="Arial" panose="020B0604020202020204" pitchFamily="34" charset="0"/>
-              <a:buChar char="•"/>
-            </a:pPr>
-            <a:endParaRPr lang="en-GB" sz="2400" b="1" dirty="0">
-              <a:latin typeface="Cambria" panose="02040503050406030204" pitchFamily="18" charset="0"/>
-              <a:ea typeface="Cambria" panose="02040503050406030204" pitchFamily="18" charset="0"/>
-            </a:endParaRPr>
-          </a:p>
-        </p:txBody>
-      </p:sp>
-      <p:pic>
-        <p:nvPicPr>
-          <p:cNvPr id="9" name="Picture 8" descr="A white circle with black background&#10;&#10;Description automatically generated">
-            <a:extLst>
-              <a:ext uri="{FF2B5EF4-FFF2-40B4-BE49-F238E27FC236}">
-                <a16:creationId xmlns:a16="http://schemas.microsoft.com/office/drawing/2014/main" id="{E905D286-EE0C-C040-92B8-B2B74CB328E1}"/>
-              </a:ext>
-            </a:extLst>
-          </p:cNvPr>
-          <p:cNvPicPr>
-            <a:picLocks noChangeAspect="1"/>
-          </p:cNvPicPr>
-          <p:nvPr/>
-        </p:nvPicPr>
-        <p:blipFill>
-          <a:blip r:embed="rId5"/>
-          <a:srcRect t="19605" r="16255" b="22685"/>
-          <a:stretch>
-            <a:fillRect/>
-          </a:stretch>
-        </p:blipFill>
-        <p:spPr>
-          <a:xfrm>
-            <a:off x="-269926" y="6222582"/>
-            <a:ext cx="939853" cy="628211"/>
-          </a:xfrm>
-          <a:prstGeom prst="rect">
-            <a:avLst/>
-          </a:prstGeom>
-        </p:spPr>
-      </p:pic>
-      <p:cxnSp>
-        <p:nvCxnSpPr>
-          <p:cNvPr id="10" name="Straight Connector 9">
-            <a:extLst>
-              <a:ext uri="{FF2B5EF4-FFF2-40B4-BE49-F238E27FC236}">
-                <a16:creationId xmlns:a16="http://schemas.microsoft.com/office/drawing/2014/main" id="{8F78C4AE-9417-F1DA-86EB-39253672D1B4}"/>
-              </a:ext>
-            </a:extLst>
-          </p:cNvPr>
-          <p:cNvCxnSpPr>
-            <a:cxnSpLocks/>
-          </p:cNvCxnSpPr>
-          <p:nvPr/>
-        </p:nvCxnSpPr>
-        <p:spPr>
-          <a:xfrm flipV="1">
-            <a:off x="669927" y="6523348"/>
-            <a:ext cx="10580947" cy="1"/>
-          </a:xfrm>
-          <a:prstGeom prst="line">
-            <a:avLst/>
-          </a:prstGeom>
-          <a:ln>
-            <a:solidFill>
-              <a:schemeClr val="bg1"/>
-            </a:solidFill>
-          </a:ln>
-        </p:spPr>
-        <p:style>
-          <a:lnRef idx="1">
-            <a:schemeClr val="dk1"/>
-          </a:lnRef>
-          <a:fillRef idx="0">
-            <a:schemeClr val="dk1"/>
-          </a:fillRef>
-          <a:effectRef idx="0">
-            <a:schemeClr val="dk1"/>
-          </a:effectRef>
-          <a:fontRef idx="minor">
-            <a:schemeClr val="tx1"/>
-          </a:fontRef>
-        </p:style>
-      </p:cxnSp>
-      <p:sp>
-        <p:nvSpPr>
-          <p:cNvPr id="11" name="Slide Number Placeholder 2">
-            <a:extLst>
-              <a:ext uri="{FF2B5EF4-FFF2-40B4-BE49-F238E27FC236}">
-                <a16:creationId xmlns:a16="http://schemas.microsoft.com/office/drawing/2014/main" id="{A5B35666-5ACA-145A-137C-488E3DF30EF3}"/>
-              </a:ext>
-            </a:extLst>
-          </p:cNvPr>
-          <p:cNvSpPr txBox="1">
-            <a:spLocks/>
-          </p:cNvSpPr>
-          <p:nvPr/>
-        </p:nvSpPr>
-        <p:spPr>
-          <a:xfrm>
-            <a:off x="8804750" y="6337394"/>
-            <a:ext cx="2825475" cy="365125"/>
-          </a:xfrm>
-          <a:prstGeom prst="rect">
-            <a:avLst/>
-          </a:prstGeom>
-        </p:spPr>
-        <p:txBody>
-          <a:bodyPr vert="horz" lIns="91440" tIns="45720" rIns="91440" bIns="45720" rtlCol="0" anchor="ctr"/>
-          <a:lstStyle>
-            <a:defPPr>
-              <a:defRPr lang="en-US"/>
-            </a:defPPr>
-            <a:lvl1pPr marL="0" algn="r" defTabSz="914400" rtl="0" eaLnBrk="1" latinLnBrk="0" hangingPunct="1">
-              <a:defRPr sz="1200" kern="1200">
-                <a:solidFill>
-                  <a:schemeClr val="tx1">
-                    <a:tint val="75000"/>
-                  </a:schemeClr>
-                </a:solidFill>
-                <a:latin typeface="+mn-lt"/>
-                <a:ea typeface="+mn-ea"/>
-                <a:cs typeface="+mn-cs"/>
-              </a:defRPr>
-            </a:lvl1pPr>
-            <a:lvl2pPr marL="457200" algn="l" defTabSz="914400" rtl="0" eaLnBrk="1" latinLnBrk="0" hangingPunct="1">
-              <a:defRPr sz="1800" kern="1200">
-                <a:solidFill>
-                  <a:schemeClr val="tx1"/>
-                </a:solidFill>
-                <a:latin typeface="+mn-lt"/>
-                <a:ea typeface="+mn-ea"/>
-                <a:cs typeface="+mn-cs"/>
-              </a:defRPr>
-            </a:lvl2pPr>
-            <a:lvl3pPr marL="914400" algn="l" defTabSz="914400" rtl="0" eaLnBrk="1" latinLnBrk="0" hangingPunct="1">
-              <a:defRPr sz="1800" kern="1200">
-                <a:solidFill>
-                  <a:schemeClr val="tx1"/>
-                </a:solidFill>
-                <a:latin typeface="+mn-lt"/>
-                <a:ea typeface="+mn-ea"/>
-                <a:cs typeface="+mn-cs"/>
-              </a:defRPr>
-            </a:lvl3pPr>
-            <a:lvl4pPr marL="1371600" algn="l" defTabSz="914400" rtl="0" eaLnBrk="1" latinLnBrk="0" hangingPunct="1">
-              <a:defRPr sz="1800" kern="1200">
-                <a:solidFill>
-                  <a:schemeClr val="tx1"/>
-                </a:solidFill>
-                <a:latin typeface="+mn-lt"/>
-                <a:ea typeface="+mn-ea"/>
-                <a:cs typeface="+mn-cs"/>
-              </a:defRPr>
-            </a:lvl4pPr>
-            <a:lvl5pPr marL="1828800" algn="l" defTabSz="914400" rtl="0" eaLnBrk="1" latinLnBrk="0" hangingPunct="1">
-              <a:defRPr sz="1800" kern="1200">
-                <a:solidFill>
-                  <a:schemeClr val="tx1"/>
-                </a:solidFill>
-                <a:latin typeface="+mn-lt"/>
-                <a:ea typeface="+mn-ea"/>
-                <a:cs typeface="+mn-cs"/>
-              </a:defRPr>
-            </a:lvl5pPr>
-            <a:lvl6pPr marL="2286000" algn="l" defTabSz="914400" rtl="0" eaLnBrk="1" latinLnBrk="0" hangingPunct="1">
-              <a:defRPr sz="1800" kern="1200">
-                <a:solidFill>
-                  <a:schemeClr val="tx1"/>
-                </a:solidFill>
-                <a:latin typeface="+mn-lt"/>
-                <a:ea typeface="+mn-ea"/>
-                <a:cs typeface="+mn-cs"/>
-              </a:defRPr>
-            </a:lvl6pPr>
-            <a:lvl7pPr marL="2743200" algn="l" defTabSz="914400" rtl="0" eaLnBrk="1" latinLnBrk="0" hangingPunct="1">
-              <a:defRPr sz="1800" kern="1200">
-                <a:solidFill>
-                  <a:schemeClr val="tx1"/>
-                </a:solidFill>
-                <a:latin typeface="+mn-lt"/>
-                <a:ea typeface="+mn-ea"/>
-                <a:cs typeface="+mn-cs"/>
-              </a:defRPr>
-            </a:lvl7pPr>
-            <a:lvl8pPr marL="3200400" algn="l" defTabSz="914400" rtl="0" eaLnBrk="1" latinLnBrk="0" hangingPunct="1">
-              <a:defRPr sz="1800" kern="1200">
-                <a:solidFill>
-                  <a:schemeClr val="tx1"/>
-                </a:solidFill>
-                <a:latin typeface="+mn-lt"/>
-                <a:ea typeface="+mn-ea"/>
-                <a:cs typeface="+mn-cs"/>
-              </a:defRPr>
-            </a:lvl8pPr>
-            <a:lvl9pPr marL="3657600" algn="l" defTabSz="914400" rtl="0" eaLnBrk="1" latinLnBrk="0" hangingPunct="1">
-              <a:defRPr sz="1800" kern="1200">
-                <a:solidFill>
-                  <a:schemeClr val="tx1"/>
-                </a:solidFill>
-                <a:latin typeface="+mn-lt"/>
-                <a:ea typeface="+mn-ea"/>
-                <a:cs typeface="+mn-cs"/>
-              </a:defRPr>
-            </a:lvl9pPr>
-          </a:lstStyle>
-          <a:p>
-            <a:fld id="{54B21BD1-F593-4F4E-86E9-52991719DFB8}" type="slidenum">
-              <a:rPr lang="en-GB" sz="1400" noProof="0" smtClean="0">
-                <a:solidFill>
-                  <a:schemeClr val="bg1"/>
-                </a:solidFill>
-                <a:latin typeface="Cambria" panose="02040503050406030204" pitchFamily="18" charset="0"/>
-                <a:ea typeface="Cambria" panose="02040503050406030204" pitchFamily="18" charset="0"/>
-              </a:rPr>
-              <a:pPr/>
-              <a:t>8</a:t>
-            </a:fld>
-            <a:endParaRPr lang="en-GB" sz="1400" noProof="0" dirty="0">
-              <a:solidFill>
-                <a:schemeClr val="bg1"/>
-              </a:solidFill>
-              <a:latin typeface="Cambria" panose="02040503050406030204" pitchFamily="18" charset="0"/>
-              <a:ea typeface="Cambria" panose="02040503050406030204" pitchFamily="18" charset="0"/>
-            </a:endParaRPr>
-          </a:p>
-        </p:txBody>
-      </p:sp>
-      <p:sp>
-        <p:nvSpPr>
-          <p:cNvPr id="12" name="TextBox 11">
-            <a:extLst>
-              <a:ext uri="{FF2B5EF4-FFF2-40B4-BE49-F238E27FC236}">
-                <a16:creationId xmlns:a16="http://schemas.microsoft.com/office/drawing/2014/main" id="{EA75DBE1-F078-0DA9-4E9E-0394D868FED0}"/>
-              </a:ext>
-            </a:extLst>
-          </p:cNvPr>
-          <p:cNvSpPr txBox="1"/>
-          <p:nvPr/>
-        </p:nvSpPr>
-        <p:spPr>
-          <a:xfrm>
-            <a:off x="3870960" y="6451133"/>
-            <a:ext cx="4450080" cy="335092"/>
-          </a:xfrm>
-          <a:prstGeom prst="rect">
-            <a:avLst/>
-          </a:prstGeom>
-          <a:noFill/>
-        </p:spPr>
-        <p:txBody>
-          <a:bodyPr wrap="square" rtlCol="0">
-            <a:spAutoFit/>
-          </a:bodyPr>
-          <a:lstStyle/>
-          <a:p>
-            <a:pPr defTabSz="825500">
-              <a:lnSpc>
-                <a:spcPct val="150000"/>
-              </a:lnSpc>
-              <a:tabLst>
-                <a:tab pos="3768725" algn="l"/>
-                <a:tab pos="4572000" algn="l"/>
-              </a:tabLst>
-            </a:pPr>
-            <a:r>
-              <a:rPr lang="en-GB" sz="1200" noProof="0" dirty="0">
-                <a:solidFill>
-                  <a:schemeClr val="bg1"/>
-                </a:solidFill>
-                <a:latin typeface="Cambria" panose="02040503050406030204" pitchFamily="18" charset="0"/>
-                <a:ea typeface="Cambria" panose="02040503050406030204" pitchFamily="18" charset="0"/>
-                <a:cs typeface="Times New Roman" panose="02020603050405020304" pitchFamily="18" charset="0"/>
-              </a:rPr>
-              <a:t>André Barros | Advanced Data Analysis | 12th January 2026</a:t>
-            </a:r>
-            <a:endParaRPr lang="en-GB" sz="1200" i="1" noProof="0" dirty="0">
-              <a:solidFill>
-                <a:schemeClr val="bg1"/>
-              </a:solidFill>
-              <a:latin typeface="Cambria" panose="02040503050406030204" pitchFamily="18" charset="0"/>
-              <a:ea typeface="Cambria" panose="02040503050406030204" pitchFamily="18" charset="0"/>
-              <a:cs typeface="Times New Roman" panose="02020603050405020304" pitchFamily="18" charset="0"/>
-            </a:endParaRPr>
-          </a:p>
-        </p:txBody>
-      </p:sp>
-      <p:pic>
-        <p:nvPicPr>
-          <p:cNvPr id="14" name="Picture 13">
-            <a:extLst>
-              <a:ext uri="{FF2B5EF4-FFF2-40B4-BE49-F238E27FC236}">
-                <a16:creationId xmlns:a16="http://schemas.microsoft.com/office/drawing/2014/main" id="{9350AA1C-B10F-C701-8C08-C1EBF0415725}"/>
-              </a:ext>
-            </a:extLst>
-          </p:cNvPr>
-          <p:cNvPicPr>
-            <a:picLocks noChangeAspect="1"/>
-          </p:cNvPicPr>
-          <p:nvPr/>
-        </p:nvPicPr>
-        <p:blipFill>
-          <a:blip r:embed="rId6"/>
-          <a:srcRect l="22765" t="18648" r="25605" b="15789"/>
-          <a:stretch>
-            <a:fillRect/>
-          </a:stretch>
-        </p:blipFill>
-        <p:spPr>
-          <a:xfrm>
-            <a:off x="11581065" y="6281675"/>
-            <a:ext cx="425229" cy="540000"/>
-          </a:xfrm>
-          <a:prstGeom prst="rect">
-            <a:avLst/>
-          </a:prstGeom>
-        </p:spPr>
-      </p:pic>
-      <p:sp>
-        <p:nvSpPr>
-          <p:cNvPr id="4" name="TextBox 3">
-            <a:extLst>
-              <a:ext uri="{FF2B5EF4-FFF2-40B4-BE49-F238E27FC236}">
-                <a16:creationId xmlns:a16="http://schemas.microsoft.com/office/drawing/2014/main" id="{B1EEA1FE-0E17-6AD1-2AFA-014911C1B9A6}"/>
-              </a:ext>
-            </a:extLst>
-          </p:cNvPr>
-          <p:cNvSpPr txBox="1"/>
-          <p:nvPr/>
-        </p:nvSpPr>
-        <p:spPr>
-          <a:xfrm>
-            <a:off x="222110" y="1529798"/>
-            <a:ext cx="11747779" cy="456472"/>
-          </a:xfrm>
-          <a:prstGeom prst="rect">
-            <a:avLst/>
-          </a:prstGeom>
-          <a:noFill/>
-        </p:spPr>
-        <p:txBody>
-          <a:bodyPr wrap="square" rtlCol="0">
-            <a:spAutoFit/>
-          </a:bodyPr>
-          <a:lstStyle/>
-          <a:p>
-            <a:pPr algn="just">
-              <a:lnSpc>
-                <a:spcPct val="150000"/>
-              </a:lnSpc>
-              <a:tabLst>
-                <a:tab pos="447675" algn="l"/>
-              </a:tabLst>
-            </a:pPr>
-            <a:r>
-              <a:rPr lang="en-GB" dirty="0">
-                <a:latin typeface="Cambria" panose="02040503050406030204" pitchFamily="18" charset="0"/>
-                <a:ea typeface="Cambria" panose="02040503050406030204" pitchFamily="18" charset="0"/>
-              </a:rPr>
-              <a:t>3.	Change kernel (language)</a:t>
-            </a:r>
-            <a:endParaRPr lang="en-GB" sz="2400" b="1" dirty="0">
-              <a:latin typeface="Cambria" panose="02040503050406030204" pitchFamily="18" charset="0"/>
-              <a:ea typeface="Cambria" panose="02040503050406030204" pitchFamily="18" charset="0"/>
-            </a:endParaRPr>
-          </a:p>
-        </p:txBody>
-      </p:sp>
-      <p:sp>
-        <p:nvSpPr>
-          <p:cNvPr id="15" name="Rectangle: Rounded Corners 14">
-            <a:extLst>
-              <a:ext uri="{FF2B5EF4-FFF2-40B4-BE49-F238E27FC236}">
-                <a16:creationId xmlns:a16="http://schemas.microsoft.com/office/drawing/2014/main" id="{6478EFC7-F045-7079-8000-5B1307E810E4}"/>
-              </a:ext>
-            </a:extLst>
-          </p:cNvPr>
-          <p:cNvSpPr/>
-          <p:nvPr/>
-        </p:nvSpPr>
-        <p:spPr>
-          <a:xfrm>
-            <a:off x="1879960" y="4441372"/>
-            <a:ext cx="1153235" cy="206256"/>
-          </a:xfrm>
-          <a:prstGeom prst="roundRect">
-            <a:avLst/>
-          </a:prstGeom>
-          <a:noFill/>
-          <a:ln>
-            <a:solidFill>
-              <a:srgbClr val="C00000"/>
-            </a:solidFill>
-          </a:ln>
-        </p:spPr>
-        <p:style>
-          <a:lnRef idx="2">
-            <a:schemeClr val="accent1">
-              <a:shade val="15000"/>
-            </a:schemeClr>
-          </a:lnRef>
-          <a:fillRef idx="1">
-            <a:schemeClr val="accent1"/>
-          </a:fillRef>
-          <a:effectRef idx="0">
-            <a:schemeClr val="accent1"/>
-          </a:effectRef>
-          <a:fontRef idx="minor">
-            <a:schemeClr val="lt1"/>
-          </a:fontRef>
-        </p:style>
-        <p:txBody>
-          <a:bodyPr rtlCol="0" anchor="ctr"/>
-          <a:lstStyle/>
-          <a:p>
-            <a:pPr algn="ctr"/>
-            <a:endParaRPr lang="pt-PT"/>
-          </a:p>
-        </p:txBody>
-      </p:sp>
-      <p:pic>
-        <p:nvPicPr>
-          <p:cNvPr id="3" name="Picture 2">
-            <a:extLst>
-              <a:ext uri="{FF2B5EF4-FFF2-40B4-BE49-F238E27FC236}">
-                <a16:creationId xmlns:a16="http://schemas.microsoft.com/office/drawing/2014/main" id="{EAC31A07-C2E3-BA9B-D4A0-5DFF260C4AC0}"/>
-              </a:ext>
-            </a:extLst>
-          </p:cNvPr>
-          <p:cNvPicPr>
-            <a:picLocks noChangeAspect="1"/>
-          </p:cNvPicPr>
-          <p:nvPr/>
-        </p:nvPicPr>
-        <p:blipFill>
-          <a:blip r:embed="rId7"/>
-          <a:srcRect b="13023"/>
-          <a:stretch>
-            <a:fillRect/>
-          </a:stretch>
-        </p:blipFill>
-        <p:spPr>
-          <a:xfrm>
-            <a:off x="4249744" y="2100727"/>
-            <a:ext cx="3092693" cy="2450647"/>
-          </a:xfrm>
-          <a:prstGeom prst="rect">
-            <a:avLst/>
-          </a:prstGeom>
-        </p:spPr>
-      </p:pic>
-      <p:sp>
-        <p:nvSpPr>
-          <p:cNvPr id="5" name="Rectangle: Rounded Corners 4">
-            <a:extLst>
-              <a:ext uri="{FF2B5EF4-FFF2-40B4-BE49-F238E27FC236}">
-                <a16:creationId xmlns:a16="http://schemas.microsoft.com/office/drawing/2014/main" id="{3AF94B33-A8EB-1EDE-6D11-70FD40963897}"/>
-              </a:ext>
-            </a:extLst>
-          </p:cNvPr>
-          <p:cNvSpPr/>
-          <p:nvPr/>
-        </p:nvSpPr>
-        <p:spPr>
-          <a:xfrm>
-            <a:off x="4321798" y="2554884"/>
-            <a:ext cx="1240229" cy="377153"/>
-          </a:xfrm>
-          <a:prstGeom prst="roundRect">
-            <a:avLst/>
-          </a:prstGeom>
-          <a:noFill/>
-          <a:ln>
-            <a:solidFill>
-              <a:srgbClr val="C00000"/>
-            </a:solidFill>
-          </a:ln>
-        </p:spPr>
-        <p:style>
-          <a:lnRef idx="2">
-            <a:schemeClr val="accent1">
-              <a:shade val="15000"/>
-            </a:schemeClr>
-          </a:lnRef>
-          <a:fillRef idx="1">
-            <a:schemeClr val="accent1"/>
-          </a:fillRef>
-          <a:effectRef idx="0">
-            <a:schemeClr val="accent1"/>
-          </a:effectRef>
-          <a:fontRef idx="minor">
-            <a:schemeClr val="lt1"/>
-          </a:fontRef>
-        </p:style>
-        <p:txBody>
-          <a:bodyPr rtlCol="0" anchor="ctr"/>
-          <a:lstStyle/>
-          <a:p>
-            <a:pPr algn="ctr"/>
-            <a:endParaRPr lang="pt-PT"/>
-          </a:p>
-        </p:txBody>
-      </p:sp>
-    </p:spTree>
-    <p:extLst>
-      <p:ext uri="{BB962C8B-B14F-4D97-AF65-F5344CB8AC3E}">
-        <p14:creationId xmlns:p14="http://schemas.microsoft.com/office/powerpoint/2010/main" val="3811760795"/>
       </p:ext>
     </p:extLst>
   </p:cSld>

</xml_diff>